<commit_message>
Presentation: architecture, industrial blades, synthetic-to-real, 3D demo
Co-Authored-By: Claude Opus 5.5 <noreply@anthropic.com>
</commit_message>
<xml_diff>
--- a/media/BladeDelta_presentation.pptx
+++ b/media/BladeDelta_presentation.pptx
@@ -27,6 +27,11 @@
     <p:sldId id="279" r:id="rId30"/>
     <p:sldId id="280" r:id="rId31"/>
     <p:sldId id="281" r:id="rId32"/>
+    <p:sldId id="282" r:id="rId33"/>
+    <p:sldId id="283" r:id="rId34"/>
+    <p:sldId id="284" r:id="rId35"/>
+    <p:sldId id="285" r:id="rId36"/>
+    <p:sldId id="286" r:id="rId37"/>
     <p:sldId id="263" r:id="rId9"/>
   </p:sldIdLst>
   <p:sldSz cx="12192000" cy="6858000"/>
@@ -1984,7 +1989,7 @@
           <a:lstStyle/>
           <a:p>
             <a:r>
-              <a:t>A real test case. Without a dent, the best explanation still mismatches the photo by 89. With the dent, 20. The improvement, 69, is the evidence. It is compared with a threshold set on healthy and stained blades so that only about 5 percent of them exceed it.</a:t>
+              <a:t>Starting from a candidate spot, the method fits a smooth dent: where it is, how deep, how big and its shape, by rendering the blade with the dent and adjusting until it matches the photo. Right: the true dent and the measured dent, coloured by depth.</a:t>
             </a:r>
           </a:p>
         </p:txBody>
@@ -2054,7 +2059,7 @@
           <a:lstStyle/>
           <a:p>
             <a:r>
-              <a:t>Because no public data has real blade dents with measured depth, we built a benchmark with exactly known answers. Six kinds of cases. Each picture: the photo with the true dent in orange rings and the reported dent in blue, the healthy blade, and the difference.</a:t>
+              <a:t>A real test case. Without a dent, the best explanation still mismatches the photo by 89. With the dent, 20. The improvement, 69, is the evidence. It is compared with a threshold set on healthy and stained blades so that only about 5 percent of them exceed it.</a:t>
             </a:r>
           </a:p>
         </p:txBody>
@@ -2124,7 +2129,7 @@
           <a:lstStyle/>
           <a:p>
             <a:r>
-              <a:t>Sealed test, 30 unseen blades. Ours separates dents from healthy blades best and finds more than twice as many dents, all in the right place. MLP and free-form fields reimplement the idea of the recent CADSplat work. Compared fairly at the same false-alarm rate, 51 percent versus at most 19.</a:t>
+              <a:t>Because no public data has real blade dents with measured depth, we built a benchmark with exactly known answers. Six kinds of cases. Each picture: the photo with the true dent in orange rings and the reported dent in blue, the healthy blade, and the difference.</a:t>
             </a:r>
           </a:p>
         </p:txBody>
@@ -2194,7 +2199,7 @@
           <a:lstStyle/>
           <a:p>
             <a:r>
-              <a:t>Same fits, with and without the evidence test. Without it, a third of healthy blades get a false dent and half of the hidden dents are wrongly "found". With it, false alarms drop to 10 percent and wrong claims on hidden dents to 15, at the cost of finding fewer dents.</a:t>
+              <a:t>Beyond the public Rotor37 blades, we imported your six industrial blade CAD models. Blue is the airfoil the method inspects; grey is the platform and root. We generated 456 cases with real-world dent sizes. Nothing was retrained on them: this tests whether the method transfers to new designs.</a:t>
             </a:r>
           </a:p>
         </p:txBody>
@@ -2264,7 +2269,7 @@
           <a:lstStyle/>
           <a:p>
             <a:r>
-              <a:t>Almost every visible dent deeper than 0.2 millimetres is found, 12 of 13. Below 0.1 millimetre the photo barely changes, and the method declines rather than guesses.</a:t>
+              <a:t>Sealed test, 30 unseen blades. Ours separates dents from healthy blades best and finds more than twice as many dents, all in the right place. MLP and free-form fields reimplement the idea of the recent CADSplat work. Compared fairly at the same false-alarm rate, 51 percent versus at most 19.</a:t>
             </a:r>
           </a:p>
         </p:txBody>
@@ -2334,7 +2339,7 @@
           <a:lstStyle/>
           <a:p>
             <a:r>
-              <a:t>On six new industrial designs the frozen method raised false alarms on most healthy blades: 67 percent over all six. Two causes: the camera check nudged correct cameras, and the brightness correction did not move with the blade. Fixed on two blades, tested on the other four: false alarms from 51 to 4 percent.</a:t>
+              <a:t>Same fits, with and without the evidence test. Without it, a third of healthy blades get a false dent and half of the hidden dents are wrongly "found". With it, false alarms drop to 10 percent and wrong claims on hidden dents to 15, at the cost of finding fewer dents.</a:t>
             </a:r>
           </a:p>
         </p:txBody>
@@ -2404,7 +2409,7 @@
           <a:lstStyle/>
           <a:p>
             <a:r>
-              <a:t>New this week. Before searching, we compute the smallest dent each point could reveal. Yellow: tiny dents visible. Dark: only deep dents. Grey: the root, which the method ignores. The per-dent prediction was checked on 300 test dents. The map values in millimetres are still optimistic and need checking against real misses.</a:t>
+              <a:t>Almost every visible dent deeper than 0.2 millimetres is found, 12 of 13. Below 0.1 millimetre the photo barely changes, and the method declines rather than guesses.</a:t>
             </a:r>
           </a:p>
         </p:txBody>
@@ -2474,7 +2479,7 @@
           <a:lstStyle/>
           <a:p>
             <a:r>
-              <a:t>The honest gap: everything so far is on rendered images. The next step is a real blade: print one of the industrial designs at twice its size, put real dents in it, photograph it, and measure the dents with a scanner.</a:t>
+              <a:t>On six new industrial designs the frozen method raised false alarms on most healthy blades: 67 percent over all six. Two causes: the camera check nudged correct cameras, and the brightness correction did not move with the blade. Fixed on two blades, tested on the other four: false alarms from 51 to 4 percent.</a:t>
             </a:r>
           </a:p>
         </p:txBody>
@@ -2544,7 +2549,7 @@
           <a:lstStyle/>
           <a:p>
             <a:r>
-              <a:t>In short: a method that measures dents in 3D from a few photos, says when it cannot tell, keeps false alarms low, predicts what it can and cannot see, and now works on new blade designs. Next: real blades.</a:t>
+              <a:t>Two held-out industrial blades. Top: a healthy blade; the old version reported a dent, the fixed one reports nothing. Bottom: a real dent; the old version put it 37 millimetres away, the fixed one finds it. Honest limitation: on these new designs the measured depth is still too small, about 60 percent of the truth on average, against 89 percent on the original blades.</a:t>
             </a:r>
           </a:p>
         </p:txBody>
@@ -2614,7 +2619,7 @@
           <a:lstStyle/>
           <a:p>
             <a:r>
-              <a:t>The interactive demo online: choose one of five test blades, see the method decision, the measured depth and the evidence against the threshold. These are real outputs of the method.</a:t>
+              <a:t>New this week. Before searching, we compute the smallest dent each point could reveal. Yellow: tiny dents visible. Dark: only deep dents. Grey: the root, which the method ignores. The per-dent prediction was checked on 300 test dents. The map values in millimetres are still optimistic and need checking against real misses.</a:t>
             </a:r>
           </a:p>
         </p:txBody>
@@ -2754,6 +2759,356 @@
           <a:lstStyle/>
           <a:p>
             <a:r>
+              <a:t>How we bridge synthetic and real. Every photo so far is rendered, which gives exact answers. Several design choices are there to survive real data: we always compare with a healthy reference so absolute appearance errors cancel; since v1.1 that correction moves with the camera; the threshold is calibrated on data, not assumed; and we tested on new industrial designs. One real dataset of scanned furniture does not work yet, mainly because its photos are misaligned. Next: a printed, dented and scanned copy of one of your blades.</a:t>
+            </a:r>
+          </a:p>
+        </p:txBody>
+      </p:sp>
+      <p:sp>
+        <p:nvSpPr>
+          <p:cNvPr id="4" name="Slide Number Placeholder 3"/>
+          <p:cNvSpPr>
+            <a:spLocks noGrp="1"/>
+          </p:cNvSpPr>
+          <p:nvPr>
+            <p:ph type="sldNum" idx="5" sz="quarter"/>
+          </p:nvPr>
+        </p:nvSpPr>
+        <p:spPr/>
+      </p:sp>
+    </p:spTree>
+  </p:cSld>
+  <p:clrMapOvr>
+    <a:masterClrMapping/>
+  </p:clrMapOvr>
+</p:notes>
+</file>
+
+<file path=ppt/notesSlides/notesSlide21.xml><?xml version="1.0" encoding="utf-8"?>
+<p:notes xmlns:a="http://schemas.openxmlformats.org/drawingml/2006/main" xmlns:p="http://schemas.openxmlformats.org/presentationml/2006/main" xmlns:r="http://schemas.openxmlformats.org/officeDocument/2006/relationships">
+  <p:cSld>
+    <p:spTree>
+      <p:nvGrpSpPr>
+        <p:cNvPr id="1" name=""/>
+        <p:cNvGrpSpPr/>
+        <p:nvPr/>
+      </p:nvGrpSpPr>
+      <p:grpSpPr>
+        <a:xfrm>
+          <a:off x="0" y="0"/>
+          <a:ext cx="0" cy="0"/>
+          <a:chOff x="0" y="0"/>
+          <a:chExt cx="0" cy="0"/>
+        </a:xfrm>
+      </p:grpSpPr>
+      <p:sp>
+        <p:nvSpPr>
+          <p:cNvPr id="2" name="Slide Image Placeholder 1"/>
+          <p:cNvSpPr>
+            <a:spLocks noGrp="1"/>
+          </p:cNvSpPr>
+          <p:nvPr>
+            <p:ph type="sldImg" idx="2"/>
+          </p:nvPr>
+        </p:nvSpPr>
+        <p:spPr/>
+      </p:sp>
+      <p:sp>
+        <p:nvSpPr>
+          <p:cNvPr id="3" name="Notes Placeholder 2"/>
+          <p:cNvSpPr>
+            <a:spLocks noGrp="1"/>
+          </p:cNvSpPr>
+          <p:nvPr>
+            <p:ph type="body" idx="3" sz="quarter"/>
+          </p:nvPr>
+        </p:nvSpPr>
+        <p:spPr/>
+        <p:txBody>
+          <a:bodyPr/>
+          <a:lstStyle/>
+          <a:p>
+            <a:r>
+              <a:t>The honest gap: everything so far is on rendered images. The next step is a real blade: print one of the industrial designs at twice its size, put real dents in it, photograph it, and measure the dents with a scanner.</a:t>
+            </a:r>
+          </a:p>
+        </p:txBody>
+      </p:sp>
+      <p:sp>
+        <p:nvSpPr>
+          <p:cNvPr id="4" name="Slide Number Placeholder 3"/>
+          <p:cNvSpPr>
+            <a:spLocks noGrp="1"/>
+          </p:cNvSpPr>
+          <p:nvPr>
+            <p:ph type="sldNum" idx="5" sz="quarter"/>
+          </p:nvPr>
+        </p:nvSpPr>
+        <p:spPr/>
+      </p:sp>
+    </p:spTree>
+  </p:cSld>
+  <p:clrMapOvr>
+    <a:masterClrMapping/>
+  </p:clrMapOvr>
+</p:notes>
+</file>
+
+<file path=ppt/notesSlides/notesSlide22.xml><?xml version="1.0" encoding="utf-8"?>
+<p:notes xmlns:a="http://schemas.openxmlformats.org/drawingml/2006/main" xmlns:p="http://schemas.openxmlformats.org/presentationml/2006/main" xmlns:r="http://schemas.openxmlformats.org/officeDocument/2006/relationships">
+  <p:cSld>
+    <p:spTree>
+      <p:nvGrpSpPr>
+        <p:cNvPr id="1" name=""/>
+        <p:cNvGrpSpPr/>
+        <p:nvPr/>
+      </p:nvGrpSpPr>
+      <p:grpSpPr>
+        <a:xfrm>
+          <a:off x="0" y="0"/>
+          <a:ext cx="0" cy="0"/>
+          <a:chOff x="0" y="0"/>
+          <a:chExt cx="0" cy="0"/>
+        </a:xfrm>
+      </p:grpSpPr>
+      <p:sp>
+        <p:nvSpPr>
+          <p:cNvPr id="2" name="Slide Image Placeholder 1"/>
+          <p:cNvSpPr>
+            <a:spLocks noGrp="1"/>
+          </p:cNvSpPr>
+          <p:nvPr>
+            <p:ph type="sldImg" idx="2"/>
+          </p:nvPr>
+        </p:nvSpPr>
+        <p:spPr/>
+      </p:sp>
+      <p:sp>
+        <p:nvSpPr>
+          <p:cNvPr id="3" name="Notes Placeholder 2"/>
+          <p:cNvSpPr>
+            <a:spLocks noGrp="1"/>
+          </p:cNvSpPr>
+          <p:nvPr>
+            <p:ph type="body" idx="3" sz="quarter"/>
+          </p:nvPr>
+        </p:nvSpPr>
+        <p:spPr/>
+        <p:txBody>
+          <a:bodyPr/>
+          <a:lstStyle/>
+          <a:p>
+            <a:r>
+              <a:t>In short: a method that measures dents in 3D from a few photos, says when it cannot tell, keeps false alarms low, predicts what it can and cannot see, and now works on new blade designs. Next: real blades.</a:t>
+            </a:r>
+          </a:p>
+        </p:txBody>
+      </p:sp>
+      <p:sp>
+        <p:nvSpPr>
+          <p:cNvPr id="4" name="Slide Number Placeholder 3"/>
+          <p:cNvSpPr>
+            <a:spLocks noGrp="1"/>
+          </p:cNvSpPr>
+          <p:nvPr>
+            <p:ph type="sldNum" idx="5" sz="quarter"/>
+          </p:nvPr>
+        </p:nvSpPr>
+        <p:spPr/>
+      </p:sp>
+    </p:spTree>
+  </p:cSld>
+  <p:clrMapOvr>
+    <a:masterClrMapping/>
+  </p:clrMapOvr>
+</p:notes>
+</file>
+
+<file path=ppt/notesSlides/notesSlide23.xml><?xml version="1.0" encoding="utf-8"?>
+<p:notes xmlns:a="http://schemas.openxmlformats.org/drawingml/2006/main" xmlns:p="http://schemas.openxmlformats.org/presentationml/2006/main" xmlns:r="http://schemas.openxmlformats.org/officeDocument/2006/relationships">
+  <p:cSld>
+    <p:spTree>
+      <p:nvGrpSpPr>
+        <p:cNvPr id="1" name=""/>
+        <p:cNvGrpSpPr/>
+        <p:nvPr/>
+      </p:nvGrpSpPr>
+      <p:grpSpPr>
+        <a:xfrm>
+          <a:off x="0" y="0"/>
+          <a:ext cx="0" cy="0"/>
+          <a:chOff x="0" y="0"/>
+          <a:chExt cx="0" cy="0"/>
+        </a:xfrm>
+      </p:grpSpPr>
+      <p:sp>
+        <p:nvSpPr>
+          <p:cNvPr id="2" name="Slide Image Placeholder 1"/>
+          <p:cNvSpPr>
+            <a:spLocks noGrp="1"/>
+          </p:cNvSpPr>
+          <p:nvPr>
+            <p:ph type="sldImg" idx="2"/>
+          </p:nvPr>
+        </p:nvSpPr>
+        <p:spPr/>
+      </p:sp>
+      <p:sp>
+        <p:nvSpPr>
+          <p:cNvPr id="3" name="Notes Placeholder 2"/>
+          <p:cNvSpPr>
+            <a:spLocks noGrp="1"/>
+          </p:cNvSpPr>
+          <p:nvPr>
+            <p:ph type="body" idx="3" sz="quarter"/>
+          </p:nvPr>
+        </p:nvSpPr>
+        <p:spPr/>
+        <p:txBody>
+          <a:bodyPr/>
+          <a:lstStyle/>
+          <a:p>
+            <a:r>
+              <a:t>The live 3D demo. Here an industrial blade: left the actual dent, right what the model predicts, 0.29 versus 0.30 millimetres, same place. Dents are exaggerated twenty times so they are visible. You can rotate, zoom, and switch between healthy, actual, the new model and the old one.</a:t>
+            </a:r>
+          </a:p>
+        </p:txBody>
+      </p:sp>
+      <p:sp>
+        <p:nvSpPr>
+          <p:cNvPr id="4" name="Slide Number Placeholder 3"/>
+          <p:cNvSpPr>
+            <a:spLocks noGrp="1"/>
+          </p:cNvSpPr>
+          <p:nvPr>
+            <p:ph type="sldNum" idx="5" sz="quarter"/>
+          </p:nvPr>
+        </p:nvSpPr>
+        <p:spPr/>
+      </p:sp>
+    </p:spTree>
+  </p:cSld>
+  <p:clrMapOvr>
+    <a:masterClrMapping/>
+  </p:clrMapOvr>
+</p:notes>
+</file>
+
+<file path=ppt/notesSlides/notesSlide24.xml><?xml version="1.0" encoding="utf-8"?>
+<p:notes xmlns:a="http://schemas.openxmlformats.org/drawingml/2006/main" xmlns:p="http://schemas.openxmlformats.org/presentationml/2006/main" xmlns:r="http://schemas.openxmlformats.org/officeDocument/2006/relationships">
+  <p:cSld>
+    <p:spTree>
+      <p:nvGrpSpPr>
+        <p:cNvPr id="1" name=""/>
+        <p:cNvGrpSpPr/>
+        <p:nvPr/>
+      </p:nvGrpSpPr>
+      <p:grpSpPr>
+        <a:xfrm>
+          <a:off x="0" y="0"/>
+          <a:ext cx="0" cy="0"/>
+          <a:chOff x="0" y="0"/>
+          <a:chExt cx="0" cy="0"/>
+        </a:xfrm>
+      </p:grpSpPr>
+      <p:sp>
+        <p:nvSpPr>
+          <p:cNvPr id="2" name="Slide Image Placeholder 1"/>
+          <p:cNvSpPr>
+            <a:spLocks noGrp="1"/>
+          </p:cNvSpPr>
+          <p:nvPr>
+            <p:ph type="sldImg" idx="2"/>
+          </p:nvPr>
+        </p:nvSpPr>
+        <p:spPr/>
+      </p:sp>
+      <p:sp>
+        <p:nvSpPr>
+          <p:cNvPr id="3" name="Notes Placeholder 2"/>
+          <p:cNvSpPr>
+            <a:spLocks noGrp="1"/>
+          </p:cNvSpPr>
+          <p:nvPr>
+            <p:ph type="body" idx="3" sz="quarter"/>
+          </p:nvPr>
+        </p:nvSpPr>
+        <p:spPr/>
+        <p:txBody>
+          <a:bodyPr/>
+          <a:lstStyle/>
+          <a:p>
+            <a:r>
+              <a:t>The interactive demo online: choose one of five test blades, see the method decision, the measured depth and the evidence against the threshold. These are real outputs of the method.</a:t>
+            </a:r>
+          </a:p>
+        </p:txBody>
+      </p:sp>
+      <p:sp>
+        <p:nvSpPr>
+          <p:cNvPr id="4" name="Slide Number Placeholder 3"/>
+          <p:cNvSpPr>
+            <a:spLocks noGrp="1"/>
+          </p:cNvSpPr>
+          <p:nvPr>
+            <p:ph type="sldNum" idx="5" sz="quarter"/>
+          </p:nvPr>
+        </p:nvSpPr>
+        <p:spPr/>
+      </p:sp>
+    </p:spTree>
+  </p:cSld>
+  <p:clrMapOvr>
+    <a:masterClrMapping/>
+  </p:clrMapOvr>
+</p:notes>
+</file>
+
+<file path=ppt/notesSlides/notesSlide25.xml><?xml version="1.0" encoding="utf-8"?>
+<p:notes xmlns:a="http://schemas.openxmlformats.org/drawingml/2006/main" xmlns:p="http://schemas.openxmlformats.org/presentationml/2006/main" xmlns:r="http://schemas.openxmlformats.org/officeDocument/2006/relationships">
+  <p:cSld>
+    <p:spTree>
+      <p:nvGrpSpPr>
+        <p:cNvPr id="1" name=""/>
+        <p:cNvGrpSpPr/>
+        <p:nvPr/>
+      </p:nvGrpSpPr>
+      <p:grpSpPr>
+        <a:xfrm>
+          <a:off x="0" y="0"/>
+          <a:ext cx="0" cy="0"/>
+          <a:chOff x="0" y="0"/>
+          <a:chExt cx="0" cy="0"/>
+        </a:xfrm>
+      </p:grpSpPr>
+      <p:sp>
+        <p:nvSpPr>
+          <p:cNvPr id="2" name="Slide Image Placeholder 1"/>
+          <p:cNvSpPr>
+            <a:spLocks noGrp="1"/>
+          </p:cNvSpPr>
+          <p:nvPr>
+            <p:ph type="sldImg" idx="2"/>
+          </p:nvPr>
+        </p:nvSpPr>
+        <p:spPr/>
+      </p:sp>
+      <p:sp>
+        <p:nvSpPr>
+          <p:cNvPr id="3" name="Notes Placeholder 2"/>
+          <p:cNvSpPr>
+            <a:spLocks noGrp="1"/>
+          </p:cNvSpPr>
+          <p:nvPr>
+            <p:ph type="body" idx="3" sz="quarter"/>
+          </p:nvPr>
+        </p:nvSpPr>
+        <p:spPr/>
+        <p:txBody>
+          <a:bodyPr/>
+          <a:lstStyle/>
+          <a:p>
+            <a:r>
               <a:t>Thank you. Questions welcome.</a:t>
             </a:r>
           </a:p>
@@ -3104,7 +3459,7 @@
           <a:lstStyle/>
           <a:p>
             <a:r>
-              <a:t>First we explain everything that is not damage: refine the camera pose from the blade outline, the light levels, and a possible stain. What is left over is what damage would have to explain.</a:t>
+              <a:t>Offline, once: render blades with known damage, train an appearance model that predicts how a blade looks under the lights, calibrate the decision threshold on healthy and stained blades, then freeze everything. Online, for each inspection: correct the camera and lighting, fit the best no-damage explanation, propose dents with a fast statistical test, fit the best dent by differentiable rendering, and compare the evidence with the threshold. The same fit also gives the detection-limit map.</a:t>
             </a:r>
           </a:p>
         </p:txBody>
@@ -3174,7 +3529,7 @@
           <a:lstStyle/>
           <a:p>
             <a:r>
-              <a:t>Subtract the healthy rendering from the photo. The difference is brightest where something changed; here, the dent. A quick statistical check over the whole surface turns this into a short list of candidate spots.</a:t>
+              <a:t>First we explain everything that is not damage: refine the camera pose from the blade outline, the light levels, and a possible stain. What is left over is what damage would have to explain.</a:t>
             </a:r>
           </a:p>
         </p:txBody>
@@ -3244,7 +3599,7 @@
           <a:lstStyle/>
           <a:p>
             <a:r>
-              <a:t>Starting from a candidate spot, the method fits a smooth dent: where it is, how deep, how big and its shape, by rendering the blade with the dent and adjusting until it matches the photo. Right: the true dent and the measured dent, coloured by depth.</a:t>
+              <a:t>Subtract the healthy rendering from the photo. The difference is brightest where something changed; here, the dent. A quick statistical check over the whole surface turns this into a short list of candidate spots.</a:t>
             </a:r>
           </a:p>
         </p:txBody>
@@ -13130,36 +13485,50 @@
           <a:lstStyle/>
           <a:p>
             <a:r>
-              <a:rPr sz="2400"/>
-              <a:t>Step 1: Explain the Photos Without Assuming Damage</a:t>
-            </a:r>
-          </a:p>
-        </p:txBody>
-      </p:sp>
-      <p:pic>
-        <p:nvPicPr>
-          <p:cNvPr id="3" name="Picture 2" descr="c_cam.png"/>
-          <p:cNvPicPr>
-            <a:picLocks noChangeAspect="1"/>
-          </p:cNvPicPr>
+              <a:rPr sz="3000"/>
+              <a:t>System Architecture</a:t>
+            </a:r>
+          </a:p>
+        </p:txBody>
+      </p:sp>
+      <p:sp>
+        <p:nvSpPr>
+          <p:cNvPr id="3" name="TextBox 2"/>
+          <p:cNvSpPr txBox="1"/>
           <p:nvPr/>
-        </p:nvPicPr>
-        <p:blipFill>
-          <a:blip r:embed="rId2"/>
-          <a:stretch>
-            <a:fillRect/>
-          </a:stretch>
-        </p:blipFill>
-        <p:spPr>
-          <a:xfrm>
-            <a:off x="548640" y="2350824"/>
-            <a:ext cx="3474720" cy="1991759"/>
+        </p:nvSpPr>
+        <p:spPr>
+          <a:xfrm>
+            <a:off x="365760" y="1741932"/>
+            <a:ext cx="2743200" cy="329184"/>
           </a:xfrm>
           <a:prstGeom prst="rect">
             <a:avLst/>
           </a:prstGeom>
-        </p:spPr>
-      </p:pic>
+          <a:noFill/>
+        </p:spPr>
+        <p:txBody>
+          <a:bodyPr wrap="square" anchor="t">
+            <a:spAutoFit/>
+          </a:bodyPr>
+          <a:lstStyle/>
+          <a:p>
+            <a:pPr algn="l">
+              <a:spcAft>
+                <a:spcPts val="200"/>
+              </a:spcAft>
+            </a:pPr>
+            <a:r>
+              <a:rPr sz="1400" b="1">
+                <a:solidFill>
+                  <a:srgbClr val="5A6577"/>
+                </a:solidFill>
+              </a:rPr>
+              <a:t>OFFLINE (once)</a:t>
+            </a:r>
+          </a:p>
+        </p:txBody>
+      </p:sp>
       <p:sp>
         <p:nvSpPr>
           <p:cNvPr id="4" name="Rounded Rectangle 3"/>
@@ -13168,8 +13537,430 @@
         </p:nvSpPr>
         <p:spPr>
           <a:xfrm>
-            <a:off x="548640" y="4869180"/>
-            <a:ext cx="3474720" cy="576072"/>
+            <a:off x="365760" y="2071116"/>
+            <a:ext cx="2514600" cy="822960"/>
+          </a:xfrm>
+          <a:prstGeom prst="roundRect">
+            <a:avLst/>
+          </a:prstGeom>
+          <a:solidFill>
+            <a:srgbClr val="5A6577"/>
+          </a:solidFill>
+          <a:ln>
+            <a:noFill/>
+          </a:ln>
+          <a:effectLst/>
+        </p:spPr>
+        <p:style>
+          <a:lnRef idx="1">
+            <a:schemeClr val="accent1"/>
+          </a:lnRef>
+          <a:fillRef idx="3">
+            <a:schemeClr val="accent1"/>
+          </a:fillRef>
+          <a:effectRef idx="2">
+            <a:schemeClr val="accent1"/>
+          </a:effectRef>
+          <a:fontRef idx="minor">
+            <a:schemeClr val="lt1"/>
+          </a:fontRef>
+        </p:style>
+        <p:txBody>
+          <a:bodyPr rtlCol="0" anchor="ctr" wrap="square"/>
+          <a:lstStyle/>
+          <a:p>
+            <a:pPr algn="ctr"/>
+            <a:r>
+              <a:rPr sz="1500" b="1">
+                <a:solidFill>
+                  <a:srgbClr val="FFFFFF"/>
+                </a:solidFill>
+              </a:rPr>
+              <a:t>Blade CAD + synthetic damage</a:t>
+            </a:r>
+          </a:p>
+          <a:p>
+            <a:pPr algn="ctr"/>
+            <a:r>
+              <a:rPr sz="1300" b="0">
+                <a:solidFill>
+                  <a:srgbClr val="FFFFFF"/>
+                </a:solidFill>
+              </a:rPr>
+              <a:t>Blender renders</a:t>
+            </a:r>
+          </a:p>
+        </p:txBody>
+      </p:sp>
+      <p:sp>
+        <p:nvSpPr>
+          <p:cNvPr id="5" name="Right Arrow 4"/>
+          <p:cNvSpPr/>
+          <p:nvPr/>
+        </p:nvSpPr>
+        <p:spPr>
+          <a:xfrm>
+            <a:off x="2907791" y="2318004"/>
+            <a:ext cx="292608" cy="288036"/>
+          </a:xfrm>
+          <a:prstGeom prst="rightArrow">
+            <a:avLst/>
+          </a:prstGeom>
+          <a:solidFill>
+            <a:srgbClr val="5A6577"/>
+          </a:solidFill>
+          <a:ln>
+            <a:noFill/>
+          </a:ln>
+          <a:effectLst/>
+        </p:spPr>
+        <p:style>
+          <a:lnRef idx="1">
+            <a:schemeClr val="accent1"/>
+          </a:lnRef>
+          <a:fillRef idx="3">
+            <a:schemeClr val="accent1"/>
+          </a:fillRef>
+          <a:effectRef idx="2">
+            <a:schemeClr val="accent1"/>
+          </a:effectRef>
+          <a:fontRef idx="minor">
+            <a:schemeClr val="lt1"/>
+          </a:fontRef>
+        </p:style>
+        <p:txBody>
+          <a:bodyPr rtlCol="0" anchor="ctr"/>
+          <a:lstStyle/>
+          <a:p>
+            <a:pPr algn="ctr"/>
+          </a:p>
+        </p:txBody>
+      </p:sp>
+      <p:sp>
+        <p:nvSpPr>
+          <p:cNvPr id="6" name="Rounded Rectangle 5"/>
+          <p:cNvSpPr/>
+          <p:nvPr/>
+        </p:nvSpPr>
+        <p:spPr>
+          <a:xfrm>
+            <a:off x="3246120" y="2071116"/>
+            <a:ext cx="2514600" cy="822960"/>
+          </a:xfrm>
+          <a:prstGeom prst="roundRect">
+            <a:avLst/>
+          </a:prstGeom>
+          <a:solidFill>
+            <a:srgbClr val="5A6577"/>
+          </a:solidFill>
+          <a:ln>
+            <a:noFill/>
+          </a:ln>
+          <a:effectLst/>
+        </p:spPr>
+        <p:style>
+          <a:lnRef idx="1">
+            <a:schemeClr val="accent1"/>
+          </a:lnRef>
+          <a:fillRef idx="3">
+            <a:schemeClr val="accent1"/>
+          </a:fillRef>
+          <a:effectRef idx="2">
+            <a:schemeClr val="accent1"/>
+          </a:effectRef>
+          <a:fontRef idx="minor">
+            <a:schemeClr val="lt1"/>
+          </a:fontRef>
+        </p:style>
+        <p:txBody>
+          <a:bodyPr rtlCol="0" anchor="ctr" wrap="square"/>
+          <a:lstStyle/>
+          <a:p>
+            <a:pPr algn="ctr"/>
+            <a:r>
+              <a:rPr sz="1500" b="1">
+                <a:solidFill>
+                  <a:srgbClr val="FFFFFF"/>
+                </a:solidFill>
+              </a:rPr>
+              <a:t>Appearance model</a:t>
+            </a:r>
+          </a:p>
+          <a:p>
+            <a:pPr algn="ctr"/>
+            <a:r>
+              <a:rPr sz="1300" b="0">
+                <a:solidFill>
+                  <a:srgbClr val="FFFFFF"/>
+                </a:solidFill>
+              </a:rPr>
+              <a:t>trained on renders</a:t>
+            </a:r>
+          </a:p>
+        </p:txBody>
+      </p:sp>
+      <p:sp>
+        <p:nvSpPr>
+          <p:cNvPr id="7" name="Right Arrow 6"/>
+          <p:cNvSpPr/>
+          <p:nvPr/>
+        </p:nvSpPr>
+        <p:spPr>
+          <a:xfrm>
+            <a:off x="5788152" y="2318004"/>
+            <a:ext cx="292608" cy="288036"/>
+          </a:xfrm>
+          <a:prstGeom prst="rightArrow">
+            <a:avLst/>
+          </a:prstGeom>
+          <a:solidFill>
+            <a:srgbClr val="5A6577"/>
+          </a:solidFill>
+          <a:ln>
+            <a:noFill/>
+          </a:ln>
+          <a:effectLst/>
+        </p:spPr>
+        <p:style>
+          <a:lnRef idx="1">
+            <a:schemeClr val="accent1"/>
+          </a:lnRef>
+          <a:fillRef idx="3">
+            <a:schemeClr val="accent1"/>
+          </a:fillRef>
+          <a:effectRef idx="2">
+            <a:schemeClr val="accent1"/>
+          </a:effectRef>
+          <a:fontRef idx="minor">
+            <a:schemeClr val="lt1"/>
+          </a:fontRef>
+        </p:style>
+        <p:txBody>
+          <a:bodyPr rtlCol="0" anchor="ctr"/>
+          <a:lstStyle/>
+          <a:p>
+            <a:pPr algn="ctr"/>
+          </a:p>
+        </p:txBody>
+      </p:sp>
+      <p:sp>
+        <p:nvSpPr>
+          <p:cNvPr id="8" name="Rounded Rectangle 7"/>
+          <p:cNvSpPr/>
+          <p:nvPr/>
+        </p:nvSpPr>
+        <p:spPr>
+          <a:xfrm>
+            <a:off x="6126480" y="2071116"/>
+            <a:ext cx="2514600" cy="822960"/>
+          </a:xfrm>
+          <a:prstGeom prst="roundRect">
+            <a:avLst/>
+          </a:prstGeom>
+          <a:solidFill>
+            <a:srgbClr val="5A6577"/>
+          </a:solidFill>
+          <a:ln>
+            <a:noFill/>
+          </a:ln>
+          <a:effectLst/>
+        </p:spPr>
+        <p:style>
+          <a:lnRef idx="1">
+            <a:schemeClr val="accent1"/>
+          </a:lnRef>
+          <a:fillRef idx="3">
+            <a:schemeClr val="accent1"/>
+          </a:fillRef>
+          <a:effectRef idx="2">
+            <a:schemeClr val="accent1"/>
+          </a:effectRef>
+          <a:fontRef idx="minor">
+            <a:schemeClr val="lt1"/>
+          </a:fontRef>
+        </p:style>
+        <p:txBody>
+          <a:bodyPr rtlCol="0" anchor="ctr" wrap="square"/>
+          <a:lstStyle/>
+          <a:p>
+            <a:pPr algn="ctr"/>
+            <a:r>
+              <a:rPr sz="1500" b="1">
+                <a:solidFill>
+                  <a:srgbClr val="FFFFFF"/>
+                </a:solidFill>
+              </a:rPr>
+              <a:t>Calibrate threshold</a:t>
+            </a:r>
+          </a:p>
+          <a:p>
+            <a:pPr algn="ctr"/>
+            <a:r>
+              <a:rPr sz="1300" b="0">
+                <a:solidFill>
+                  <a:srgbClr val="FFFFFF"/>
+                </a:solidFill>
+              </a:rPr>
+              <a:t>healthy + stained blades</a:t>
+            </a:r>
+          </a:p>
+        </p:txBody>
+      </p:sp>
+      <p:sp>
+        <p:nvSpPr>
+          <p:cNvPr id="9" name="Right Arrow 8"/>
+          <p:cNvSpPr/>
+          <p:nvPr/>
+        </p:nvSpPr>
+        <p:spPr>
+          <a:xfrm>
+            <a:off x="8668512" y="2318004"/>
+            <a:ext cx="292608" cy="288036"/>
+          </a:xfrm>
+          <a:prstGeom prst="rightArrow">
+            <a:avLst/>
+          </a:prstGeom>
+          <a:solidFill>
+            <a:srgbClr val="5A6577"/>
+          </a:solidFill>
+          <a:ln>
+            <a:noFill/>
+          </a:ln>
+          <a:effectLst/>
+        </p:spPr>
+        <p:style>
+          <a:lnRef idx="1">
+            <a:schemeClr val="accent1"/>
+          </a:lnRef>
+          <a:fillRef idx="3">
+            <a:schemeClr val="accent1"/>
+          </a:fillRef>
+          <a:effectRef idx="2">
+            <a:schemeClr val="accent1"/>
+          </a:effectRef>
+          <a:fontRef idx="minor">
+            <a:schemeClr val="lt1"/>
+          </a:fontRef>
+        </p:style>
+        <p:txBody>
+          <a:bodyPr rtlCol="0" anchor="ctr"/>
+          <a:lstStyle/>
+          <a:p>
+            <a:pPr algn="ctr"/>
+          </a:p>
+        </p:txBody>
+      </p:sp>
+      <p:sp>
+        <p:nvSpPr>
+          <p:cNvPr id="10" name="Rounded Rectangle 9"/>
+          <p:cNvSpPr/>
+          <p:nvPr/>
+        </p:nvSpPr>
+        <p:spPr>
+          <a:xfrm>
+            <a:off x="9006840" y="2071116"/>
+            <a:ext cx="2514600" cy="822960"/>
+          </a:xfrm>
+          <a:prstGeom prst="roundRect">
+            <a:avLst/>
+          </a:prstGeom>
+          <a:solidFill>
+            <a:srgbClr val="5A6577"/>
+          </a:solidFill>
+          <a:ln>
+            <a:noFill/>
+          </a:ln>
+          <a:effectLst/>
+        </p:spPr>
+        <p:style>
+          <a:lnRef idx="1">
+            <a:schemeClr val="accent1"/>
+          </a:lnRef>
+          <a:fillRef idx="3">
+            <a:schemeClr val="accent1"/>
+          </a:fillRef>
+          <a:effectRef idx="2">
+            <a:schemeClr val="accent1"/>
+          </a:effectRef>
+          <a:fontRef idx="minor">
+            <a:schemeClr val="lt1"/>
+          </a:fontRef>
+        </p:style>
+        <p:txBody>
+          <a:bodyPr rtlCol="0" anchor="ctr" wrap="square"/>
+          <a:lstStyle/>
+          <a:p>
+            <a:pPr algn="ctr"/>
+            <a:r>
+              <a:rPr sz="1500" b="1">
+                <a:solidFill>
+                  <a:srgbClr val="FFFFFF"/>
+                </a:solidFill>
+              </a:rPr>
+              <a:t>Freeze</a:t>
+            </a:r>
+          </a:p>
+          <a:p>
+            <a:pPr algn="ctr"/>
+            <a:r>
+              <a:rPr sz="1300" b="0">
+                <a:solidFill>
+                  <a:srgbClr val="FFFFFF"/>
+                </a:solidFill>
+              </a:rPr>
+              <a:t>fingerprint, then test</a:t>
+            </a:r>
+          </a:p>
+        </p:txBody>
+      </p:sp>
+      <p:sp>
+        <p:nvSpPr>
+          <p:cNvPr id="11" name="TextBox 10"/>
+          <p:cNvSpPr txBox="1"/>
+          <p:nvPr/>
+        </p:nvSpPr>
+        <p:spPr>
+          <a:xfrm>
+            <a:off x="365760" y="3099816"/>
+            <a:ext cx="2743200" cy="329184"/>
+          </a:xfrm>
+          <a:prstGeom prst="rect">
+            <a:avLst/>
+          </a:prstGeom>
+          <a:noFill/>
+        </p:spPr>
+        <p:txBody>
+          <a:bodyPr wrap="square" anchor="t">
+            <a:spAutoFit/>
+          </a:bodyPr>
+          <a:lstStyle/>
+          <a:p>
+            <a:pPr algn="l">
+              <a:spcAft>
+                <a:spcPts val="200"/>
+              </a:spcAft>
+            </a:pPr>
+            <a:r>
+              <a:rPr sz="1400" b="1">
+                <a:solidFill>
+                  <a:srgbClr val="0047BB"/>
+                </a:solidFill>
+              </a:rPr>
+              <a:t>ONLINE (each inspection)</a:t>
+            </a:r>
+          </a:p>
+        </p:txBody>
+      </p:sp>
+      <p:sp>
+        <p:nvSpPr>
+          <p:cNvPr id="12" name="Rounded Rectangle 11"/>
+          <p:cNvSpPr/>
+          <p:nvPr/>
+        </p:nvSpPr>
+        <p:spPr>
+          <a:xfrm>
+            <a:off x="365760" y="3429000"/>
+            <a:ext cx="1691640" cy="1028700"/>
           </a:xfrm>
           <a:prstGeom prst="roundRect">
             <a:avLst/>
@@ -13202,50 +13993,81 @@
           <a:p>
             <a:pPr algn="ctr"/>
             <a:r>
-              <a:rPr sz="2000" b="1">
+              <a:rPr sz="1400" b="1">
                 <a:solidFill>
                   <a:srgbClr val="FFFFFF"/>
                 </a:solidFill>
               </a:rPr>
-              <a:t>Fix camera position</a:t>
-            </a:r>
-          </a:p>
-        </p:txBody>
-      </p:sp>
-      <p:pic>
-        <p:nvPicPr>
-          <p:cNvPr id="5" name="Picture 4" descr="c_light.png"/>
-          <p:cNvPicPr>
-            <a:picLocks noChangeAspect="1"/>
-          </p:cNvPicPr>
-          <p:nvPr/>
-        </p:nvPicPr>
-        <p:blipFill>
-          <a:blip r:embed="rId3"/>
-          <a:stretch>
-            <a:fillRect/>
-          </a:stretch>
-        </p:blipFill>
-        <p:spPr>
-          <a:xfrm>
-            <a:off x="4343400" y="2350824"/>
-            <a:ext cx="3474720" cy="1991759"/>
-          </a:xfrm>
-          <a:prstGeom prst="rect">
-            <a:avLst/>
-          </a:prstGeom>
-        </p:spPr>
-      </p:pic>
-      <p:sp>
-        <p:nvSpPr>
-          <p:cNvPr id="6" name="Rounded Rectangle 5"/>
+              <a:t>CAD + 2–7 photos</a:t>
+            </a:r>
+          </a:p>
+          <a:p>
+            <a:pPr algn="ctr"/>
+            <a:r>
+              <a:rPr sz="1200" b="0">
+                <a:solidFill>
+                  <a:srgbClr val="FFFFFF"/>
+                </a:solidFill>
+              </a:rPr>
+              <a:t>calibrated cameras</a:t>
+            </a:r>
+          </a:p>
+        </p:txBody>
+      </p:sp>
+      <p:sp>
+        <p:nvSpPr>
+          <p:cNvPr id="13" name="Right Arrow 12"/>
           <p:cNvSpPr/>
           <p:nvPr/>
         </p:nvSpPr>
         <p:spPr>
           <a:xfrm>
-            <a:off x="4343400" y="4869180"/>
-            <a:ext cx="3474720" cy="576072"/>
+            <a:off x="2075688" y="3799332"/>
+            <a:ext cx="201168" cy="263347"/>
+          </a:xfrm>
+          <a:prstGeom prst="rightArrow">
+            <a:avLst/>
+          </a:prstGeom>
+          <a:solidFill>
+            <a:srgbClr val="5A6577"/>
+          </a:solidFill>
+          <a:ln>
+            <a:noFill/>
+          </a:ln>
+          <a:effectLst/>
+        </p:spPr>
+        <p:style>
+          <a:lnRef idx="1">
+            <a:schemeClr val="accent1"/>
+          </a:lnRef>
+          <a:fillRef idx="3">
+            <a:schemeClr val="accent1"/>
+          </a:fillRef>
+          <a:effectRef idx="2">
+            <a:schemeClr val="accent1"/>
+          </a:effectRef>
+          <a:fontRef idx="minor">
+            <a:schemeClr val="lt1"/>
+          </a:fontRef>
+        </p:style>
+        <p:txBody>
+          <a:bodyPr rtlCol="0" anchor="ctr"/>
+          <a:lstStyle/>
+          <a:p>
+            <a:pPr algn="ctr"/>
+          </a:p>
+        </p:txBody>
+      </p:sp>
+      <p:sp>
+        <p:nvSpPr>
+          <p:cNvPr id="14" name="Rounded Rectangle 13"/>
+          <p:cNvSpPr/>
+          <p:nvPr/>
+        </p:nvSpPr>
+        <p:spPr>
+          <a:xfrm>
+            <a:off x="2286000" y="3429000"/>
+            <a:ext cx="1691640" cy="1028700"/>
           </a:xfrm>
           <a:prstGeom prst="roundRect">
             <a:avLst/>
@@ -13278,50 +14100,81 @@
           <a:p>
             <a:pPr algn="ctr"/>
             <a:r>
-              <a:rPr sz="2000" b="1">
+              <a:rPr sz="1400" b="1">
                 <a:solidFill>
                   <a:srgbClr val="FFFFFF"/>
                 </a:solidFill>
               </a:rPr>
-              <a:t>Fix lighting changes</a:t>
-            </a:r>
-          </a:p>
-        </p:txBody>
-      </p:sp>
-      <p:pic>
-        <p:nvPicPr>
-          <p:cNvPr id="7" name="Picture 6" descr="c_stain.png"/>
-          <p:cNvPicPr>
-            <a:picLocks noChangeAspect="1"/>
-          </p:cNvPicPr>
-          <p:nvPr/>
-        </p:nvPicPr>
-        <p:blipFill>
-          <a:blip r:embed="rId4"/>
-          <a:stretch>
-            <a:fillRect/>
-          </a:stretch>
-        </p:blipFill>
-        <p:spPr>
-          <a:xfrm>
-            <a:off x="8464829" y="1947672"/>
-            <a:ext cx="2821381" cy="2798064"/>
-          </a:xfrm>
-          <a:prstGeom prst="rect">
-            <a:avLst/>
-          </a:prstGeom>
-        </p:spPr>
-      </p:pic>
-      <p:sp>
-        <p:nvSpPr>
-          <p:cNvPr id="8" name="Rounded Rectangle 7"/>
+              <a:t>Camera &amp; light fix</a:t>
+            </a:r>
+          </a:p>
+          <a:p>
+            <a:pPr algn="ctr"/>
+            <a:r>
+              <a:rPr sz="1200" b="0">
+                <a:solidFill>
+                  <a:srgbClr val="FFFFFF"/>
+                </a:solidFill>
+              </a:rPr>
+              <a:t>v1.1: moves with blade</a:t>
+            </a:r>
+          </a:p>
+        </p:txBody>
+      </p:sp>
+      <p:sp>
+        <p:nvSpPr>
+          <p:cNvPr id="15" name="Right Arrow 14"/>
           <p:cNvSpPr/>
           <p:nvPr/>
         </p:nvSpPr>
         <p:spPr>
           <a:xfrm>
-            <a:off x="8138160" y="4869180"/>
-            <a:ext cx="3474720" cy="576072"/>
+            <a:off x="3995928" y="3799332"/>
+            <a:ext cx="201168" cy="263347"/>
+          </a:xfrm>
+          <a:prstGeom prst="rightArrow">
+            <a:avLst/>
+          </a:prstGeom>
+          <a:solidFill>
+            <a:srgbClr val="5A6577"/>
+          </a:solidFill>
+          <a:ln>
+            <a:noFill/>
+          </a:ln>
+          <a:effectLst/>
+        </p:spPr>
+        <p:style>
+          <a:lnRef idx="1">
+            <a:schemeClr val="accent1"/>
+          </a:lnRef>
+          <a:fillRef idx="3">
+            <a:schemeClr val="accent1"/>
+          </a:fillRef>
+          <a:effectRef idx="2">
+            <a:schemeClr val="accent1"/>
+          </a:effectRef>
+          <a:fontRef idx="minor">
+            <a:schemeClr val="lt1"/>
+          </a:fontRef>
+        </p:style>
+        <p:txBody>
+          <a:bodyPr rtlCol="0" anchor="ctr"/>
+          <a:lstStyle/>
+          <a:p>
+            <a:pPr algn="ctr"/>
+          </a:p>
+        </p:txBody>
+      </p:sp>
+      <p:sp>
+        <p:nvSpPr>
+          <p:cNvPr id="16" name="Rounded Rectangle 15"/>
+          <p:cNvSpPr/>
+          <p:nvPr/>
+        </p:nvSpPr>
+        <p:spPr>
+          <a:xfrm>
+            <a:off x="4206240" y="3429000"/>
+            <a:ext cx="1691640" cy="1028700"/>
           </a:xfrm>
           <a:prstGeom prst="roundRect">
             <a:avLst/>
@@ -13354,50 +14207,500 @@
           <a:p>
             <a:pPr algn="ctr"/>
             <a:r>
-              <a:rPr sz="2000" b="1">
+              <a:rPr sz="1400" b="1">
                 <a:solidFill>
                   <a:srgbClr val="FFFFFF"/>
                 </a:solidFill>
               </a:rPr>
-              <a:t>Fix stains</a:t>
-            </a:r>
-          </a:p>
-        </p:txBody>
-      </p:sp>
-      <p:sp>
-        <p:nvSpPr>
-          <p:cNvPr id="9" name="TextBox 8"/>
-          <p:cNvSpPr txBox="1"/>
-          <p:nvPr/>
-        </p:nvSpPr>
-        <p:spPr>
-          <a:xfrm>
-            <a:off x="548640" y="5650992"/>
-            <a:ext cx="11064240" cy="493776"/>
-          </a:xfrm>
-          <a:prstGeom prst="rect">
-            <a:avLst/>
-          </a:prstGeom>
-          <a:noFill/>
-        </p:spPr>
-        <p:txBody>
-          <a:bodyPr wrap="square" anchor="t">
-            <a:spAutoFit/>
-          </a:bodyPr>
-          <a:lstStyle/>
-          <a:p>
-            <a:pPr algn="ctr">
-              <a:spcAft>
-                <a:spcPts val="200"/>
-              </a:spcAft>
-            </a:pPr>
-            <a:r>
-              <a:rPr sz="2200" b="1">
+              <a:t>No-damage fit</a:t>
+            </a:r>
+          </a:p>
+          <a:p>
+            <a:pPr algn="ctr"/>
+            <a:r>
+              <a:rPr sz="1200" b="0">
                 <a:solidFill>
-                  <a:srgbClr val="0047BB"/>
+                  <a:srgbClr val="FFFFFF"/>
                 </a:solidFill>
               </a:rPr>
-              <a:t>This gives us the best 'no damage' explanation.</a:t>
+              <a:t>pose · light · stain</a:t>
+            </a:r>
+          </a:p>
+        </p:txBody>
+      </p:sp>
+      <p:sp>
+        <p:nvSpPr>
+          <p:cNvPr id="17" name="Right Arrow 16"/>
+          <p:cNvSpPr/>
+          <p:nvPr/>
+        </p:nvSpPr>
+        <p:spPr>
+          <a:xfrm>
+            <a:off x="5916168" y="3799332"/>
+            <a:ext cx="201168" cy="263347"/>
+          </a:xfrm>
+          <a:prstGeom prst="rightArrow">
+            <a:avLst/>
+          </a:prstGeom>
+          <a:solidFill>
+            <a:srgbClr val="5A6577"/>
+          </a:solidFill>
+          <a:ln>
+            <a:noFill/>
+          </a:ln>
+          <a:effectLst/>
+        </p:spPr>
+        <p:style>
+          <a:lnRef idx="1">
+            <a:schemeClr val="accent1"/>
+          </a:lnRef>
+          <a:fillRef idx="3">
+            <a:schemeClr val="accent1"/>
+          </a:fillRef>
+          <a:effectRef idx="2">
+            <a:schemeClr val="accent1"/>
+          </a:effectRef>
+          <a:fontRef idx="minor">
+            <a:schemeClr val="lt1"/>
+          </a:fontRef>
+        </p:style>
+        <p:txBody>
+          <a:bodyPr rtlCol="0" anchor="ctr"/>
+          <a:lstStyle/>
+          <a:p>
+            <a:pPr algn="ctr"/>
+          </a:p>
+        </p:txBody>
+      </p:sp>
+      <p:sp>
+        <p:nvSpPr>
+          <p:cNvPr id="18" name="Rounded Rectangle 17"/>
+          <p:cNvSpPr/>
+          <p:nvPr/>
+        </p:nvSpPr>
+        <p:spPr>
+          <a:xfrm>
+            <a:off x="6126480" y="3429000"/>
+            <a:ext cx="1691640" cy="1028700"/>
+          </a:xfrm>
+          <a:prstGeom prst="roundRect">
+            <a:avLst/>
+          </a:prstGeom>
+          <a:solidFill>
+            <a:srgbClr val="E8833A"/>
+          </a:solidFill>
+          <a:ln>
+            <a:noFill/>
+          </a:ln>
+          <a:effectLst/>
+        </p:spPr>
+        <p:style>
+          <a:lnRef idx="1">
+            <a:schemeClr val="accent1"/>
+          </a:lnRef>
+          <a:fillRef idx="3">
+            <a:schemeClr val="accent1"/>
+          </a:fillRef>
+          <a:effectRef idx="2">
+            <a:schemeClr val="accent1"/>
+          </a:effectRef>
+          <a:fontRef idx="minor">
+            <a:schemeClr val="lt1"/>
+          </a:fontRef>
+        </p:style>
+        <p:txBody>
+          <a:bodyPr rtlCol="0" anchor="ctr" wrap="square"/>
+          <a:lstStyle/>
+          <a:p>
+            <a:pPr algn="ctr"/>
+            <a:r>
+              <a:rPr sz="1400" b="1">
+                <a:solidFill>
+                  <a:srgbClr val="FFFFFF"/>
+                </a:solidFill>
+              </a:rPr>
+              <a:t>Dent proposals</a:t>
+            </a:r>
+          </a:p>
+          <a:p>
+            <a:pPr algn="ctr"/>
+            <a:r>
+              <a:rPr sz="1200" b="0">
+                <a:solidFill>
+                  <a:srgbClr val="FFFFFF"/>
+                </a:solidFill>
+              </a:rPr>
+              <a:t>score test, 1 pass</a:t>
+            </a:r>
+          </a:p>
+        </p:txBody>
+      </p:sp>
+      <p:sp>
+        <p:nvSpPr>
+          <p:cNvPr id="19" name="Right Arrow 18"/>
+          <p:cNvSpPr/>
+          <p:nvPr/>
+        </p:nvSpPr>
+        <p:spPr>
+          <a:xfrm>
+            <a:off x="7836408" y="3799332"/>
+            <a:ext cx="201168" cy="263347"/>
+          </a:xfrm>
+          <a:prstGeom prst="rightArrow">
+            <a:avLst/>
+          </a:prstGeom>
+          <a:solidFill>
+            <a:srgbClr val="5A6577"/>
+          </a:solidFill>
+          <a:ln>
+            <a:noFill/>
+          </a:ln>
+          <a:effectLst/>
+        </p:spPr>
+        <p:style>
+          <a:lnRef idx="1">
+            <a:schemeClr val="accent1"/>
+          </a:lnRef>
+          <a:fillRef idx="3">
+            <a:schemeClr val="accent1"/>
+          </a:fillRef>
+          <a:effectRef idx="2">
+            <a:schemeClr val="accent1"/>
+          </a:effectRef>
+          <a:fontRef idx="minor">
+            <a:schemeClr val="lt1"/>
+          </a:fontRef>
+        </p:style>
+        <p:txBody>
+          <a:bodyPr rtlCol="0" anchor="ctr"/>
+          <a:lstStyle/>
+          <a:p>
+            <a:pPr algn="ctr"/>
+          </a:p>
+        </p:txBody>
+      </p:sp>
+      <p:sp>
+        <p:nvSpPr>
+          <p:cNvPr id="20" name="Rounded Rectangle 19"/>
+          <p:cNvSpPr/>
+          <p:nvPr/>
+        </p:nvSpPr>
+        <p:spPr>
+          <a:xfrm>
+            <a:off x="8046720" y="3429000"/>
+            <a:ext cx="1691640" cy="1028700"/>
+          </a:xfrm>
+          <a:prstGeom prst="roundRect">
+            <a:avLst/>
+          </a:prstGeom>
+          <a:solidFill>
+            <a:srgbClr val="E8833A"/>
+          </a:solidFill>
+          <a:ln>
+            <a:noFill/>
+          </a:ln>
+          <a:effectLst/>
+        </p:spPr>
+        <p:style>
+          <a:lnRef idx="1">
+            <a:schemeClr val="accent1"/>
+          </a:lnRef>
+          <a:fillRef idx="3">
+            <a:schemeClr val="accent1"/>
+          </a:fillRef>
+          <a:effectRef idx="2">
+            <a:schemeClr val="accent1"/>
+          </a:effectRef>
+          <a:fontRef idx="minor">
+            <a:schemeClr val="lt1"/>
+          </a:fontRef>
+        </p:style>
+        <p:txBody>
+          <a:bodyPr rtlCol="0" anchor="ctr" wrap="square"/>
+          <a:lstStyle/>
+          <a:p>
+            <a:pPr algn="ctr"/>
+            <a:r>
+              <a:rPr sz="1400" b="1">
+                <a:solidFill>
+                  <a:srgbClr val="FFFFFF"/>
+                </a:solidFill>
+              </a:rPr>
+              <a:t>Dent fit</a:t>
+            </a:r>
+          </a:p>
+          <a:p>
+            <a:pPr algn="ctr"/>
+            <a:r>
+              <a:rPr sz="1200" b="0">
+                <a:solidFill>
+                  <a:srgbClr val="FFFFFF"/>
+                </a:solidFill>
+              </a:rPr>
+              <a:t>differentiable rendering</a:t>
+            </a:r>
+          </a:p>
+        </p:txBody>
+      </p:sp>
+      <p:sp>
+        <p:nvSpPr>
+          <p:cNvPr id="21" name="Right Arrow 20"/>
+          <p:cNvSpPr/>
+          <p:nvPr/>
+        </p:nvSpPr>
+        <p:spPr>
+          <a:xfrm>
+            <a:off x="9756648" y="3799332"/>
+            <a:ext cx="201168" cy="263347"/>
+          </a:xfrm>
+          <a:prstGeom prst="rightArrow">
+            <a:avLst/>
+          </a:prstGeom>
+          <a:solidFill>
+            <a:srgbClr val="5A6577"/>
+          </a:solidFill>
+          <a:ln>
+            <a:noFill/>
+          </a:ln>
+          <a:effectLst/>
+        </p:spPr>
+        <p:style>
+          <a:lnRef idx="1">
+            <a:schemeClr val="accent1"/>
+          </a:lnRef>
+          <a:fillRef idx="3">
+            <a:schemeClr val="accent1"/>
+          </a:fillRef>
+          <a:effectRef idx="2">
+            <a:schemeClr val="accent1"/>
+          </a:effectRef>
+          <a:fontRef idx="minor">
+            <a:schemeClr val="lt1"/>
+          </a:fontRef>
+        </p:style>
+        <p:txBody>
+          <a:bodyPr rtlCol="0" anchor="ctr"/>
+          <a:lstStyle/>
+          <a:p>
+            <a:pPr algn="ctr"/>
+          </a:p>
+        </p:txBody>
+      </p:sp>
+      <p:sp>
+        <p:nvSpPr>
+          <p:cNvPr id="22" name="Rounded Rectangle 21"/>
+          <p:cNvSpPr/>
+          <p:nvPr/>
+        </p:nvSpPr>
+        <p:spPr>
+          <a:xfrm>
+            <a:off x="9966960" y="3429000"/>
+            <a:ext cx="1691640" cy="1028700"/>
+          </a:xfrm>
+          <a:prstGeom prst="roundRect">
+            <a:avLst/>
+          </a:prstGeom>
+          <a:solidFill>
+            <a:srgbClr val="1A7F37"/>
+          </a:solidFill>
+          <a:ln>
+            <a:noFill/>
+          </a:ln>
+          <a:effectLst/>
+        </p:spPr>
+        <p:style>
+          <a:lnRef idx="1">
+            <a:schemeClr val="accent1"/>
+          </a:lnRef>
+          <a:fillRef idx="3">
+            <a:schemeClr val="accent1"/>
+          </a:fillRef>
+          <a:effectRef idx="2">
+            <a:schemeClr val="accent1"/>
+          </a:effectRef>
+          <a:fontRef idx="minor">
+            <a:schemeClr val="lt1"/>
+          </a:fontRef>
+        </p:style>
+        <p:txBody>
+          <a:bodyPr rtlCol="0" anchor="ctr" wrap="square"/>
+          <a:lstStyle/>
+          <a:p>
+            <a:pPr algn="ctr"/>
+            <a:r>
+              <a:rPr sz="1400" b="1">
+                <a:solidFill>
+                  <a:srgbClr val="FFFFFF"/>
+                </a:solidFill>
+              </a:rPr>
+              <a:t>Evidence vs threshold</a:t>
+            </a:r>
+          </a:p>
+          <a:p>
+            <a:pPr algn="ctr"/>
+            <a:r>
+              <a:rPr sz="1200" b="0">
+                <a:solidFill>
+                  <a:srgbClr val="FFFFFF"/>
+                </a:solidFill>
+              </a:rPr>
+              <a:t>report or abstain</a:t>
+            </a:r>
+          </a:p>
+        </p:txBody>
+      </p:sp>
+      <p:sp>
+        <p:nvSpPr>
+          <p:cNvPr id="23" name="Rounded Rectangle 22"/>
+          <p:cNvSpPr/>
+          <p:nvPr/>
+        </p:nvSpPr>
+        <p:spPr>
+          <a:xfrm>
+            <a:off x="6126480" y="4828031"/>
+            <a:ext cx="2651760" cy="740664"/>
+          </a:xfrm>
+          <a:prstGeom prst="roundRect">
+            <a:avLst/>
+          </a:prstGeom>
+          <a:solidFill>
+            <a:srgbClr val="1A7F37"/>
+          </a:solidFill>
+          <a:ln>
+            <a:noFill/>
+          </a:ln>
+          <a:effectLst/>
+        </p:spPr>
+        <p:style>
+          <a:lnRef idx="1">
+            <a:schemeClr val="accent1"/>
+          </a:lnRef>
+          <a:fillRef idx="3">
+            <a:schemeClr val="accent1"/>
+          </a:fillRef>
+          <a:effectRef idx="2">
+            <a:schemeClr val="accent1"/>
+          </a:effectRef>
+          <a:fontRef idx="minor">
+            <a:schemeClr val="lt1"/>
+          </a:fontRef>
+        </p:style>
+        <p:txBody>
+          <a:bodyPr rtlCol="0" anchor="ctr" wrap="square"/>
+          <a:lstStyle/>
+          <a:p>
+            <a:pPr algn="ctr"/>
+            <a:r>
+              <a:rPr sz="1600" b="1">
+                <a:solidFill>
+                  <a:srgbClr val="FFFFFF"/>
+                </a:solidFill>
+              </a:rPr>
+              <a:t>Dent: location + depth (mm)</a:t>
+            </a:r>
+          </a:p>
+        </p:txBody>
+      </p:sp>
+      <p:sp>
+        <p:nvSpPr>
+          <p:cNvPr id="24" name="Rounded Rectangle 23"/>
+          <p:cNvSpPr/>
+          <p:nvPr/>
+        </p:nvSpPr>
+        <p:spPr>
+          <a:xfrm>
+            <a:off x="8961120" y="4828031"/>
+            <a:ext cx="2651760" cy="740664"/>
+          </a:xfrm>
+          <a:prstGeom prst="roundRect">
+            <a:avLst/>
+          </a:prstGeom>
+          <a:solidFill>
+            <a:srgbClr val="C62828"/>
+          </a:solidFill>
+          <a:ln>
+            <a:noFill/>
+          </a:ln>
+          <a:effectLst/>
+        </p:spPr>
+        <p:style>
+          <a:lnRef idx="1">
+            <a:schemeClr val="accent1"/>
+          </a:lnRef>
+          <a:fillRef idx="3">
+            <a:schemeClr val="accent1"/>
+          </a:fillRef>
+          <a:effectRef idx="2">
+            <a:schemeClr val="accent1"/>
+          </a:effectRef>
+          <a:fontRef idx="minor">
+            <a:schemeClr val="lt1"/>
+          </a:fontRef>
+        </p:style>
+        <p:txBody>
+          <a:bodyPr rtlCol="0" anchor="ctr" wrap="square"/>
+          <a:lstStyle/>
+          <a:p>
+            <a:pPr algn="ctr"/>
+            <a:r>
+              <a:rPr sz="1600" b="1">
+                <a:solidFill>
+                  <a:srgbClr val="FFFFFF"/>
+                </a:solidFill>
+              </a:rPr>
+              <a:t>Not supported</a:t>
+            </a:r>
+          </a:p>
+        </p:txBody>
+      </p:sp>
+      <p:sp>
+        <p:nvSpPr>
+          <p:cNvPr id="25" name="Rounded Rectangle 24"/>
+          <p:cNvSpPr/>
+          <p:nvPr/>
+        </p:nvSpPr>
+        <p:spPr>
+          <a:xfrm>
+            <a:off x="365760" y="4828031"/>
+            <a:ext cx="5486400" cy="740664"/>
+          </a:xfrm>
+          <a:prstGeom prst="roundRect">
+            <a:avLst/>
+          </a:prstGeom>
+          <a:solidFill>
+            <a:srgbClr val="F2F5FA"/>
+          </a:solidFill>
+          <a:ln>
+            <a:noFill/>
+          </a:ln>
+          <a:effectLst/>
+        </p:spPr>
+        <p:style>
+          <a:lnRef idx="1">
+            <a:schemeClr val="accent1"/>
+          </a:lnRef>
+          <a:fillRef idx="3">
+            <a:schemeClr val="accent1"/>
+          </a:fillRef>
+          <a:effectRef idx="2">
+            <a:schemeClr val="accent1"/>
+          </a:effectRef>
+          <a:fontRef idx="minor">
+            <a:schemeClr val="lt1"/>
+          </a:fontRef>
+        </p:style>
+        <p:txBody>
+          <a:bodyPr rtlCol="0" anchor="ctr" wrap="square"/>
+          <a:lstStyle/>
+          <a:p>
+            <a:pPr algn="ctr"/>
+            <a:r>
+              <a:rPr sz="1600" b="1">
+                <a:solidFill>
+                  <a:srgbClr val="1F2937"/>
+                </a:solidFill>
+              </a:rPr>
+              <a:t>Detection-limit map: smallest visible dent per point</a:t>
             </a:r>
           </a:p>
         </p:txBody>
@@ -13436,15 +14739,15 @@
           <a:lstStyle/>
           <a:p>
             <a:r>
-              <a:rPr sz="3000"/>
-              <a:t>Step 2: Find Where Damage Could Be</a:t>
+              <a:rPr sz="2400"/>
+              <a:t>Step 1: Explain the Photos Without Assuming Damage</a:t>
             </a:r>
           </a:p>
         </p:txBody>
       </p:sp>
       <p:pic>
         <p:nvPicPr>
-          <p:cNvPr id="3" name="Picture 2" descr="s8_photo.png"/>
+          <p:cNvPr id="3" name="Picture 2" descr="c_cam.png"/>
           <p:cNvPicPr>
             <a:picLocks noChangeAspect="1"/>
           </p:cNvPicPr>
@@ -13458,8 +14761,8 @@
         </p:blipFill>
         <p:spPr>
           <a:xfrm>
-            <a:off x="927512" y="1947672"/>
-            <a:ext cx="2534095" cy="3456432"/>
+            <a:off x="548640" y="2350824"/>
+            <a:ext cx="3474720" cy="1991759"/>
           </a:xfrm>
           <a:prstGeom prst="rect">
             <a:avLst/>
@@ -13468,45 +14771,59 @@
       </p:pic>
       <p:sp>
         <p:nvSpPr>
-          <p:cNvPr id="4" name="TextBox 3"/>
-          <p:cNvSpPr txBox="1"/>
+          <p:cNvPr id="4" name="Rounded Rectangle 3"/>
+          <p:cNvSpPr/>
           <p:nvPr/>
         </p:nvSpPr>
         <p:spPr>
           <a:xfrm>
-            <a:off x="640080" y="5486400"/>
-            <a:ext cx="3108960" cy="411480"/>
-          </a:xfrm>
-          <a:prstGeom prst="rect">
-            <a:avLst/>
-          </a:prstGeom>
-          <a:noFill/>
-        </p:spPr>
-        <p:txBody>
-          <a:bodyPr wrap="square" anchor="t">
-            <a:spAutoFit/>
-          </a:bodyPr>
-          <a:lstStyle/>
-          <a:p>
-            <a:pPr algn="ctr">
-              <a:spcAft>
-                <a:spcPts val="200"/>
-              </a:spcAft>
-            </a:pPr>
+            <a:off x="548640" y="4869180"/>
+            <a:ext cx="3474720" cy="576072"/>
+          </a:xfrm>
+          <a:prstGeom prst="roundRect">
+            <a:avLst/>
+          </a:prstGeom>
+          <a:solidFill>
+            <a:srgbClr val="0047BB"/>
+          </a:solidFill>
+          <a:ln>
+            <a:noFill/>
+          </a:ln>
+          <a:effectLst/>
+        </p:spPr>
+        <p:style>
+          <a:lnRef idx="1">
+            <a:schemeClr val="accent1"/>
+          </a:lnRef>
+          <a:fillRef idx="3">
+            <a:schemeClr val="accent1"/>
+          </a:fillRef>
+          <a:effectRef idx="2">
+            <a:schemeClr val="accent1"/>
+          </a:effectRef>
+          <a:fontRef idx="minor">
+            <a:schemeClr val="lt1"/>
+          </a:fontRef>
+        </p:style>
+        <p:txBody>
+          <a:bodyPr rtlCol="0" anchor="ctr" wrap="square"/>
+          <a:lstStyle/>
+          <a:p>
+            <a:pPr algn="ctr"/>
             <a:r>
               <a:rPr sz="2000" b="1">
                 <a:solidFill>
-                  <a:srgbClr val="1F2937"/>
+                  <a:srgbClr val="FFFFFF"/>
                 </a:solidFill>
               </a:rPr>
-              <a:t>Photo</a:t>
+              <a:t>Fix camera position</a:t>
             </a:r>
           </a:p>
         </p:txBody>
       </p:sp>
       <p:pic>
         <p:nvPicPr>
-          <p:cNvPr id="5" name="Picture 4" descr="s8_healthy.png"/>
+          <p:cNvPr id="5" name="Picture 4" descr="c_light.png"/>
           <p:cNvPicPr>
             <a:picLocks noChangeAspect="1"/>
           </p:cNvPicPr>
@@ -13520,8 +14837,8 @@
         </p:blipFill>
         <p:spPr>
           <a:xfrm>
-            <a:off x="4859432" y="1947672"/>
-            <a:ext cx="2534095" cy="3456432"/>
+            <a:off x="4343400" y="2350824"/>
+            <a:ext cx="3474720" cy="1991759"/>
           </a:xfrm>
           <a:prstGeom prst="rect">
             <a:avLst/>
@@ -13530,45 +14847,59 @@
       </p:pic>
       <p:sp>
         <p:nvSpPr>
-          <p:cNvPr id="6" name="TextBox 5"/>
-          <p:cNvSpPr txBox="1"/>
+          <p:cNvPr id="6" name="Rounded Rectangle 5"/>
+          <p:cNvSpPr/>
           <p:nvPr/>
         </p:nvSpPr>
         <p:spPr>
           <a:xfrm>
-            <a:off x="4572000" y="5486400"/>
-            <a:ext cx="3108960" cy="411480"/>
-          </a:xfrm>
-          <a:prstGeom prst="rect">
-            <a:avLst/>
-          </a:prstGeom>
-          <a:noFill/>
-        </p:spPr>
-        <p:txBody>
-          <a:bodyPr wrap="square" anchor="t">
-            <a:spAutoFit/>
-          </a:bodyPr>
-          <a:lstStyle/>
-          <a:p>
-            <a:pPr algn="ctr">
-              <a:spcAft>
-                <a:spcPts val="200"/>
-              </a:spcAft>
-            </a:pPr>
+            <a:off x="4343400" y="4869180"/>
+            <a:ext cx="3474720" cy="576072"/>
+          </a:xfrm>
+          <a:prstGeom prst="roundRect">
+            <a:avLst/>
+          </a:prstGeom>
+          <a:solidFill>
+            <a:srgbClr val="0047BB"/>
+          </a:solidFill>
+          <a:ln>
+            <a:noFill/>
+          </a:ln>
+          <a:effectLst/>
+        </p:spPr>
+        <p:style>
+          <a:lnRef idx="1">
+            <a:schemeClr val="accent1"/>
+          </a:lnRef>
+          <a:fillRef idx="3">
+            <a:schemeClr val="accent1"/>
+          </a:fillRef>
+          <a:effectRef idx="2">
+            <a:schemeClr val="accent1"/>
+          </a:effectRef>
+          <a:fontRef idx="minor">
+            <a:schemeClr val="lt1"/>
+          </a:fontRef>
+        </p:style>
+        <p:txBody>
+          <a:bodyPr rtlCol="0" anchor="ctr" wrap="square"/>
+          <a:lstStyle/>
+          <a:p>
+            <a:pPr algn="ctr"/>
             <a:r>
               <a:rPr sz="2000" b="1">
                 <a:solidFill>
-                  <a:srgbClr val="1F2937"/>
+                  <a:srgbClr val="FFFFFF"/>
                 </a:solidFill>
               </a:rPr>
-              <a:t>Healthy render</a:t>
+              <a:t>Fix lighting changes</a:t>
             </a:r>
           </a:p>
         </p:txBody>
       </p:sp>
       <p:pic>
         <p:nvPicPr>
-          <p:cNvPr id="7" name="Picture 6" descr="s8_residual.png"/>
+          <p:cNvPr id="7" name="Picture 6" descr="c_stain.png"/>
           <p:cNvPicPr>
             <a:picLocks noChangeAspect="1"/>
           </p:cNvPicPr>
@@ -13582,8 +14913,8 @@
         </p:blipFill>
         <p:spPr>
           <a:xfrm>
-            <a:off x="8791352" y="1947672"/>
-            <a:ext cx="2534095" cy="3456432"/>
+            <a:off x="8464829" y="1947672"/>
+            <a:ext cx="2821381" cy="2798064"/>
           </a:xfrm>
           <a:prstGeom prst="rect">
             <a:avLst/>
@@ -13592,14 +14923,66 @@
       </p:pic>
       <p:sp>
         <p:nvSpPr>
-          <p:cNvPr id="8" name="TextBox 7"/>
+          <p:cNvPr id="8" name="Rounded Rectangle 7"/>
+          <p:cNvSpPr/>
+          <p:nvPr/>
+        </p:nvSpPr>
+        <p:spPr>
+          <a:xfrm>
+            <a:off x="8138160" y="4869180"/>
+            <a:ext cx="3474720" cy="576072"/>
+          </a:xfrm>
+          <a:prstGeom prst="roundRect">
+            <a:avLst/>
+          </a:prstGeom>
+          <a:solidFill>
+            <a:srgbClr val="0047BB"/>
+          </a:solidFill>
+          <a:ln>
+            <a:noFill/>
+          </a:ln>
+          <a:effectLst/>
+        </p:spPr>
+        <p:style>
+          <a:lnRef idx="1">
+            <a:schemeClr val="accent1"/>
+          </a:lnRef>
+          <a:fillRef idx="3">
+            <a:schemeClr val="accent1"/>
+          </a:fillRef>
+          <a:effectRef idx="2">
+            <a:schemeClr val="accent1"/>
+          </a:effectRef>
+          <a:fontRef idx="minor">
+            <a:schemeClr val="lt1"/>
+          </a:fontRef>
+        </p:style>
+        <p:txBody>
+          <a:bodyPr rtlCol="0" anchor="ctr" wrap="square"/>
+          <a:lstStyle/>
+          <a:p>
+            <a:pPr algn="ctr"/>
+            <a:r>
+              <a:rPr sz="2000" b="1">
+                <a:solidFill>
+                  <a:srgbClr val="FFFFFF"/>
+                </a:solidFill>
+              </a:rPr>
+              <a:t>Fix stains</a:t>
+            </a:r>
+          </a:p>
+        </p:txBody>
+      </p:sp>
+      <p:sp>
+        <p:nvSpPr>
+          <p:cNvPr id="9" name="TextBox 8"/>
           <p:cNvSpPr txBox="1"/>
           <p:nvPr/>
         </p:nvSpPr>
         <p:spPr>
           <a:xfrm>
-            <a:off x="8503919" y="5486400"/>
-            <a:ext cx="3108960" cy="411480"/>
+            <a:off x="548640" y="5650992"/>
+            <a:ext cx="11064240" cy="493776"/>
           </a:xfrm>
           <a:prstGeom prst="rect">
             <a:avLst/>
@@ -13618,126 +15001,12 @@
               </a:spcAft>
             </a:pPr>
             <a:r>
-              <a:rPr sz="2000" b="1">
+              <a:rPr sz="2200" b="1">
                 <a:solidFill>
-                  <a:srgbClr val="1F2937"/>
+                  <a:srgbClr val="0047BB"/>
                 </a:solidFill>
               </a:rPr>
-              <a:t>Difference</a:t>
-            </a:r>
-          </a:p>
-        </p:txBody>
-      </p:sp>
-      <p:sp>
-        <p:nvSpPr>
-          <p:cNvPr id="9" name="TextBox 8"/>
-          <p:cNvSpPr txBox="1"/>
-          <p:nvPr/>
-        </p:nvSpPr>
-        <p:spPr>
-          <a:xfrm>
-            <a:off x="3749039" y="3346704"/>
-            <a:ext cx="822960" cy="740664"/>
-          </a:xfrm>
-          <a:prstGeom prst="rect">
-            <a:avLst/>
-          </a:prstGeom>
-          <a:noFill/>
-        </p:spPr>
-        <p:txBody>
-          <a:bodyPr wrap="square" anchor="t">
-            <a:spAutoFit/>
-          </a:bodyPr>
-          <a:lstStyle/>
-          <a:p>
-            <a:pPr algn="ctr">
-              <a:spcAft>
-                <a:spcPts val="200"/>
-              </a:spcAft>
-            </a:pPr>
-            <a:r>
-              <a:rPr sz="5400" b="1">
-                <a:solidFill>
-                  <a:srgbClr val="5A6577"/>
-                </a:solidFill>
-              </a:rPr>
-              <a:t>−</a:t>
-            </a:r>
-          </a:p>
-        </p:txBody>
-      </p:sp>
-      <p:sp>
-        <p:nvSpPr>
-          <p:cNvPr id="10" name="TextBox 9"/>
-          <p:cNvSpPr txBox="1"/>
-          <p:nvPr/>
-        </p:nvSpPr>
-        <p:spPr>
-          <a:xfrm>
-            <a:off x="7680960" y="3346704"/>
-            <a:ext cx="822960" cy="740664"/>
-          </a:xfrm>
-          <a:prstGeom prst="rect">
-            <a:avLst/>
-          </a:prstGeom>
-          <a:noFill/>
-        </p:spPr>
-        <p:txBody>
-          <a:bodyPr wrap="square" anchor="t">
-            <a:spAutoFit/>
-          </a:bodyPr>
-          <a:lstStyle/>
-          <a:p>
-            <a:pPr algn="ctr">
-              <a:spcAft>
-                <a:spcPts val="200"/>
-              </a:spcAft>
-            </a:pPr>
-            <a:r>
-              <a:rPr sz="5400" b="1">
-                <a:solidFill>
-                  <a:srgbClr val="5A6577"/>
-                </a:solidFill>
-              </a:rPr>
-              <a:t>=</a:t>
-            </a:r>
-          </a:p>
-        </p:txBody>
-      </p:sp>
-      <p:sp>
-        <p:nvSpPr>
-          <p:cNvPr id="11" name="TextBox 10"/>
-          <p:cNvSpPr txBox="1"/>
-          <p:nvPr/>
-        </p:nvSpPr>
-        <p:spPr>
-          <a:xfrm>
-            <a:off x="8046720" y="5856731"/>
-            <a:ext cx="3840480" cy="411480"/>
-          </a:xfrm>
-          <a:prstGeom prst="rect">
-            <a:avLst/>
-          </a:prstGeom>
-          <a:noFill/>
-        </p:spPr>
-        <p:txBody>
-          <a:bodyPr wrap="square" anchor="t">
-            <a:spAutoFit/>
-          </a:bodyPr>
-          <a:lstStyle/>
-          <a:p>
-            <a:pPr algn="ctr">
-              <a:spcAft>
-                <a:spcPts val="200"/>
-              </a:spcAft>
-            </a:pPr>
-            <a:r>
-              <a:rPr sz="1800" b="1">
-                <a:solidFill>
-                  <a:srgbClr val="E8833A"/>
-                </a:solidFill>
-              </a:rPr>
-              <a:t>Bright = suspicious region</a:t>
+              <a:t>This gives us the best 'no damage' explanation.</a:t>
             </a:r>
           </a:p>
         </p:txBody>
@@ -13777,203 +15046,14 @@
           <a:p>
             <a:r>
               <a:rPr sz="3000"/>
-              <a:t>Step 3: Estimate the 3D Shape</a:t>
-            </a:r>
-          </a:p>
-        </p:txBody>
-      </p:sp>
-      <p:sp>
-        <p:nvSpPr>
-          <p:cNvPr id="3" name="Rounded Rectangle 2"/>
-          <p:cNvSpPr/>
-          <p:nvPr/>
-        </p:nvSpPr>
-        <p:spPr>
-          <a:xfrm>
-            <a:off x="548640" y="2029968"/>
-            <a:ext cx="3840480" cy="1069848"/>
-          </a:xfrm>
-          <a:prstGeom prst="roundRect">
-            <a:avLst/>
-          </a:prstGeom>
-          <a:solidFill>
-            <a:srgbClr val="0047BB"/>
-          </a:solidFill>
-          <a:ln>
-            <a:noFill/>
-          </a:ln>
-          <a:effectLst/>
-        </p:spPr>
-        <p:style>
-          <a:lnRef idx="1">
-            <a:schemeClr val="accent1"/>
-          </a:lnRef>
-          <a:fillRef idx="3">
-            <a:schemeClr val="accent1"/>
-          </a:fillRef>
-          <a:effectRef idx="2">
-            <a:schemeClr val="accent1"/>
-          </a:effectRef>
-          <a:fontRef idx="minor">
-            <a:schemeClr val="lt1"/>
-          </a:fontRef>
-        </p:style>
-        <p:txBody>
-          <a:bodyPr rtlCol="0" anchor="ctr" wrap="square"/>
-          <a:lstStyle/>
-          <a:p>
-            <a:pPr algn="ctr"/>
-            <a:r>
-              <a:rPr sz="1900" b="1">
-                <a:solidFill>
-                  <a:srgbClr val="FFFFFF"/>
-                </a:solidFill>
-              </a:rPr>
-              <a:t>Candidate spot</a:t>
-            </a:r>
-          </a:p>
-          <a:p>
-            <a:pPr algn="ctr"/>
-            <a:r>
-              <a:rPr sz="1700" b="0">
-                <a:solidFill>
-                  <a:srgbClr val="FFFFFF"/>
-                </a:solidFill>
-              </a:rPr>
-              <a:t>from step 2</a:t>
-            </a:r>
-          </a:p>
-        </p:txBody>
-      </p:sp>
-      <p:sp>
-        <p:nvSpPr>
-          <p:cNvPr id="4" name="Rounded Rectangle 3"/>
-          <p:cNvSpPr/>
-          <p:nvPr/>
-        </p:nvSpPr>
-        <p:spPr>
-          <a:xfrm>
-            <a:off x="548640" y="3387852"/>
-            <a:ext cx="3840480" cy="1069848"/>
-          </a:xfrm>
-          <a:prstGeom prst="roundRect">
-            <a:avLst/>
-          </a:prstGeom>
-          <a:solidFill>
-            <a:srgbClr val="E8833A"/>
-          </a:solidFill>
-          <a:ln>
-            <a:noFill/>
-          </a:ln>
-          <a:effectLst/>
-        </p:spPr>
-        <p:style>
-          <a:lnRef idx="1">
-            <a:schemeClr val="accent1"/>
-          </a:lnRef>
-          <a:fillRef idx="3">
-            <a:schemeClr val="accent1"/>
-          </a:fillRef>
-          <a:effectRef idx="2">
-            <a:schemeClr val="accent1"/>
-          </a:effectRef>
-          <a:fontRef idx="minor">
-            <a:schemeClr val="lt1"/>
-          </a:fontRef>
-        </p:style>
-        <p:txBody>
-          <a:bodyPr rtlCol="0" anchor="ctr" wrap="square"/>
-          <a:lstStyle/>
-          <a:p>
-            <a:pPr algn="ctr"/>
-            <a:r>
-              <a:rPr sz="1900" b="1">
-                <a:solidFill>
-                  <a:srgbClr val="FFFFFF"/>
-                </a:solidFill>
-              </a:rPr>
-              <a:t>Smooth dent</a:t>
-            </a:r>
-          </a:p>
-          <a:p>
-            <a:pPr algn="ctr"/>
-            <a:r>
-              <a:rPr sz="1700" b="0">
-                <a:solidFill>
-                  <a:srgbClr val="FFFFFF"/>
-                </a:solidFill>
-              </a:rPr>
-              <a:t>position · depth · size · shape</a:t>
-            </a:r>
-          </a:p>
-        </p:txBody>
-      </p:sp>
-      <p:sp>
-        <p:nvSpPr>
-          <p:cNvPr id="5" name="Rounded Rectangle 4"/>
-          <p:cNvSpPr/>
-          <p:nvPr/>
-        </p:nvSpPr>
-        <p:spPr>
-          <a:xfrm>
-            <a:off x="548640" y="4745736"/>
-            <a:ext cx="3840480" cy="1069848"/>
-          </a:xfrm>
-          <a:prstGeom prst="roundRect">
-            <a:avLst/>
-          </a:prstGeom>
-          <a:solidFill>
-            <a:srgbClr val="E8833A"/>
-          </a:solidFill>
-          <a:ln>
-            <a:noFill/>
-          </a:ln>
-          <a:effectLst/>
-        </p:spPr>
-        <p:style>
-          <a:lnRef idx="1">
-            <a:schemeClr val="accent1"/>
-          </a:lnRef>
-          <a:fillRef idx="3">
-            <a:schemeClr val="accent1"/>
-          </a:fillRef>
-          <a:effectRef idx="2">
-            <a:schemeClr val="accent1"/>
-          </a:effectRef>
-          <a:fontRef idx="minor">
-            <a:schemeClr val="lt1"/>
-          </a:fontRef>
-        </p:style>
-        <p:txBody>
-          <a:bodyPr rtlCol="0" anchor="ctr" wrap="square"/>
-          <a:lstStyle/>
-          <a:p>
-            <a:pPr algn="ctr"/>
-            <a:r>
-              <a:rPr sz="1900" b="1">
-                <a:solidFill>
-                  <a:srgbClr val="FFFFFF"/>
-                </a:solidFill>
-              </a:rPr>
-              <a:t>Render &amp; compare</a:t>
-            </a:r>
-          </a:p>
-          <a:p>
-            <a:pPr algn="ctr"/>
-            <a:r>
-              <a:rPr sz="1700" b="0">
-                <a:solidFill>
-                  <a:srgbClr val="FFFFFF"/>
-                </a:solidFill>
-              </a:rPr>
-              <a:t>with the photo, adjust</a:t>
+              <a:t>Step 2: Find Where Damage Could Be</a:t>
             </a:r>
           </a:p>
         </p:txBody>
       </p:sp>
       <p:pic>
         <p:nvPicPr>
-          <p:cNvPr id="6" name="Picture 5" descr="depth_01.png"/>
+          <p:cNvPr id="3" name="Picture 2" descr="s8_photo.png"/>
           <p:cNvPicPr>
             <a:picLocks noChangeAspect="1"/>
           </p:cNvPicPr>
@@ -13987,8 +15067,8 @@
         </p:blipFill>
         <p:spPr>
           <a:xfrm>
-            <a:off x="4846320" y="1959647"/>
-            <a:ext cx="6858000" cy="3761664"/>
+            <a:off x="927512" y="1947672"/>
+            <a:ext cx="2534095" cy="3456432"/>
           </a:xfrm>
           <a:prstGeom prst="rect">
             <a:avLst/>
@@ -13997,14 +15077,14 @@
       </p:pic>
       <p:sp>
         <p:nvSpPr>
-          <p:cNvPr id="7" name="TextBox 6"/>
+          <p:cNvPr id="4" name="TextBox 3"/>
           <p:cNvSpPr txBox="1"/>
           <p:nvPr/>
         </p:nvSpPr>
         <p:spPr>
           <a:xfrm>
-            <a:off x="548640" y="5939028"/>
-            <a:ext cx="11155680" cy="411480"/>
+            <a:off x="640080" y="5486400"/>
+            <a:ext cx="3108960" cy="411480"/>
           </a:xfrm>
           <a:prstGeom prst="rect">
             <a:avLst/>
@@ -14023,12 +15103,250 @@
               </a:spcAft>
             </a:pPr>
             <a:r>
-              <a:rPr sz="1800" b="0">
+              <a:rPr sz="2000" b="1">
+                <a:solidFill>
+                  <a:srgbClr val="1F2937"/>
+                </a:solidFill>
+              </a:rPr>
+              <a:t>Photo</a:t>
+            </a:r>
+          </a:p>
+        </p:txBody>
+      </p:sp>
+      <p:pic>
+        <p:nvPicPr>
+          <p:cNvPr id="5" name="Picture 4" descr="s8_healthy.png"/>
+          <p:cNvPicPr>
+            <a:picLocks noChangeAspect="1"/>
+          </p:cNvPicPr>
+          <p:nvPr/>
+        </p:nvPicPr>
+        <p:blipFill>
+          <a:blip r:embed="rId3"/>
+          <a:stretch>
+            <a:fillRect/>
+          </a:stretch>
+        </p:blipFill>
+        <p:spPr>
+          <a:xfrm>
+            <a:off x="4859432" y="1947672"/>
+            <a:ext cx="2534095" cy="3456432"/>
+          </a:xfrm>
+          <a:prstGeom prst="rect">
+            <a:avLst/>
+          </a:prstGeom>
+        </p:spPr>
+      </p:pic>
+      <p:sp>
+        <p:nvSpPr>
+          <p:cNvPr id="6" name="TextBox 5"/>
+          <p:cNvSpPr txBox="1"/>
+          <p:nvPr/>
+        </p:nvSpPr>
+        <p:spPr>
+          <a:xfrm>
+            <a:off x="4572000" y="5486400"/>
+            <a:ext cx="3108960" cy="411480"/>
+          </a:xfrm>
+          <a:prstGeom prst="rect">
+            <a:avLst/>
+          </a:prstGeom>
+          <a:noFill/>
+        </p:spPr>
+        <p:txBody>
+          <a:bodyPr wrap="square" anchor="t">
+            <a:spAutoFit/>
+          </a:bodyPr>
+          <a:lstStyle/>
+          <a:p>
+            <a:pPr algn="ctr">
+              <a:spcAft>
+                <a:spcPts val="200"/>
+              </a:spcAft>
+            </a:pPr>
+            <a:r>
+              <a:rPr sz="2000" b="1">
+                <a:solidFill>
+                  <a:srgbClr val="1F2937"/>
+                </a:solidFill>
+              </a:rPr>
+              <a:t>Healthy render</a:t>
+            </a:r>
+          </a:p>
+        </p:txBody>
+      </p:sp>
+      <p:pic>
+        <p:nvPicPr>
+          <p:cNvPr id="7" name="Picture 6" descr="s8_residual.png"/>
+          <p:cNvPicPr>
+            <a:picLocks noChangeAspect="1"/>
+          </p:cNvPicPr>
+          <p:nvPr/>
+        </p:nvPicPr>
+        <p:blipFill>
+          <a:blip r:embed="rId4"/>
+          <a:stretch>
+            <a:fillRect/>
+          </a:stretch>
+        </p:blipFill>
+        <p:spPr>
+          <a:xfrm>
+            <a:off x="8791352" y="1947672"/>
+            <a:ext cx="2534095" cy="3456432"/>
+          </a:xfrm>
+          <a:prstGeom prst="rect">
+            <a:avLst/>
+          </a:prstGeom>
+        </p:spPr>
+      </p:pic>
+      <p:sp>
+        <p:nvSpPr>
+          <p:cNvPr id="8" name="TextBox 7"/>
+          <p:cNvSpPr txBox="1"/>
+          <p:nvPr/>
+        </p:nvSpPr>
+        <p:spPr>
+          <a:xfrm>
+            <a:off x="8503919" y="5486400"/>
+            <a:ext cx="3108960" cy="411480"/>
+          </a:xfrm>
+          <a:prstGeom prst="rect">
+            <a:avLst/>
+          </a:prstGeom>
+          <a:noFill/>
+        </p:spPr>
+        <p:txBody>
+          <a:bodyPr wrap="square" anchor="t">
+            <a:spAutoFit/>
+          </a:bodyPr>
+          <a:lstStyle/>
+          <a:p>
+            <a:pPr algn="ctr">
+              <a:spcAft>
+                <a:spcPts val="200"/>
+              </a:spcAft>
+            </a:pPr>
+            <a:r>
+              <a:rPr sz="2000" b="1">
+                <a:solidFill>
+                  <a:srgbClr val="1F2937"/>
+                </a:solidFill>
+              </a:rPr>
+              <a:t>Difference</a:t>
+            </a:r>
+          </a:p>
+        </p:txBody>
+      </p:sp>
+      <p:sp>
+        <p:nvSpPr>
+          <p:cNvPr id="9" name="TextBox 8"/>
+          <p:cNvSpPr txBox="1"/>
+          <p:nvPr/>
+        </p:nvSpPr>
+        <p:spPr>
+          <a:xfrm>
+            <a:off x="3749039" y="3346704"/>
+            <a:ext cx="822960" cy="740664"/>
+          </a:xfrm>
+          <a:prstGeom prst="rect">
+            <a:avLst/>
+          </a:prstGeom>
+          <a:noFill/>
+        </p:spPr>
+        <p:txBody>
+          <a:bodyPr wrap="square" anchor="t">
+            <a:spAutoFit/>
+          </a:bodyPr>
+          <a:lstStyle/>
+          <a:p>
+            <a:pPr algn="ctr">
+              <a:spcAft>
+                <a:spcPts val="200"/>
+              </a:spcAft>
+            </a:pPr>
+            <a:r>
+              <a:rPr sz="5400" b="1">
                 <a:solidFill>
                   <a:srgbClr val="5A6577"/>
                 </a:solidFill>
               </a:rPr>
-              <a:t>Optimised via differentiable rendering. Reported 0.35 mm, true 0.36 mm.</a:t>
+              <a:t>−</a:t>
+            </a:r>
+          </a:p>
+        </p:txBody>
+      </p:sp>
+      <p:sp>
+        <p:nvSpPr>
+          <p:cNvPr id="10" name="TextBox 9"/>
+          <p:cNvSpPr txBox="1"/>
+          <p:nvPr/>
+        </p:nvSpPr>
+        <p:spPr>
+          <a:xfrm>
+            <a:off x="7680960" y="3346704"/>
+            <a:ext cx="822960" cy="740664"/>
+          </a:xfrm>
+          <a:prstGeom prst="rect">
+            <a:avLst/>
+          </a:prstGeom>
+          <a:noFill/>
+        </p:spPr>
+        <p:txBody>
+          <a:bodyPr wrap="square" anchor="t">
+            <a:spAutoFit/>
+          </a:bodyPr>
+          <a:lstStyle/>
+          <a:p>
+            <a:pPr algn="ctr">
+              <a:spcAft>
+                <a:spcPts val="200"/>
+              </a:spcAft>
+            </a:pPr>
+            <a:r>
+              <a:rPr sz="5400" b="1">
+                <a:solidFill>
+                  <a:srgbClr val="5A6577"/>
+                </a:solidFill>
+              </a:rPr>
+              <a:t>=</a:t>
+            </a:r>
+          </a:p>
+        </p:txBody>
+      </p:sp>
+      <p:sp>
+        <p:nvSpPr>
+          <p:cNvPr id="11" name="TextBox 10"/>
+          <p:cNvSpPr txBox="1"/>
+          <p:nvPr/>
+        </p:nvSpPr>
+        <p:spPr>
+          <a:xfrm>
+            <a:off x="8046720" y="5856731"/>
+            <a:ext cx="3840480" cy="411480"/>
+          </a:xfrm>
+          <a:prstGeom prst="rect">
+            <a:avLst/>
+          </a:prstGeom>
+          <a:noFill/>
+        </p:spPr>
+        <p:txBody>
+          <a:bodyPr wrap="square" anchor="t">
+            <a:spAutoFit/>
+          </a:bodyPr>
+          <a:lstStyle/>
+          <a:p>
+            <a:pPr algn="ctr">
+              <a:spcAft>
+                <a:spcPts val="200"/>
+              </a:spcAft>
+            </a:pPr>
+            <a:r>
+              <a:rPr sz="1800" b="1">
+                <a:solidFill>
+                  <a:srgbClr val="E8833A"/>
+                </a:solidFill>
+              </a:rPr>
+              <a:t>Bright = suspicious region</a:t>
             </a:r>
           </a:p>
         </p:txBody>
@@ -14067,6 +15385,297 @@
           <a:lstStyle/>
           <a:p>
             <a:r>
+              <a:rPr sz="3000"/>
+              <a:t>Step 3: Estimate the 3D Shape</a:t>
+            </a:r>
+          </a:p>
+        </p:txBody>
+      </p:sp>
+      <p:sp>
+        <p:nvSpPr>
+          <p:cNvPr id="3" name="Rounded Rectangle 2"/>
+          <p:cNvSpPr/>
+          <p:nvPr/>
+        </p:nvSpPr>
+        <p:spPr>
+          <a:xfrm>
+            <a:off x="548640" y="2029968"/>
+            <a:ext cx="3840480" cy="1069848"/>
+          </a:xfrm>
+          <a:prstGeom prst="roundRect">
+            <a:avLst/>
+          </a:prstGeom>
+          <a:solidFill>
+            <a:srgbClr val="0047BB"/>
+          </a:solidFill>
+          <a:ln>
+            <a:noFill/>
+          </a:ln>
+          <a:effectLst/>
+        </p:spPr>
+        <p:style>
+          <a:lnRef idx="1">
+            <a:schemeClr val="accent1"/>
+          </a:lnRef>
+          <a:fillRef idx="3">
+            <a:schemeClr val="accent1"/>
+          </a:fillRef>
+          <a:effectRef idx="2">
+            <a:schemeClr val="accent1"/>
+          </a:effectRef>
+          <a:fontRef idx="minor">
+            <a:schemeClr val="lt1"/>
+          </a:fontRef>
+        </p:style>
+        <p:txBody>
+          <a:bodyPr rtlCol="0" anchor="ctr" wrap="square"/>
+          <a:lstStyle/>
+          <a:p>
+            <a:pPr algn="ctr"/>
+            <a:r>
+              <a:rPr sz="1900" b="1">
+                <a:solidFill>
+                  <a:srgbClr val="FFFFFF"/>
+                </a:solidFill>
+              </a:rPr>
+              <a:t>Candidate spot</a:t>
+            </a:r>
+          </a:p>
+          <a:p>
+            <a:pPr algn="ctr"/>
+            <a:r>
+              <a:rPr sz="1700" b="0">
+                <a:solidFill>
+                  <a:srgbClr val="FFFFFF"/>
+                </a:solidFill>
+              </a:rPr>
+              <a:t>from step 2</a:t>
+            </a:r>
+          </a:p>
+        </p:txBody>
+      </p:sp>
+      <p:sp>
+        <p:nvSpPr>
+          <p:cNvPr id="4" name="Rounded Rectangle 3"/>
+          <p:cNvSpPr/>
+          <p:nvPr/>
+        </p:nvSpPr>
+        <p:spPr>
+          <a:xfrm>
+            <a:off x="548640" y="3387852"/>
+            <a:ext cx="3840480" cy="1069848"/>
+          </a:xfrm>
+          <a:prstGeom prst="roundRect">
+            <a:avLst/>
+          </a:prstGeom>
+          <a:solidFill>
+            <a:srgbClr val="E8833A"/>
+          </a:solidFill>
+          <a:ln>
+            <a:noFill/>
+          </a:ln>
+          <a:effectLst/>
+        </p:spPr>
+        <p:style>
+          <a:lnRef idx="1">
+            <a:schemeClr val="accent1"/>
+          </a:lnRef>
+          <a:fillRef idx="3">
+            <a:schemeClr val="accent1"/>
+          </a:fillRef>
+          <a:effectRef idx="2">
+            <a:schemeClr val="accent1"/>
+          </a:effectRef>
+          <a:fontRef idx="minor">
+            <a:schemeClr val="lt1"/>
+          </a:fontRef>
+        </p:style>
+        <p:txBody>
+          <a:bodyPr rtlCol="0" anchor="ctr" wrap="square"/>
+          <a:lstStyle/>
+          <a:p>
+            <a:pPr algn="ctr"/>
+            <a:r>
+              <a:rPr sz="1900" b="1">
+                <a:solidFill>
+                  <a:srgbClr val="FFFFFF"/>
+                </a:solidFill>
+              </a:rPr>
+              <a:t>Smooth dent</a:t>
+            </a:r>
+          </a:p>
+          <a:p>
+            <a:pPr algn="ctr"/>
+            <a:r>
+              <a:rPr sz="1700" b="0">
+                <a:solidFill>
+                  <a:srgbClr val="FFFFFF"/>
+                </a:solidFill>
+              </a:rPr>
+              <a:t>position · depth · size · shape</a:t>
+            </a:r>
+          </a:p>
+        </p:txBody>
+      </p:sp>
+      <p:sp>
+        <p:nvSpPr>
+          <p:cNvPr id="5" name="Rounded Rectangle 4"/>
+          <p:cNvSpPr/>
+          <p:nvPr/>
+        </p:nvSpPr>
+        <p:spPr>
+          <a:xfrm>
+            <a:off x="548640" y="4745736"/>
+            <a:ext cx="3840480" cy="1069848"/>
+          </a:xfrm>
+          <a:prstGeom prst="roundRect">
+            <a:avLst/>
+          </a:prstGeom>
+          <a:solidFill>
+            <a:srgbClr val="E8833A"/>
+          </a:solidFill>
+          <a:ln>
+            <a:noFill/>
+          </a:ln>
+          <a:effectLst/>
+        </p:spPr>
+        <p:style>
+          <a:lnRef idx="1">
+            <a:schemeClr val="accent1"/>
+          </a:lnRef>
+          <a:fillRef idx="3">
+            <a:schemeClr val="accent1"/>
+          </a:fillRef>
+          <a:effectRef idx="2">
+            <a:schemeClr val="accent1"/>
+          </a:effectRef>
+          <a:fontRef idx="minor">
+            <a:schemeClr val="lt1"/>
+          </a:fontRef>
+        </p:style>
+        <p:txBody>
+          <a:bodyPr rtlCol="0" anchor="ctr" wrap="square"/>
+          <a:lstStyle/>
+          <a:p>
+            <a:pPr algn="ctr"/>
+            <a:r>
+              <a:rPr sz="1900" b="1">
+                <a:solidFill>
+                  <a:srgbClr val="FFFFFF"/>
+                </a:solidFill>
+              </a:rPr>
+              <a:t>Render &amp; compare</a:t>
+            </a:r>
+          </a:p>
+          <a:p>
+            <a:pPr algn="ctr"/>
+            <a:r>
+              <a:rPr sz="1700" b="0">
+                <a:solidFill>
+                  <a:srgbClr val="FFFFFF"/>
+                </a:solidFill>
+              </a:rPr>
+              <a:t>with the photo, adjust</a:t>
+            </a:r>
+          </a:p>
+        </p:txBody>
+      </p:sp>
+      <p:pic>
+        <p:nvPicPr>
+          <p:cNvPr id="6" name="Picture 5" descr="depth_01.png"/>
+          <p:cNvPicPr>
+            <a:picLocks noChangeAspect="1"/>
+          </p:cNvPicPr>
+          <p:nvPr/>
+        </p:nvPicPr>
+        <p:blipFill>
+          <a:blip r:embed="rId2"/>
+          <a:stretch>
+            <a:fillRect/>
+          </a:stretch>
+        </p:blipFill>
+        <p:spPr>
+          <a:xfrm>
+            <a:off x="4846320" y="1959647"/>
+            <a:ext cx="6858000" cy="3761664"/>
+          </a:xfrm>
+          <a:prstGeom prst="rect">
+            <a:avLst/>
+          </a:prstGeom>
+        </p:spPr>
+      </p:pic>
+      <p:sp>
+        <p:nvSpPr>
+          <p:cNvPr id="7" name="TextBox 6"/>
+          <p:cNvSpPr txBox="1"/>
+          <p:nvPr/>
+        </p:nvSpPr>
+        <p:spPr>
+          <a:xfrm>
+            <a:off x="548640" y="5939028"/>
+            <a:ext cx="11155680" cy="411480"/>
+          </a:xfrm>
+          <a:prstGeom prst="rect">
+            <a:avLst/>
+          </a:prstGeom>
+          <a:noFill/>
+        </p:spPr>
+        <p:txBody>
+          <a:bodyPr wrap="square" anchor="t">
+            <a:spAutoFit/>
+          </a:bodyPr>
+          <a:lstStyle/>
+          <a:p>
+            <a:pPr algn="ctr">
+              <a:spcAft>
+                <a:spcPts val="200"/>
+              </a:spcAft>
+            </a:pPr>
+            <a:r>
+              <a:rPr sz="1800" b="0">
+                <a:solidFill>
+                  <a:srgbClr val="5A6577"/>
+                </a:solidFill>
+              </a:rPr>
+              <a:t>Optimised via differentiable rendering. Reported 0.35 mm, true 0.36 mm.</a:t>
+            </a:r>
+          </a:p>
+        </p:txBody>
+      </p:sp>
+    </p:spTree>
+  </p:cSld>
+  <p:clrMapOvr>
+    <a:masterClrMapping/>
+  </p:clrMapOvr>
+</p:sld>
+</file>
+
+<file path=ppt/slides/slide15.xml><?xml version="1.0" encoding="utf-8"?>
+<p:sld xmlns:a="http://schemas.openxmlformats.org/drawingml/2006/main" xmlns:p="http://schemas.openxmlformats.org/presentationml/2006/main" xmlns:r="http://schemas.openxmlformats.org/officeDocument/2006/relationships">
+  <p:cSld>
+    <p:spTree>
+      <p:nvGrpSpPr>
+        <p:cNvPr id="1" name=""/>
+        <p:cNvGrpSpPr/>
+        <p:nvPr/>
+      </p:nvGrpSpPr>
+      <p:grpSpPr/>
+      <p:sp>
+        <p:nvSpPr>
+          <p:cNvPr id="2" name="Title 1"/>
+          <p:cNvSpPr>
+            <a:spLocks noGrp="1"/>
+          </p:cNvSpPr>
+          <p:nvPr>
+            <p:ph type="title"/>
+          </p:nvPr>
+        </p:nvSpPr>
+        <p:spPr/>
+        <p:txBody>
+          <a:bodyPr/>
+          <a:lstStyle/>
+          <a:p>
+            <a:r>
               <a:rPr sz="2400"/>
               <a:t>Step 4: The Evidence Test (Our Key Idea)</a:t>
             </a:r>
@@ -14245,7 +15854,7 @@
 </p:sld>
 </file>
 
-<file path=ppt/slides/slide15.xml><?xml version="1.0" encoding="utf-8"?>
+<file path=ppt/slides/slide16.xml><?xml version="1.0" encoding="utf-8"?>
 <p:sld xmlns:a="http://schemas.openxmlformats.org/drawingml/2006/main" xmlns:p="http://schemas.openxmlformats.org/presentationml/2006/main" xmlns:r="http://schemas.openxmlformats.org/officeDocument/2006/relationships">
   <p:cSld>
     <p:spTree>
@@ -14794,7 +16403,213 @@
 </p:sld>
 </file>
 
-<file path=ppt/slides/slide16.xml><?xml version="1.0" encoding="utf-8"?>
+<file path=ppt/slides/slide17.xml><?xml version="1.0" encoding="utf-8"?>
+<p:sld xmlns:a="http://schemas.openxmlformats.org/drawingml/2006/main" xmlns:p="http://schemas.openxmlformats.org/presentationml/2006/main" xmlns:r="http://schemas.openxmlformats.org/officeDocument/2006/relationships">
+  <p:cSld>
+    <p:spTree>
+      <p:nvGrpSpPr>
+        <p:cNvPr id="1" name=""/>
+        <p:cNvGrpSpPr/>
+        <p:nvPr/>
+      </p:nvGrpSpPr>
+      <p:grpSpPr/>
+      <p:sp>
+        <p:nvSpPr>
+          <p:cNvPr id="2" name="Title 1"/>
+          <p:cNvSpPr>
+            <a:spLocks noGrp="1"/>
+          </p:cNvSpPr>
+          <p:nvPr>
+            <p:ph type="title"/>
+          </p:nvPr>
+        </p:nvSpPr>
+        <p:spPr/>
+        <p:txBody>
+          <a:bodyPr/>
+          <a:lstStyle/>
+          <a:p>
+            <a:r>
+              <a:rPr sz="2400"/>
+              <a:t>Our Data: Six Industrial Blade Designs</a:t>
+            </a:r>
+          </a:p>
+        </p:txBody>
+      </p:sp>
+      <p:pic>
+        <p:nvPicPr>
+          <p:cNvPr id="3" name="Picture 2" descr="cad6_blades.png"/>
+          <p:cNvPicPr>
+            <a:picLocks noChangeAspect="1"/>
+          </p:cNvPicPr>
+          <p:nvPr/>
+        </p:nvPicPr>
+        <p:blipFill>
+          <a:blip r:embed="rId2"/>
+          <a:stretch>
+            <a:fillRect/>
+          </a:stretch>
+        </p:blipFill>
+        <p:spPr>
+          <a:xfrm>
+            <a:off x="970357" y="1783080"/>
+            <a:ext cx="10220805" cy="2386584"/>
+          </a:xfrm>
+          <a:prstGeom prst="rect">
+            <a:avLst/>
+          </a:prstGeom>
+        </p:spPr>
+      </p:pic>
+      <p:sp>
+        <p:nvSpPr>
+          <p:cNvPr id="4" name="TextBox 3"/>
+          <p:cNvSpPr txBox="1"/>
+          <p:nvPr/>
+        </p:nvSpPr>
+        <p:spPr>
+          <a:xfrm>
+            <a:off x="548640" y="4334256"/>
+            <a:ext cx="5669280" cy="1975104"/>
+          </a:xfrm>
+          <a:prstGeom prst="rect">
+            <a:avLst/>
+          </a:prstGeom>
+          <a:noFill/>
+        </p:spPr>
+        <p:txBody>
+          <a:bodyPr wrap="square" anchor="t">
+            <a:spAutoFit/>
+          </a:bodyPr>
+          <a:lstStyle/>
+          <a:p>
+            <a:pPr algn="l">
+              <a:spcAft>
+                <a:spcPts val="800"/>
+              </a:spcAft>
+            </a:pPr>
+            <a:r>
+              <a:rPr sz="1700" b="0">
+                <a:solidFill>
+                  <a:srgbClr val="1F2937"/>
+                </a:solidFill>
+              </a:rPr>
+              <a:t>•  Your six STEP CAD models (airfoils 24–70 mm), with platform and root</a:t>
+            </a:r>
+          </a:p>
+          <a:p>
+            <a:pPr algn="l">
+              <a:spcAft>
+                <a:spcPts val="800"/>
+              </a:spcAft>
+            </a:pPr>
+            <a:r>
+              <a:rPr sz="1700" b="0">
+                <a:solidFill>
+                  <a:srgbClr val="1F2937"/>
+                </a:solidFill>
+              </a:rPr>
+              <a:t>•  456 cases: 30% visible dents, 15% hidden, 20% healthy, 15% stain, 10% dent + stain, 10% camera error</a:t>
+            </a:r>
+          </a:p>
+          <a:p>
+            <a:pPr algn="l">
+              <a:spcAft>
+                <a:spcPts val="800"/>
+              </a:spcAft>
+            </a:pPr>
+            <a:r>
+              <a:rPr sz="1700" b="0">
+                <a:solidFill>
+                  <a:srgbClr val="1F2937"/>
+                </a:solidFill>
+              </a:rPr>
+              <a:t>•  Real-world dent sizes: 0.1–1.0 mm deep, 1–5 mm radius</a:t>
+            </a:r>
+          </a:p>
+        </p:txBody>
+      </p:sp>
+      <p:sp>
+        <p:nvSpPr>
+          <p:cNvPr id="5" name="Rounded Rectangle 4"/>
+          <p:cNvSpPr/>
+          <p:nvPr/>
+        </p:nvSpPr>
+        <p:spPr>
+          <a:xfrm>
+            <a:off x="6492240" y="4416552"/>
+            <a:ext cx="5212080" cy="1563624"/>
+          </a:xfrm>
+          <a:prstGeom prst="roundRect">
+            <a:avLst/>
+          </a:prstGeom>
+          <a:solidFill>
+            <a:srgbClr val="F2F5FA"/>
+          </a:solidFill>
+          <a:ln>
+            <a:noFill/>
+          </a:ln>
+          <a:effectLst/>
+        </p:spPr>
+        <p:style>
+          <a:lnRef idx="1">
+            <a:schemeClr val="accent1"/>
+          </a:lnRef>
+          <a:fillRef idx="3">
+            <a:schemeClr val="accent1"/>
+          </a:fillRef>
+          <a:effectRef idx="2">
+            <a:schemeClr val="accent1"/>
+          </a:effectRef>
+          <a:fontRef idx="minor">
+            <a:schemeClr val="lt1"/>
+          </a:fontRef>
+        </p:style>
+        <p:txBody>
+          <a:bodyPr rtlCol="0" anchor="ctr" wrap="square"/>
+          <a:lstStyle/>
+          <a:p>
+            <a:pPr algn="ctr"/>
+            <a:r>
+              <a:rPr sz="1700" b="1">
+                <a:solidFill>
+                  <a:srgbClr val="1F2937"/>
+                </a:solidFill>
+              </a:rPr>
+              <a:t>A tougher test</a:t>
+            </a:r>
+          </a:p>
+          <a:p>
+            <a:pPr algn="ctr"/>
+            <a:r>
+              <a:rPr sz="1500" b="0">
+                <a:solidFill>
+                  <a:srgbClr val="1F2937"/>
+                </a:solidFill>
+              </a:rPr>
+              <a:t>The method was never trained or tuned on these designs.</a:t>
+            </a:r>
+          </a:p>
+          <a:p>
+            <a:pPr algn="ctr"/>
+            <a:r>
+              <a:rPr sz="1500" b="0">
+                <a:solidFill>
+                  <a:srgbClr val="1F2937"/>
+                </a:solidFill>
+              </a:rPr>
+              <a:t>Blades 1–2: develop the fix · 3–6: held out</a:t>
+            </a:r>
+          </a:p>
+        </p:txBody>
+      </p:sp>
+    </p:spTree>
+  </p:cSld>
+  <p:clrMapOvr>
+    <a:masterClrMapping/>
+  </p:clrMapOvr>
+</p:sld>
+</file>
+
+<file path=ppt/slides/slide18.xml><?xml version="1.0" encoding="utf-8"?>
 <p:sld xmlns:a="http://schemas.openxmlformats.org/drawingml/2006/main" xmlns:p="http://schemas.openxmlformats.org/presentationml/2006/main" xmlns:r="http://schemas.openxmlformats.org/officeDocument/2006/relationships">
   <p:cSld>
     <p:spTree>
@@ -14890,7 +16705,7 @@
 </p:sld>
 </file>
 
-<file path=ppt/slides/slide17.xml><?xml version="1.0" encoding="utf-8"?>
+<file path=ppt/slides/slide19.xml><?xml version="1.0" encoding="utf-8"?>
 <p:sld xmlns:a="http://schemas.openxmlformats.org/drawingml/2006/main" xmlns:p="http://schemas.openxmlformats.org/presentationml/2006/main" xmlns:r="http://schemas.openxmlformats.org/officeDocument/2006/relationships">
   <p:cSld>
     <p:spTree>
@@ -15004,7 +16819,7 @@
 </p:sld>
 </file>
 
-<file path=ppt/slides/slide18.xml><?xml version="1.0" encoding="utf-8"?>
+<file path=ppt/slides/slide20.xml><?xml version="1.0" encoding="utf-8"?>
 <p:sld xmlns:a="http://schemas.openxmlformats.org/drawingml/2006/main" xmlns:p="http://schemas.openxmlformats.org/presentationml/2006/main" xmlns:r="http://schemas.openxmlformats.org/officeDocument/2006/relationships">
   <p:cSld>
     <p:spTree>
@@ -15197,7 +17012,7 @@
 </p:sld>
 </file>
 
-<file path=ppt/slides/slide19.xml><?xml version="1.0" encoding="utf-8"?>
+<file path=ppt/slides/slide21.xml><?xml version="1.0" encoding="utf-8"?>
 <p:sld xmlns:a="http://schemas.openxmlformats.org/drawingml/2006/main" xmlns:p="http://schemas.openxmlformats.org/presentationml/2006/main" xmlns:r="http://schemas.openxmlformats.org/officeDocument/2006/relationships">
   <p:cSld>
     <p:spTree>
@@ -15326,7 +17141,287 @@
 </p:sld>
 </file>
 
-<file path=ppt/slides/slide20.xml><?xml version="1.0" encoding="utf-8"?>
+<file path=ppt/slides/slide22.xml><?xml version="1.0" encoding="utf-8"?>
+<p:sld xmlns:a="http://schemas.openxmlformats.org/drawingml/2006/main" xmlns:p="http://schemas.openxmlformats.org/presentationml/2006/main" xmlns:r="http://schemas.openxmlformats.org/officeDocument/2006/relationships">
+  <p:cSld>
+    <p:spTree>
+      <p:nvGrpSpPr>
+        <p:cNvPr id="1" name=""/>
+        <p:cNvGrpSpPr/>
+        <p:nvPr/>
+      </p:nvGrpSpPr>
+      <p:grpSpPr/>
+      <p:sp>
+        <p:nvSpPr>
+          <p:cNvPr id="2" name="Title 1"/>
+          <p:cNvSpPr>
+            <a:spLocks noGrp="1"/>
+          </p:cNvSpPr>
+          <p:nvPr>
+            <p:ph type="title"/>
+          </p:nvPr>
+        </p:nvSpPr>
+        <p:spPr/>
+        <p:txBody>
+          <a:bodyPr/>
+          <a:lstStyle/>
+          <a:p>
+            <a:r>
+              <a:rPr sz="2400"/>
+              <a:t>Industrial Blades: Before and After the Fix</a:t>
+            </a:r>
+          </a:p>
+        </p:txBody>
+      </p:sp>
+      <p:sp>
+        <p:nvSpPr>
+          <p:cNvPr id="3" name="TextBox 2"/>
+          <p:cNvSpPr txBox="1"/>
+          <p:nvPr/>
+        </p:nvSpPr>
+        <p:spPr>
+          <a:xfrm>
+            <a:off x="548640" y="1783080"/>
+            <a:ext cx="5486400" cy="329184"/>
+          </a:xfrm>
+          <a:prstGeom prst="rect">
+            <a:avLst/>
+          </a:prstGeom>
+          <a:noFill/>
+        </p:spPr>
+        <p:txBody>
+          <a:bodyPr wrap="square" anchor="t">
+            <a:spAutoFit/>
+          </a:bodyPr>
+          <a:lstStyle/>
+          <a:p>
+            <a:pPr algn="l">
+              <a:spcAft>
+                <a:spcPts val="200"/>
+              </a:spcAft>
+            </a:pPr>
+            <a:r>
+              <a:rPr sz="1600" b="1">
+                <a:solidFill>
+                  <a:srgbClr val="C62828"/>
+                </a:solidFill>
+              </a:rPr>
+              <a:t>Frozen v1</a:t>
+            </a:r>
+          </a:p>
+        </p:txBody>
+      </p:sp>
+      <p:sp>
+        <p:nvSpPr>
+          <p:cNvPr id="4" name="TextBox 3"/>
+          <p:cNvSpPr txBox="1"/>
+          <p:nvPr/>
+        </p:nvSpPr>
+        <p:spPr>
+          <a:xfrm>
+            <a:off x="6309360" y="1783080"/>
+            <a:ext cx="5486400" cy="329184"/>
+          </a:xfrm>
+          <a:prstGeom prst="rect">
+            <a:avLst/>
+          </a:prstGeom>
+          <a:noFill/>
+        </p:spPr>
+        <p:txBody>
+          <a:bodyPr wrap="square" anchor="t">
+            <a:spAutoFit/>
+          </a:bodyPr>
+          <a:lstStyle/>
+          <a:p>
+            <a:pPr algn="l">
+              <a:spcAft>
+                <a:spcPts val="200"/>
+              </a:spcAft>
+            </a:pPr>
+            <a:r>
+              <a:rPr sz="1600" b="1">
+                <a:solidFill>
+                  <a:srgbClr val="1A7F37"/>
+                </a:solidFill>
+              </a:rPr>
+              <a:t>v1.1 (fixed)</a:t>
+            </a:r>
+          </a:p>
+        </p:txBody>
+      </p:sp>
+      <p:pic>
+        <p:nvPicPr>
+          <p:cNvPr id="5" name="Picture 4" descr="fix_before.jpg"/>
+          <p:cNvPicPr>
+            <a:picLocks noChangeAspect="1"/>
+          </p:cNvPicPr>
+          <p:nvPr/>
+        </p:nvPicPr>
+        <p:blipFill>
+          <a:blip r:embed="rId2"/>
+          <a:stretch>
+            <a:fillRect/>
+          </a:stretch>
+        </p:blipFill>
+        <p:spPr>
+          <a:xfrm>
+            <a:off x="1177747" y="2153412"/>
+            <a:ext cx="4228185" cy="1316736"/>
+          </a:xfrm>
+          <a:prstGeom prst="rect">
+            <a:avLst/>
+          </a:prstGeom>
+        </p:spPr>
+      </p:pic>
+      <p:pic>
+        <p:nvPicPr>
+          <p:cNvPr id="6" name="Picture 5" descr="fix_after.jpg"/>
+          <p:cNvPicPr>
+            <a:picLocks noChangeAspect="1"/>
+          </p:cNvPicPr>
+          <p:nvPr/>
+        </p:nvPicPr>
+        <p:blipFill>
+          <a:blip r:embed="rId3"/>
+          <a:stretch>
+            <a:fillRect/>
+          </a:stretch>
+        </p:blipFill>
+        <p:spPr>
+          <a:xfrm>
+            <a:off x="6938467" y="2153412"/>
+            <a:ext cx="4228185" cy="1316736"/>
+          </a:xfrm>
+          <a:prstGeom prst="rect">
+            <a:avLst/>
+          </a:prstGeom>
+        </p:spPr>
+      </p:pic>
+      <p:pic>
+        <p:nvPicPr>
+          <p:cNvPr id="7" name="Picture 6" descr="fix2_before.jpg"/>
+          <p:cNvPicPr>
+            <a:picLocks noChangeAspect="1"/>
+          </p:cNvPicPr>
+          <p:nvPr/>
+        </p:nvPicPr>
+        <p:blipFill>
+          <a:blip r:embed="rId4"/>
+          <a:stretch>
+            <a:fillRect/>
+          </a:stretch>
+        </p:blipFill>
+        <p:spPr>
+          <a:xfrm>
+            <a:off x="1216152" y="3593592"/>
+            <a:ext cx="4151376" cy="1316736"/>
+          </a:xfrm>
+          <a:prstGeom prst="rect">
+            <a:avLst/>
+          </a:prstGeom>
+        </p:spPr>
+      </p:pic>
+      <p:pic>
+        <p:nvPicPr>
+          <p:cNvPr id="8" name="Picture 7" descr="fix2_after.jpg"/>
+          <p:cNvPicPr>
+            <a:picLocks noChangeAspect="1"/>
+          </p:cNvPicPr>
+          <p:nvPr/>
+        </p:nvPicPr>
+        <p:blipFill>
+          <a:blip r:embed="rId5"/>
+          <a:stretch>
+            <a:fillRect/>
+          </a:stretch>
+        </p:blipFill>
+        <p:spPr>
+          <a:xfrm>
+            <a:off x="6976872" y="3593592"/>
+            <a:ext cx="4151376" cy="1316736"/>
+          </a:xfrm>
+          <a:prstGeom prst="rect">
+            <a:avLst/>
+          </a:prstGeom>
+        </p:spPr>
+      </p:pic>
+      <p:sp>
+        <p:nvSpPr>
+          <p:cNvPr id="9" name="TextBox 8"/>
+          <p:cNvSpPr txBox="1"/>
+          <p:nvPr/>
+        </p:nvSpPr>
+        <p:spPr>
+          <a:xfrm>
+            <a:off x="548640" y="4992624"/>
+            <a:ext cx="11247120" cy="1234440"/>
+          </a:xfrm>
+          <a:prstGeom prst="rect">
+            <a:avLst/>
+          </a:prstGeom>
+          <a:noFill/>
+        </p:spPr>
+        <p:txBody>
+          <a:bodyPr wrap="square" anchor="t">
+            <a:spAutoFit/>
+          </a:bodyPr>
+          <a:lstStyle/>
+          <a:p>
+            <a:pPr algn="l">
+              <a:spcAft>
+                <a:spcPts val="800"/>
+              </a:spcAft>
+            </a:pPr>
+            <a:r>
+              <a:rPr sz="1600" b="0">
+                <a:solidFill>
+                  <a:srgbClr val="1F2937"/>
+                </a:solidFill>
+              </a:rPr>
+              <a:t>•  Top: healthy blade, camera moved: v1 invents a dent; v1.1 reports nothing.</a:t>
+            </a:r>
+          </a:p>
+          <a:p>
+            <a:pPr algn="l">
+              <a:spcAft>
+                <a:spcPts val="800"/>
+              </a:spcAft>
+            </a:pPr>
+            <a:r>
+              <a:rPr sz="1600" b="0">
+                <a:solidFill>
+                  <a:srgbClr val="1F2937"/>
+                </a:solidFill>
+              </a:rPr>
+              <a:t>•  Bottom: real dent: v1 is 37 mm off; v1.1 finds the right place.</a:t>
+            </a:r>
+          </a:p>
+          <a:p>
+            <a:pPr algn="l">
+              <a:spcAft>
+                <a:spcPts val="800"/>
+              </a:spcAft>
+            </a:pPr>
+            <a:r>
+              <a:rPr sz="1600" b="0">
+                <a:solidFill>
+                  <a:srgbClr val="1F2937"/>
+                </a:solidFill>
+              </a:rPr>
+              <a:t>•  Still open: on new designs depth is underestimated (median 60% of true, vs 89% on Rotor37).</a:t>
+            </a:r>
+          </a:p>
+        </p:txBody>
+      </p:sp>
+    </p:spTree>
+  </p:cSld>
+  <p:clrMapOvr>
+    <a:masterClrMapping/>
+  </p:clrMapOvr>
+</p:sld>
+</file>
+
+<file path=ppt/slides/slide23.xml><?xml version="1.0" encoding="utf-8"?>
 <p:sld xmlns:a="http://schemas.openxmlformats.org/drawingml/2006/main" xmlns:p="http://schemas.openxmlformats.org/presentationml/2006/main" xmlns:r="http://schemas.openxmlformats.org/officeDocument/2006/relationships">
   <p:cSld>
     <p:spTree>
@@ -15510,7 +17605,857 @@
 </p:sld>
 </file>
 
-<file path=ppt/slides/slide21.xml><?xml version="1.0" encoding="utf-8"?>
+<file path=ppt/slides/slide24.xml><?xml version="1.0" encoding="utf-8"?>
+<p:sld xmlns:a="http://schemas.openxmlformats.org/drawingml/2006/main" xmlns:p="http://schemas.openxmlformats.org/presentationml/2006/main" xmlns:r="http://schemas.openxmlformats.org/officeDocument/2006/relationships">
+  <p:cSld>
+    <p:spTree>
+      <p:nvGrpSpPr>
+        <p:cNvPr id="1" name=""/>
+        <p:cNvGrpSpPr/>
+        <p:nvPr/>
+      </p:nvGrpSpPr>
+      <p:grpSpPr/>
+      <p:sp>
+        <p:nvSpPr>
+          <p:cNvPr id="2" name="Title 1"/>
+          <p:cNvSpPr>
+            <a:spLocks noGrp="1"/>
+          </p:cNvSpPr>
+          <p:nvPr>
+            <p:ph type="title"/>
+          </p:nvPr>
+        </p:nvSpPr>
+        <p:spPr/>
+        <p:txBody>
+          <a:bodyPr/>
+          <a:lstStyle/>
+          <a:p>
+            <a:r>
+              <a:rPr sz="3000"/>
+              <a:t>From Synthetic to Real Data</a:t>
+            </a:r>
+          </a:p>
+        </p:txBody>
+      </p:sp>
+      <p:sp>
+        <p:nvSpPr>
+          <p:cNvPr id="3" name="Rounded Rectangle 2"/>
+          <p:cNvSpPr/>
+          <p:nvPr/>
+        </p:nvSpPr>
+        <p:spPr>
+          <a:xfrm>
+            <a:off x="365760" y="1947672"/>
+            <a:ext cx="1691640" cy="1316736"/>
+          </a:xfrm>
+          <a:prstGeom prst="roundRect">
+            <a:avLst/>
+          </a:prstGeom>
+          <a:solidFill>
+            <a:srgbClr val="5A6577"/>
+          </a:solidFill>
+          <a:ln>
+            <a:noFill/>
+          </a:ln>
+          <a:effectLst/>
+        </p:spPr>
+        <p:style>
+          <a:lnRef idx="1">
+            <a:schemeClr val="accent1"/>
+          </a:lnRef>
+          <a:fillRef idx="3">
+            <a:schemeClr val="accent1"/>
+          </a:fillRef>
+          <a:effectRef idx="2">
+            <a:schemeClr val="accent1"/>
+          </a:effectRef>
+          <a:fontRef idx="minor">
+            <a:schemeClr val="lt1"/>
+          </a:fontRef>
+        </p:style>
+        <p:txBody>
+          <a:bodyPr rtlCol="0" anchor="ctr" wrap="square"/>
+          <a:lstStyle/>
+          <a:p>
+            <a:pPr algn="ctr"/>
+            <a:r>
+              <a:rPr sz="1500" b="1">
+                <a:solidFill>
+                  <a:srgbClr val="FFFFFF"/>
+                </a:solidFill>
+              </a:rPr>
+              <a:t>Synthetic</a:t>
+            </a:r>
+          </a:p>
+          <a:p>
+            <a:pPr algn="ctr"/>
+            <a:r>
+              <a:rPr sz="1300" b="0">
+                <a:solidFill>
+                  <a:srgbClr val="FFFFFF"/>
+                </a:solidFill>
+              </a:rPr>
+              <a:t>rendered blades, exact truth</a:t>
+            </a:r>
+          </a:p>
+        </p:txBody>
+      </p:sp>
+      <p:sp>
+        <p:nvSpPr>
+          <p:cNvPr id="4" name="Right Arrow 3"/>
+          <p:cNvSpPr/>
+          <p:nvPr/>
+        </p:nvSpPr>
+        <p:spPr>
+          <a:xfrm>
+            <a:off x="2075688" y="2441448"/>
+            <a:ext cx="201168" cy="263347"/>
+          </a:xfrm>
+          <a:prstGeom prst="rightArrow">
+            <a:avLst/>
+          </a:prstGeom>
+          <a:solidFill>
+            <a:srgbClr val="5A6577"/>
+          </a:solidFill>
+          <a:ln>
+            <a:noFill/>
+          </a:ln>
+          <a:effectLst/>
+        </p:spPr>
+        <p:style>
+          <a:lnRef idx="1">
+            <a:schemeClr val="accent1"/>
+          </a:lnRef>
+          <a:fillRef idx="3">
+            <a:schemeClr val="accent1"/>
+          </a:fillRef>
+          <a:effectRef idx="2">
+            <a:schemeClr val="accent1"/>
+          </a:effectRef>
+          <a:fontRef idx="minor">
+            <a:schemeClr val="lt1"/>
+          </a:fontRef>
+        </p:style>
+        <p:txBody>
+          <a:bodyPr rtlCol="0" anchor="ctr"/>
+          <a:lstStyle/>
+          <a:p>
+            <a:pPr algn="ctr"/>
+          </a:p>
+        </p:txBody>
+      </p:sp>
+      <p:sp>
+        <p:nvSpPr>
+          <p:cNvPr id="5" name="Rounded Rectangle 4"/>
+          <p:cNvSpPr/>
+          <p:nvPr/>
+        </p:nvSpPr>
+        <p:spPr>
+          <a:xfrm>
+            <a:off x="2286000" y="1947672"/>
+            <a:ext cx="1691640" cy="1316736"/>
+          </a:xfrm>
+          <a:prstGeom prst="roundRect">
+            <a:avLst/>
+          </a:prstGeom>
+          <a:solidFill>
+            <a:srgbClr val="0047BB"/>
+          </a:solidFill>
+          <a:ln>
+            <a:noFill/>
+          </a:ln>
+          <a:effectLst/>
+        </p:spPr>
+        <p:style>
+          <a:lnRef idx="1">
+            <a:schemeClr val="accent1"/>
+          </a:lnRef>
+          <a:fillRef idx="3">
+            <a:schemeClr val="accent1"/>
+          </a:fillRef>
+          <a:effectRef idx="2">
+            <a:schemeClr val="accent1"/>
+          </a:effectRef>
+          <a:fontRef idx="minor">
+            <a:schemeClr val="lt1"/>
+          </a:fontRef>
+        </p:style>
+        <p:txBody>
+          <a:bodyPr rtlCol="0" anchor="ctr" wrap="square"/>
+          <a:lstStyle/>
+          <a:p>
+            <a:pPr algn="ctr"/>
+            <a:r>
+              <a:rPr sz="1500" b="1">
+                <a:solidFill>
+                  <a:srgbClr val="FFFFFF"/>
+                </a:solidFill>
+              </a:rPr>
+              <a:t>Compare to healthy</a:t>
+            </a:r>
+          </a:p>
+          <a:p>
+            <a:pPr algn="ctr"/>
+            <a:r>
+              <a:rPr sz="1300" b="0">
+                <a:solidFill>
+                  <a:srgbClr val="FFFFFF"/>
+                </a:solidFill>
+              </a:rPr>
+              <a:t>appearance errors cancel</a:t>
+            </a:r>
+          </a:p>
+        </p:txBody>
+      </p:sp>
+      <p:sp>
+        <p:nvSpPr>
+          <p:cNvPr id="6" name="Right Arrow 5"/>
+          <p:cNvSpPr/>
+          <p:nvPr/>
+        </p:nvSpPr>
+        <p:spPr>
+          <a:xfrm>
+            <a:off x="3995928" y="2441448"/>
+            <a:ext cx="201168" cy="263347"/>
+          </a:xfrm>
+          <a:prstGeom prst="rightArrow">
+            <a:avLst/>
+          </a:prstGeom>
+          <a:solidFill>
+            <a:srgbClr val="5A6577"/>
+          </a:solidFill>
+          <a:ln>
+            <a:noFill/>
+          </a:ln>
+          <a:effectLst/>
+        </p:spPr>
+        <p:style>
+          <a:lnRef idx="1">
+            <a:schemeClr val="accent1"/>
+          </a:lnRef>
+          <a:fillRef idx="3">
+            <a:schemeClr val="accent1"/>
+          </a:fillRef>
+          <a:effectRef idx="2">
+            <a:schemeClr val="accent1"/>
+          </a:effectRef>
+          <a:fontRef idx="minor">
+            <a:schemeClr val="lt1"/>
+          </a:fontRef>
+        </p:style>
+        <p:txBody>
+          <a:bodyPr rtlCol="0" anchor="ctr"/>
+          <a:lstStyle/>
+          <a:p>
+            <a:pPr algn="ctr"/>
+          </a:p>
+        </p:txBody>
+      </p:sp>
+      <p:sp>
+        <p:nvSpPr>
+          <p:cNvPr id="7" name="Rounded Rectangle 6"/>
+          <p:cNvSpPr/>
+          <p:nvPr/>
+        </p:nvSpPr>
+        <p:spPr>
+          <a:xfrm>
+            <a:off x="4206240" y="1947672"/>
+            <a:ext cx="1691640" cy="1316736"/>
+          </a:xfrm>
+          <a:prstGeom prst="roundRect">
+            <a:avLst/>
+          </a:prstGeom>
+          <a:solidFill>
+            <a:srgbClr val="0047BB"/>
+          </a:solidFill>
+          <a:ln>
+            <a:noFill/>
+          </a:ln>
+          <a:effectLst/>
+        </p:spPr>
+        <p:style>
+          <a:lnRef idx="1">
+            <a:schemeClr val="accent1"/>
+          </a:lnRef>
+          <a:fillRef idx="3">
+            <a:schemeClr val="accent1"/>
+          </a:fillRef>
+          <a:effectRef idx="2">
+            <a:schemeClr val="accent1"/>
+          </a:effectRef>
+          <a:fontRef idx="minor">
+            <a:schemeClr val="lt1"/>
+          </a:fontRef>
+        </p:style>
+        <p:txBody>
+          <a:bodyPr rtlCol="0" anchor="ctr" wrap="square"/>
+          <a:lstStyle/>
+          <a:p>
+            <a:pPr algn="ctr"/>
+            <a:r>
+              <a:rPr sz="1500" b="1">
+                <a:solidFill>
+                  <a:srgbClr val="FFFFFF"/>
+                </a:solidFill>
+              </a:rPr>
+              <a:t>Correction follows camera</a:t>
+            </a:r>
+          </a:p>
+          <a:p>
+            <a:pPr algn="ctr"/>
+            <a:r>
+              <a:rPr sz="1300" b="0">
+                <a:solidFill>
+                  <a:srgbClr val="FFFFFF"/>
+                </a:solidFill>
+              </a:rPr>
+              <a:t>v1.1: survives camera drift</a:t>
+            </a:r>
+          </a:p>
+        </p:txBody>
+      </p:sp>
+      <p:sp>
+        <p:nvSpPr>
+          <p:cNvPr id="8" name="Right Arrow 7"/>
+          <p:cNvSpPr/>
+          <p:nvPr/>
+        </p:nvSpPr>
+        <p:spPr>
+          <a:xfrm>
+            <a:off x="5916168" y="2441448"/>
+            <a:ext cx="201168" cy="263347"/>
+          </a:xfrm>
+          <a:prstGeom prst="rightArrow">
+            <a:avLst/>
+          </a:prstGeom>
+          <a:solidFill>
+            <a:srgbClr val="5A6577"/>
+          </a:solidFill>
+          <a:ln>
+            <a:noFill/>
+          </a:ln>
+          <a:effectLst/>
+        </p:spPr>
+        <p:style>
+          <a:lnRef idx="1">
+            <a:schemeClr val="accent1"/>
+          </a:lnRef>
+          <a:fillRef idx="3">
+            <a:schemeClr val="accent1"/>
+          </a:fillRef>
+          <a:effectRef idx="2">
+            <a:schemeClr val="accent1"/>
+          </a:effectRef>
+          <a:fontRef idx="minor">
+            <a:schemeClr val="lt1"/>
+          </a:fontRef>
+        </p:style>
+        <p:txBody>
+          <a:bodyPr rtlCol="0" anchor="ctr"/>
+          <a:lstStyle/>
+          <a:p>
+            <a:pPr algn="ctr"/>
+          </a:p>
+        </p:txBody>
+      </p:sp>
+      <p:sp>
+        <p:nvSpPr>
+          <p:cNvPr id="9" name="Rounded Rectangle 8"/>
+          <p:cNvSpPr/>
+          <p:nvPr/>
+        </p:nvSpPr>
+        <p:spPr>
+          <a:xfrm>
+            <a:off x="6126480" y="1947672"/>
+            <a:ext cx="1691640" cy="1316736"/>
+          </a:xfrm>
+          <a:prstGeom prst="roundRect">
+            <a:avLst/>
+          </a:prstGeom>
+          <a:solidFill>
+            <a:srgbClr val="0047BB"/>
+          </a:solidFill>
+          <a:ln>
+            <a:noFill/>
+          </a:ln>
+          <a:effectLst/>
+        </p:spPr>
+        <p:style>
+          <a:lnRef idx="1">
+            <a:schemeClr val="accent1"/>
+          </a:lnRef>
+          <a:fillRef idx="3">
+            <a:schemeClr val="accent1"/>
+          </a:fillRef>
+          <a:effectRef idx="2">
+            <a:schemeClr val="accent1"/>
+          </a:effectRef>
+          <a:fontRef idx="minor">
+            <a:schemeClr val="lt1"/>
+          </a:fontRef>
+        </p:style>
+        <p:txBody>
+          <a:bodyPr rtlCol="0" anchor="ctr" wrap="square"/>
+          <a:lstStyle/>
+          <a:p>
+            <a:pPr algn="ctr"/>
+            <a:r>
+              <a:rPr sz="1500" b="1">
+                <a:solidFill>
+                  <a:srgbClr val="FFFFFF"/>
+                </a:solidFill>
+              </a:rPr>
+              <a:t>Calibrate on negatives</a:t>
+            </a:r>
+          </a:p>
+          <a:p>
+            <a:pPr algn="ctr"/>
+            <a:r>
+              <a:rPr sz="1300" b="0">
+                <a:solidFill>
+                  <a:srgbClr val="FFFFFF"/>
+                </a:solidFill>
+              </a:rPr>
+              <a:t>threshold set on data</a:t>
+            </a:r>
+          </a:p>
+        </p:txBody>
+      </p:sp>
+      <p:sp>
+        <p:nvSpPr>
+          <p:cNvPr id="10" name="Right Arrow 9"/>
+          <p:cNvSpPr/>
+          <p:nvPr/>
+        </p:nvSpPr>
+        <p:spPr>
+          <a:xfrm>
+            <a:off x="7836408" y="2441448"/>
+            <a:ext cx="201168" cy="263347"/>
+          </a:xfrm>
+          <a:prstGeom prst="rightArrow">
+            <a:avLst/>
+          </a:prstGeom>
+          <a:solidFill>
+            <a:srgbClr val="5A6577"/>
+          </a:solidFill>
+          <a:ln>
+            <a:noFill/>
+          </a:ln>
+          <a:effectLst/>
+        </p:spPr>
+        <p:style>
+          <a:lnRef idx="1">
+            <a:schemeClr val="accent1"/>
+          </a:lnRef>
+          <a:fillRef idx="3">
+            <a:schemeClr val="accent1"/>
+          </a:fillRef>
+          <a:effectRef idx="2">
+            <a:schemeClr val="accent1"/>
+          </a:effectRef>
+          <a:fontRef idx="minor">
+            <a:schemeClr val="lt1"/>
+          </a:fontRef>
+        </p:style>
+        <p:txBody>
+          <a:bodyPr rtlCol="0" anchor="ctr"/>
+          <a:lstStyle/>
+          <a:p>
+            <a:pPr algn="ctr"/>
+          </a:p>
+        </p:txBody>
+      </p:sp>
+      <p:sp>
+        <p:nvSpPr>
+          <p:cNvPr id="11" name="Rounded Rectangle 10"/>
+          <p:cNvSpPr/>
+          <p:nvPr/>
+        </p:nvSpPr>
+        <p:spPr>
+          <a:xfrm>
+            <a:off x="8046720" y="1947672"/>
+            <a:ext cx="1691640" cy="1316736"/>
+          </a:xfrm>
+          <a:prstGeom prst="roundRect">
+            <a:avLst/>
+          </a:prstGeom>
+          <a:solidFill>
+            <a:srgbClr val="E8833A"/>
+          </a:solidFill>
+          <a:ln>
+            <a:noFill/>
+          </a:ln>
+          <a:effectLst/>
+        </p:spPr>
+        <p:style>
+          <a:lnRef idx="1">
+            <a:schemeClr val="accent1"/>
+          </a:lnRef>
+          <a:fillRef idx="3">
+            <a:schemeClr val="accent1"/>
+          </a:fillRef>
+          <a:effectRef idx="2">
+            <a:schemeClr val="accent1"/>
+          </a:effectRef>
+          <a:fontRef idx="minor">
+            <a:schemeClr val="lt1"/>
+          </a:fontRef>
+        </p:style>
+        <p:txBody>
+          <a:bodyPr rtlCol="0" anchor="ctr" wrap="square"/>
+          <a:lstStyle/>
+          <a:p>
+            <a:pPr algn="ctr"/>
+            <a:r>
+              <a:rPr sz="1500" b="1">
+                <a:solidFill>
+                  <a:srgbClr val="FFFFFF"/>
+                </a:solidFill>
+              </a:rPr>
+              <a:t>New designs</a:t>
+            </a:r>
+          </a:p>
+          <a:p>
+            <a:pPr algn="ctr"/>
+            <a:r>
+              <a:rPr sz="1300" b="0">
+                <a:solidFill>
+                  <a:srgbClr val="FFFFFF"/>
+                </a:solidFill>
+              </a:rPr>
+              <a:t>6 industrial blades: detection transfers</a:t>
+            </a:r>
+          </a:p>
+        </p:txBody>
+      </p:sp>
+      <p:sp>
+        <p:nvSpPr>
+          <p:cNvPr id="12" name="Right Arrow 11"/>
+          <p:cNvSpPr/>
+          <p:nvPr/>
+        </p:nvSpPr>
+        <p:spPr>
+          <a:xfrm>
+            <a:off x="9756648" y="2441448"/>
+            <a:ext cx="201168" cy="263347"/>
+          </a:xfrm>
+          <a:prstGeom prst="rightArrow">
+            <a:avLst/>
+          </a:prstGeom>
+          <a:solidFill>
+            <a:srgbClr val="5A6577"/>
+          </a:solidFill>
+          <a:ln>
+            <a:noFill/>
+          </a:ln>
+          <a:effectLst/>
+        </p:spPr>
+        <p:style>
+          <a:lnRef idx="1">
+            <a:schemeClr val="accent1"/>
+          </a:lnRef>
+          <a:fillRef idx="3">
+            <a:schemeClr val="accent1"/>
+          </a:fillRef>
+          <a:effectRef idx="2">
+            <a:schemeClr val="accent1"/>
+          </a:effectRef>
+          <a:fontRef idx="minor">
+            <a:schemeClr val="lt1"/>
+          </a:fontRef>
+        </p:style>
+        <p:txBody>
+          <a:bodyPr rtlCol="0" anchor="ctr"/>
+          <a:lstStyle/>
+          <a:p>
+            <a:pPr algn="ctr"/>
+          </a:p>
+        </p:txBody>
+      </p:sp>
+      <p:sp>
+        <p:nvSpPr>
+          <p:cNvPr id="13" name="Rounded Rectangle 12"/>
+          <p:cNvSpPr/>
+          <p:nvPr/>
+        </p:nvSpPr>
+        <p:spPr>
+          <a:xfrm>
+            <a:off x="9966960" y="1947672"/>
+            <a:ext cx="1691640" cy="1316736"/>
+          </a:xfrm>
+          <a:prstGeom prst="roundRect">
+            <a:avLst/>
+          </a:prstGeom>
+          <a:solidFill>
+            <a:srgbClr val="1A7F37"/>
+          </a:solidFill>
+          <a:ln>
+            <a:noFill/>
+          </a:ln>
+          <a:effectLst/>
+        </p:spPr>
+        <p:style>
+          <a:lnRef idx="1">
+            <a:schemeClr val="accent1"/>
+          </a:lnRef>
+          <a:fillRef idx="3">
+            <a:schemeClr val="accent1"/>
+          </a:fillRef>
+          <a:effectRef idx="2">
+            <a:schemeClr val="accent1"/>
+          </a:effectRef>
+          <a:fontRef idx="minor">
+            <a:schemeClr val="lt1"/>
+          </a:fontRef>
+        </p:style>
+        <p:txBody>
+          <a:bodyPr rtlCol="0" anchor="ctr" wrap="square"/>
+          <a:lstStyle/>
+          <a:p>
+            <a:pPr algn="ctr"/>
+            <a:r>
+              <a:rPr sz="1500" b="1">
+                <a:solidFill>
+                  <a:srgbClr val="FFFFFF"/>
+                </a:solidFill>
+              </a:rPr>
+              <a:t>Real blade</a:t>
+            </a:r>
+          </a:p>
+          <a:p>
+            <a:pPr algn="ctr"/>
+            <a:r>
+              <a:rPr sz="1300" b="0">
+                <a:solidFill>
+                  <a:srgbClr val="FFFFFF"/>
+                </a:solidFill>
+              </a:rPr>
+              <a:t>printed, dented, scanned (next)</a:t>
+            </a:r>
+          </a:p>
+        </p:txBody>
+      </p:sp>
+      <p:sp>
+        <p:nvSpPr>
+          <p:cNvPr id="14" name="TextBox 13"/>
+          <p:cNvSpPr txBox="1"/>
+          <p:nvPr/>
+        </p:nvSpPr>
+        <p:spPr>
+          <a:xfrm>
+            <a:off x="548640" y="3593592"/>
+            <a:ext cx="5486400" cy="2468880"/>
+          </a:xfrm>
+          <a:prstGeom prst="rect">
+            <a:avLst/>
+          </a:prstGeom>
+          <a:noFill/>
+        </p:spPr>
+        <p:txBody>
+          <a:bodyPr wrap="square" anchor="t">
+            <a:spAutoFit/>
+          </a:bodyPr>
+          <a:lstStyle/>
+          <a:p>
+            <a:pPr algn="l">
+              <a:spcAft>
+                <a:spcPts val="800"/>
+              </a:spcAft>
+            </a:pPr>
+            <a:r>
+              <a:rPr sz="1700" b="0">
+                <a:solidFill>
+                  <a:srgbClr val="1F2937"/>
+                </a:solidFill>
+              </a:rPr>
+              <a:t>•  Real scanned objects (SiM3D, ICCV 2025): not working yet (separation 0.54)</a:t>
+            </a:r>
+          </a:p>
+          <a:p>
+            <a:pPr algn="l">
+              <a:spcAft>
+                <a:spcPts val="800"/>
+              </a:spcAft>
+            </a:pPr>
+            <a:r>
+              <a:rPr sz="1700" b="0">
+                <a:solidFill>
+                  <a:srgbClr val="1F2937"/>
+                </a:solidFill>
+              </a:rPr>
+              <a:t>•  Why: healthy and damaged photos 4–18 px apart; textured wood</a:t>
+            </a:r>
+          </a:p>
+          <a:p>
+            <a:pPr algn="l">
+              <a:spcAft>
+                <a:spcPts val="800"/>
+              </a:spcAft>
+            </a:pPr>
+            <a:r>
+              <a:rPr sz="1700" b="0">
+                <a:solidFill>
+                  <a:srgbClr val="1F2937"/>
+                </a:solidFill>
+              </a:rPr>
+              <a:t>•  Plan: print industrial blade 5 at 2×, dent it, marker-based camera poses, scanner truth</a:t>
+            </a:r>
+          </a:p>
+        </p:txBody>
+      </p:sp>
+      <p:pic>
+        <p:nvPicPr>
+          <p:cNvPr id="15" name="Picture 14" descr="s8_photo.png"/>
+          <p:cNvPicPr>
+            <a:picLocks noChangeAspect="1"/>
+          </p:cNvPicPr>
+          <p:nvPr/>
+        </p:nvPicPr>
+        <p:blipFill>
+          <a:blip r:embed="rId2"/>
+          <a:stretch>
+            <a:fillRect/>
+          </a:stretch>
+        </p:blipFill>
+        <p:spPr>
+          <a:xfrm>
+            <a:off x="6532710" y="3511296"/>
+            <a:ext cx="1930739" cy="2633472"/>
+          </a:xfrm>
+          <a:prstGeom prst="rect">
+            <a:avLst/>
+          </a:prstGeom>
+        </p:spPr>
+      </p:pic>
+      <p:sp>
+        <p:nvSpPr>
+          <p:cNvPr id="16" name="Right Arrow 15"/>
+          <p:cNvSpPr/>
+          <p:nvPr/>
+        </p:nvSpPr>
+        <p:spPr>
+          <a:xfrm>
+            <a:off x="8732520" y="4663440"/>
+            <a:ext cx="502920" cy="329184"/>
+          </a:xfrm>
+          <a:prstGeom prst="rightArrow">
+            <a:avLst/>
+          </a:prstGeom>
+          <a:solidFill>
+            <a:srgbClr val="5A6577"/>
+          </a:solidFill>
+          <a:ln>
+            <a:noFill/>
+          </a:ln>
+          <a:effectLst/>
+        </p:spPr>
+        <p:style>
+          <a:lnRef idx="1">
+            <a:schemeClr val="accent1"/>
+          </a:lnRef>
+          <a:fillRef idx="3">
+            <a:schemeClr val="accent1"/>
+          </a:fillRef>
+          <a:effectRef idx="2">
+            <a:schemeClr val="accent1"/>
+          </a:effectRef>
+          <a:fontRef idx="minor">
+            <a:schemeClr val="lt1"/>
+          </a:fontRef>
+        </p:style>
+        <p:txBody>
+          <a:bodyPr rtlCol="0" anchor="ctr"/>
+          <a:lstStyle/>
+          <a:p>
+            <a:pPr algn="ctr"/>
+          </a:p>
+        </p:txBody>
+      </p:sp>
+      <p:sp>
+        <p:nvSpPr>
+          <p:cNvPr id="17" name="Rounded Rectangle 16"/>
+          <p:cNvSpPr/>
+          <p:nvPr/>
+        </p:nvSpPr>
+        <p:spPr>
+          <a:xfrm>
+            <a:off x="9372600" y="3511296"/>
+            <a:ext cx="2377440" cy="2633472"/>
+          </a:xfrm>
+          <a:prstGeom prst="roundRect">
+            <a:avLst/>
+          </a:prstGeom>
+          <a:solidFill>
+            <a:srgbClr val="F2F5FA"/>
+          </a:solidFill>
+          <a:ln w="19050">
+            <a:solidFill>
+              <a:srgbClr val="5A6577"/>
+            </a:solidFill>
+          </a:ln>
+          <a:effectLst/>
+        </p:spPr>
+        <p:style>
+          <a:lnRef idx="1">
+            <a:schemeClr val="accent1"/>
+          </a:lnRef>
+          <a:fillRef idx="3">
+            <a:schemeClr val="accent1"/>
+          </a:fillRef>
+          <a:effectRef idx="2">
+            <a:schemeClr val="accent1"/>
+          </a:effectRef>
+          <a:fontRef idx="minor">
+            <a:schemeClr val="lt1"/>
+          </a:fontRef>
+        </p:style>
+        <p:txBody>
+          <a:bodyPr rtlCol="0" anchor="ctr" wrap="square"/>
+          <a:lstStyle/>
+          <a:p>
+            <a:pPr algn="ctr"/>
+            <a:r>
+              <a:rPr sz="2000" b="1">
+                <a:solidFill>
+                  <a:srgbClr val="5A6577"/>
+                </a:solidFill>
+              </a:rPr>
+              <a:t>?</a:t>
+            </a:r>
+          </a:p>
+          <a:p>
+            <a:pPr algn="ctr"/>
+            <a:r>
+              <a:rPr sz="1800" b="0">
+                <a:solidFill>
+                  <a:srgbClr val="5A6577"/>
+                </a:solidFill>
+              </a:rPr>
+              <a:t>real printed</a:t>
+            </a:r>
+          </a:p>
+          <a:p>
+            <a:pPr algn="ctr"/>
+            <a:r>
+              <a:rPr sz="1800" b="0">
+                <a:solidFill>
+                  <a:srgbClr val="5A6577"/>
+                </a:solidFill>
+              </a:rPr>
+              <a:t>blade</a:t>
+            </a:r>
+          </a:p>
+        </p:txBody>
+      </p:sp>
+    </p:spTree>
+  </p:cSld>
+  <p:clrMapOvr>
+    <a:masterClrMapping/>
+  </p:clrMapOvr>
+</p:sld>
+</file>
+
+<file path=ppt/slides/slide25.xml><?xml version="1.0" encoding="utf-8"?>
 <p:sld xmlns:a="http://schemas.openxmlformats.org/drawingml/2006/main" xmlns:p="http://schemas.openxmlformats.org/presentationml/2006/main" xmlns:r="http://schemas.openxmlformats.org/officeDocument/2006/relationships">
   <p:cSld>
     <p:spTree>
@@ -15800,7 +18745,7 @@
 </p:sld>
 </file>
 
-<file path=ppt/slides/slide22.xml><?xml version="1.0" encoding="utf-8"?>
+<file path=ppt/slides/slide26.xml><?xml version="1.0" encoding="utf-8"?>
 <p:sld xmlns:a="http://schemas.openxmlformats.org/drawingml/2006/main" xmlns:p="http://schemas.openxmlformats.org/presentationml/2006/main" xmlns:r="http://schemas.openxmlformats.org/officeDocument/2006/relationships">
   <p:cSld>
     <p:spTree>
@@ -15910,7 +18855,7 @@
                   <a:srgbClr val="1F2937"/>
                 </a:solidFill>
               </a:rPr>
-              <a:t>•  It generalises to new blade designs (after a fix)</a:t>
+              <a:t>•  Finds damage on new blade designs (after a fix); depth there still ~40% low</a:t>
             </a:r>
           </a:p>
           <a:p>
@@ -15962,7 +18907,192 @@
 </p:sld>
 </file>
 
-<file path=ppt/slides/slide23.xml><?xml version="1.0" encoding="utf-8"?>
+<file path=ppt/slides/slide27.xml><?xml version="1.0" encoding="utf-8"?>
+<p:sld xmlns:a="http://schemas.openxmlformats.org/drawingml/2006/main" xmlns:p="http://schemas.openxmlformats.org/presentationml/2006/main" xmlns:r="http://schemas.openxmlformats.org/officeDocument/2006/relationships">
+  <p:cSld>
+    <p:spTree>
+      <p:nvGrpSpPr>
+        <p:cNvPr id="1" name=""/>
+        <p:cNvGrpSpPr/>
+        <p:nvPr/>
+      </p:nvGrpSpPr>
+      <p:grpSpPr/>
+      <p:sp>
+        <p:nvSpPr>
+          <p:cNvPr id="2" name="Title 1"/>
+          <p:cNvSpPr>
+            <a:spLocks noGrp="1"/>
+          </p:cNvSpPr>
+          <p:nvPr>
+            <p:ph type="title"/>
+          </p:nvPr>
+        </p:nvSpPr>
+        <p:spPr/>
+        <p:txBody>
+          <a:bodyPr/>
+          <a:lstStyle/>
+          <a:p>
+            <a:r>
+              <a:rPr sz="2400"/>
+              <a:t>3D Demo: Actual Damage vs Model Prediction</a:t>
+            </a:r>
+          </a:p>
+        </p:txBody>
+      </p:sp>
+      <p:pic>
+        <p:nvPicPr>
+          <p:cNvPr id="3" name="Picture 2" descr="viewer_ind.png"/>
+          <p:cNvPicPr>
+            <a:picLocks noChangeAspect="1"/>
+          </p:cNvPicPr>
+          <p:nvPr/>
+        </p:nvPicPr>
+        <p:blipFill>
+          <a:blip r:embed="rId2"/>
+          <a:stretch>
+            <a:fillRect/>
+          </a:stretch>
+        </p:blipFill>
+        <p:spPr>
+          <a:xfrm>
+            <a:off x="715571" y="1783080"/>
+            <a:ext cx="6889897" cy="4114800"/>
+          </a:xfrm>
+          <a:prstGeom prst="rect">
+            <a:avLst/>
+          </a:prstGeom>
+        </p:spPr>
+      </p:pic>
+      <p:sp>
+        <p:nvSpPr>
+          <p:cNvPr id="4" name="TextBox 3"/>
+          <p:cNvSpPr txBox="1"/>
+          <p:nvPr/>
+        </p:nvSpPr>
+        <p:spPr>
+          <a:xfrm>
+            <a:off x="8138160" y="1947672"/>
+            <a:ext cx="3657600" cy="2962656"/>
+          </a:xfrm>
+          <a:prstGeom prst="rect">
+            <a:avLst/>
+          </a:prstGeom>
+          <a:noFill/>
+        </p:spPr>
+        <p:txBody>
+          <a:bodyPr wrap="square" anchor="t">
+            <a:spAutoFit/>
+          </a:bodyPr>
+          <a:lstStyle/>
+          <a:p>
+            <a:pPr algn="l">
+              <a:spcAft>
+                <a:spcPts val="800"/>
+              </a:spcAft>
+            </a:pPr>
+            <a:r>
+              <a:rPr sz="1600" b="0">
+                <a:solidFill>
+                  <a:srgbClr val="1F2937"/>
+                </a:solidFill>
+              </a:rPr>
+              <a:t>•  Rotate the blade 360°</a:t>
+            </a:r>
+          </a:p>
+          <a:p>
+            <a:pPr algn="l">
+              <a:spcAft>
+                <a:spcPts val="800"/>
+              </a:spcAft>
+            </a:pPr>
+            <a:r>
+              <a:rPr sz="1600" b="0">
+                <a:solidFill>
+                  <a:srgbClr val="1F2937"/>
+                </a:solidFill>
+              </a:rPr>
+              <a:t>•  Switch: healthy · actual damage · model prediction · old model</a:t>
+            </a:r>
+          </a:p>
+          <a:p>
+            <a:pPr algn="l">
+              <a:spcAft>
+                <a:spcPts val="800"/>
+              </a:spcAft>
+            </a:pPr>
+            <a:r>
+              <a:rPr sz="1600" b="0">
+                <a:solidFill>
+                  <a:srgbClr val="1F2937"/>
+                </a:solidFill>
+              </a:rPr>
+              <a:t>•  Side by side: truth (left) vs model (right)</a:t>
+            </a:r>
+          </a:p>
+          <a:p>
+            <a:pPr algn="l">
+              <a:spcAft>
+                <a:spcPts val="800"/>
+              </a:spcAft>
+            </a:pPr>
+            <a:r>
+              <a:rPr sz="1600" b="0">
+                <a:solidFill>
+                  <a:srgbClr val="1F2937"/>
+                </a:solidFill>
+              </a:rPr>
+              <a:t>•  Rotor37 and industrial blades</a:t>
+            </a:r>
+          </a:p>
+        </p:txBody>
+      </p:sp>
+      <p:sp>
+        <p:nvSpPr>
+          <p:cNvPr id="5" name="TextBox 4"/>
+          <p:cNvSpPr txBox="1"/>
+          <p:nvPr/>
+        </p:nvSpPr>
+        <p:spPr>
+          <a:xfrm>
+            <a:off x="8138160" y="4910328"/>
+            <a:ext cx="3657600" cy="987552"/>
+          </a:xfrm>
+          <a:prstGeom prst="rect">
+            <a:avLst/>
+          </a:prstGeom>
+          <a:noFill/>
+        </p:spPr>
+        <p:txBody>
+          <a:bodyPr wrap="square" anchor="t">
+            <a:spAutoFit/>
+          </a:bodyPr>
+          <a:lstStyle/>
+          <a:p>
+            <a:pPr algn="l">
+              <a:spcAft>
+                <a:spcPts val="200"/>
+              </a:spcAft>
+            </a:pPr>
+            <a:r>
+              <a:rPr sz="1400" b="1">
+                <a:solidFill>
+                  <a:srgbClr val="0047BB"/>
+                </a:solidFill>
+              </a:rPr>
+              <a:t>afeefaaazam03.github.io/3D-Jetblade/viewer3d.html</a:t>
+            </a:r>
+          </a:p>
+        </p:txBody>
+      </p:sp>
+    </p:spTree>
+  </p:cSld>
+  <p:clrMapOvr>
+    <a:masterClrMapping/>
+  </p:clrMapOvr>
+</p:sld>
+</file>
+
+<file path=ppt/slides/slide28.xml><?xml version="1.0" encoding="utf-8"?>
 <p:sld xmlns:a="http://schemas.openxmlformats.org/drawingml/2006/main" xmlns:p="http://schemas.openxmlformats.org/presentationml/2006/main" xmlns:r="http://schemas.openxmlformats.org/officeDocument/2006/relationships">
   <p:cSld>
     <p:spTree>

</xml_diff>

<commit_message>
Statistical baselines (chi-square, a-contrario), detection-limit map check; paper, slides, page synced
Co-Authored-By: Claude Opus 5.5 <noreply@anthropic.com>
</commit_message>
<xml_diff>
--- a/media/BladeDelta_presentation.pptx
+++ b/media/BladeDelta_presentation.pptx
@@ -32,6 +32,7 @@
     <p:sldId id="284" r:id="rId35"/>
     <p:sldId id="285" r:id="rId36"/>
     <p:sldId id="286" r:id="rId37"/>
+    <p:sldId id="287" r:id="rId38"/>
     <p:sldId id="263" r:id="rId9"/>
   </p:sldIdLst>
   <p:sldSz cx="12192000" cy="6858000"/>
@@ -1525,6 +1526,250 @@
 </c:chartSpace>
 </file>
 
+<file path=ppt/charts/chart8.xml><?xml version="1.0" encoding="utf-8"?>
+<c:chartSpace xmlns:c="http://schemas.openxmlformats.org/drawingml/2006/chart" xmlns:a="http://schemas.openxmlformats.org/drawingml/2006/main" xmlns:r="http://schemas.openxmlformats.org/officeDocument/2006/relationships">
+  <c:date1904 val="0"/>
+  <c:chart>
+    <c:autoTitleDeleted val="0"/>
+    <c:plotArea>
+      <c:barChart>
+        <c:barDir val="col"/>
+        <c:grouping val="clustered"/>
+        <c:ser>
+          <c:idx val="0"/>
+          <c:order val="0"/>
+          <c:tx>
+            <c:strRef>
+              <c:f>Sheet1!$B$1</c:f>
+              <c:strCache>
+                <c:ptCount val="1"/>
+                <c:pt idx="0">
+                  <c:v>Target false alarms (%)</c:v>
+                </c:pt>
+              </c:strCache>
+            </c:strRef>
+          </c:tx>
+          <c:spPr>
+            <a:solidFill>
+              <a:srgbClr val="5A6577"/>
+            </a:solidFill>
+          </c:spPr>
+          <c:dLbls>
+            <c:numFmt formatCode="0" sourceLinked="0"/>
+            <c:txPr>
+              <a:bodyPr/>
+              <a:lstStyle/>
+              <a:p>
+                <a:pPr>
+                  <a:defRPr sz="1400" b="1"/>
+                </a:pPr>
+              </a:p>
+            </c:txPr>
+            <c:dLblPos val="outEnd"/>
+            <c:showLegendKey val="0"/>
+            <c:showVal val="1"/>
+            <c:showCatName val="0"/>
+            <c:showSerName val="0"/>
+            <c:showPercent val="0"/>
+            <c:showBubbleSize val="0"/>
+            <c:showLeaderLines val="1"/>
+          </c:dLbls>
+          <c:cat>
+            <c:strRef>
+              <c:f>Sheet1!$A$2:$A$4</c:f>
+              <c:strCache>
+                <c:ptCount val="3"/>
+                <c:pt idx="0">
+                  <c:v>Ours (calibrated)</c:v>
+                </c:pt>
+                <c:pt idx="1">
+                  <c:v>Textbook χ² test</c:v>
+                </c:pt>
+                <c:pt idx="2">
+                  <c:v>A-contrario</c:v>
+                </c:pt>
+              </c:strCache>
+            </c:strRef>
+          </c:cat>
+          <c:val>
+            <c:numRef>
+              <c:f>Sheet1!$B$2:$B$4</c:f>
+              <c:numCache>
+                <c:formatCode>General</c:formatCode>
+                <c:ptCount val="3"/>
+                <c:pt idx="0">
+                  <c:v>5</c:v>
+                </c:pt>
+                <c:pt idx="1">
+                  <c:v>1</c:v>
+                </c:pt>
+                <c:pt idx="2">
+                  <c:v>0</c:v>
+                </c:pt>
+              </c:numCache>
+            </c:numRef>
+          </c:val>
+        </c:ser>
+        <c:ser>
+          <c:idx val="1"/>
+          <c:order val="1"/>
+          <c:tx>
+            <c:strRef>
+              <c:f>Sheet1!$C$1</c:f>
+              <c:strCache>
+                <c:ptCount val="1"/>
+                <c:pt idx="0">
+                  <c:v>Actual false alarms (%)</c:v>
+                </c:pt>
+              </c:strCache>
+            </c:strRef>
+          </c:tx>
+          <c:spPr>
+            <a:solidFill>
+              <a:srgbClr val="C62828"/>
+            </a:solidFill>
+          </c:spPr>
+          <c:dLbls>
+            <c:numFmt formatCode="0" sourceLinked="0"/>
+            <c:txPr>
+              <a:bodyPr/>
+              <a:lstStyle/>
+              <a:p>
+                <a:pPr>
+                  <a:defRPr sz="1400" b="1"/>
+                </a:pPr>
+              </a:p>
+            </c:txPr>
+            <c:dLblPos val="outEnd"/>
+            <c:showLegendKey val="0"/>
+            <c:showVal val="1"/>
+            <c:showCatName val="0"/>
+            <c:showSerName val="0"/>
+            <c:showPercent val="0"/>
+            <c:showBubbleSize val="0"/>
+            <c:showLeaderLines val="1"/>
+          </c:dLbls>
+          <c:cat>
+            <c:strRef>
+              <c:f>Sheet1!$A$2:$A$4</c:f>
+              <c:strCache>
+                <c:ptCount val="3"/>
+                <c:pt idx="0">
+                  <c:v>Ours (calibrated)</c:v>
+                </c:pt>
+                <c:pt idx="1">
+                  <c:v>Textbook χ² test</c:v>
+                </c:pt>
+                <c:pt idx="2">
+                  <c:v>A-contrario</c:v>
+                </c:pt>
+              </c:strCache>
+            </c:strRef>
+          </c:cat>
+          <c:val>
+            <c:numRef>
+              <c:f>Sheet1!$C$2:$C$4</c:f>
+              <c:numCache>
+                <c:formatCode>General</c:formatCode>
+                <c:ptCount val="3"/>
+                <c:pt idx="0">
+                  <c:v>10</c:v>
+                </c:pt>
+                <c:pt idx="1">
+                  <c:v>32</c:v>
+                </c:pt>
+                <c:pt idx="2">
+                  <c:v>96</c:v>
+                </c:pt>
+              </c:numCache>
+            </c:numRef>
+          </c:val>
+        </c:ser>
+        <c:gapWidth val="60"/>
+        <c:axId val="-2068027336"/>
+        <c:axId val="-2113994440"/>
+      </c:barChart>
+      <c:catAx>
+        <c:axId val="-2068027336"/>
+        <c:scaling>
+          <c:orientation val="minMax"/>
+        </c:scaling>
+        <c:delete val="0"/>
+        <c:axPos val="b"/>
+        <c:majorTickMark val="out"/>
+        <c:minorTickMark val="none"/>
+        <c:tickLblPos val="nextTo"/>
+        <c:txPr>
+          <a:bodyPr/>
+          <a:lstStyle/>
+          <a:p>
+            <a:pPr>
+              <a:defRPr sz="1400"/>
+            </a:pPr>
+          </a:p>
+        </c:txPr>
+        <c:crossAx val="-2113994440"/>
+        <c:crosses val="autoZero"/>
+        <c:auto val="1"/>
+        <c:lblAlgn val="ctr"/>
+        <c:lblOffset val="100"/>
+        <c:noMultiLvlLbl val="0"/>
+      </c:catAx>
+      <c:valAx>
+        <c:axId val="-2113994440"/>
+        <c:scaling>
+          <c:max val="105.0"/>
+          <c:min val="0.0"/>
+        </c:scaling>
+        <c:delete/>
+        <c:axPos val="l"/>
+        <c:majorTickMark val="out"/>
+        <c:minorTickMark val="none"/>
+        <c:tickLblPos val="nextTo"/>
+        <c:txPr>
+          <a:bodyPr/>
+          <a:lstStyle/>
+          <a:p>
+            <a:pPr>
+              <a:defRPr sz="1200"/>
+            </a:pPr>
+          </a:p>
+        </c:txPr>
+        <c:crossAx val="-2068027336"/>
+        <c:crosses val="autoZero"/>
+      </c:valAx>
+    </c:plotArea>
+    <c:legend>
+      <c:legendPos val="b"/>
+      <c:overlay val="0"/>
+      <c:txPr>
+        <a:bodyPr/>
+        <a:lstStyle/>
+        <a:p>
+          <a:pPr>
+            <a:defRPr sz="1400"/>
+          </a:pPr>
+        </a:p>
+      </c:txPr>
+    </c:legend>
+    <c:dispBlanksAs val="gap"/>
+  </c:chart>
+  <c:txPr>
+    <a:bodyPr/>
+    <a:lstStyle/>
+    <a:p>
+      <a:pPr>
+        <a:defRPr sz="1800"/>
+      </a:pPr>
+      <a:endParaRPr lang="en-US"/>
+    </a:p>
+  </c:txPr>
+  <c:externalData r:id="rId1">
+    <c:autoUpdate val="0"/>
+  </c:externalData>
+</c:chartSpace>
+</file>
+
 <file path=ppt/notesMasters/notesMaster1.xml><?xml version="1.0" encoding="utf-8"?>
 <p:notesMaster xmlns:a="http://schemas.openxmlformats.org/drawingml/2006/main" xmlns:r="http://schemas.openxmlformats.org/officeDocument/2006/relationships" xmlns:p="http://schemas.openxmlformats.org/presentationml/2006/main">
   <p:cSld>
@@ -2619,7 +2864,7 @@
           <a:lstStyle/>
           <a:p>
             <a:r>
-              <a:t>New this week. Before searching, we compute the smallest dent each point could reveal. Yellow: tiny dents visible. Dark: only deep dents. Grey: the root, which the method ignores. The per-dent prediction was checked on 300 test dents. The map values in millimetres are still optimistic and need checking against real misses.</a:t>
+              <a:t>The evidence score is a likelihood ratio, so why not use a textbook threshold? Because those assume ideal image noise. On the same test fits, a chi-square threshold asked for 1 percent false alarms gives 32 percent, and the classic a-contrario detector flags 96 percent of healthy blades. Our threshold is set on real healthy and stained blades, so it stays close to its target. Calibration is what makes false-alarm control work.</a:t>
             </a:r>
           </a:p>
         </p:txBody>
@@ -2759,7 +3004,7 @@
           <a:lstStyle/>
           <a:p>
             <a:r>
-              <a:t>How we bridge synthetic and real. Every photo so far is rendered, which gives exact answers. Several design choices are there to survive real data: we always compare with a healthy reference so absolute appearance errors cancel; since v1.1 that correction moves with the camera; the threshold is calibrated on data, not assumed; and we tested on new industrial designs. One real dataset of scanned furniture does not work yet, mainly because its photos are misaligned. Next: a printed, dented and scanned copy of one of your blades.</a:t>
+              <a:t>New this week. Before searching, we compute the smallest dent each point could reveal. Yellow: tiny dents visible. Dark: only deep dents. Grey: the root, which the method ignores. The per-dent prediction was checked on 300 test dents. The map values in millimetres are still optimistic and need checking against real misses.</a:t>
             </a:r>
           </a:p>
         </p:txBody>
@@ -2829,7 +3074,7 @@
           <a:lstStyle/>
           <a:p>
             <a:r>
-              <a:t>The honest gap: everything so far is on rendered images. The next step is a real blade: print one of the industrial designs at twice its size, put real dents in it, photograph it, and measure the dents with a scanner.</a:t>
+              <a:t>How we bridge synthetic and real. Every photo so far is rendered, which gives exact answers. Several design choices are there to survive real data: we always compare with a healthy reference so absolute appearance errors cancel; since v1.1 that correction moves with the camera; the threshold is calibrated on data, not assumed; and we tested on new industrial designs. One real dataset of scanned furniture does not work yet, mainly because its photos are misaligned. Next: a printed, dented and scanned copy of one of your blades.</a:t>
             </a:r>
           </a:p>
         </p:txBody>
@@ -2899,7 +3144,7 @@
           <a:lstStyle/>
           <a:p>
             <a:r>
-              <a:t>In short: a method that measures dents in 3D from a few photos, says when it cannot tell, keeps false alarms low, predicts what it can and cannot see, and now works on new blade designs. Next: real blades.</a:t>
+              <a:t>The honest gap: everything so far is on rendered images. The next step is a real blade: print one of the industrial designs at twice its size, put real dents in it, photograph it, and measure the dents with a scanner.</a:t>
             </a:r>
           </a:p>
         </p:txBody>
@@ -2969,7 +3214,7 @@
           <a:lstStyle/>
           <a:p>
             <a:r>
-              <a:t>The live 3D demo. Here an industrial blade: left the actual dent, right what the model predicts, 0.29 versus 0.30 millimetres, same place. Dents are exaggerated twenty times so they are visible. You can rotate, zoom, and switch between healthy, actual, the new model and the old one.</a:t>
+              <a:t>In short: a method that measures dents in 3D from a few photos, says when it cannot tell, keeps false alarms low, predicts what it can and cannot see, and now works on new blade designs. Next: real blades.</a:t>
             </a:r>
           </a:p>
         </p:txBody>
@@ -3039,7 +3284,7 @@
           <a:lstStyle/>
           <a:p>
             <a:r>
-              <a:t>The interactive demo online: choose one of five test blades, see the method decision, the measured depth and the evidence against the threshold. These are real outputs of the method.</a:t>
+              <a:t>The live 3D demo. Here an industrial blade: left the actual dent, right what the model predicts, 0.29 versus 0.30 millimetres, same place. Dents are exaggerated twenty times so they are visible. You can rotate, zoom, and switch between healthy, actual, the new model and the old one.</a:t>
             </a:r>
           </a:p>
         </p:txBody>
@@ -3065,6 +3310,76 @@
 </file>
 
 <file path=ppt/notesSlides/notesSlide25.xml><?xml version="1.0" encoding="utf-8"?>
+<p:notes xmlns:a="http://schemas.openxmlformats.org/drawingml/2006/main" xmlns:p="http://schemas.openxmlformats.org/presentationml/2006/main" xmlns:r="http://schemas.openxmlformats.org/officeDocument/2006/relationships">
+  <p:cSld>
+    <p:spTree>
+      <p:nvGrpSpPr>
+        <p:cNvPr id="1" name=""/>
+        <p:cNvGrpSpPr/>
+        <p:nvPr/>
+      </p:nvGrpSpPr>
+      <p:grpSpPr>
+        <a:xfrm>
+          <a:off x="0" y="0"/>
+          <a:ext cx="0" cy="0"/>
+          <a:chOff x="0" y="0"/>
+          <a:chExt cx="0" cy="0"/>
+        </a:xfrm>
+      </p:grpSpPr>
+      <p:sp>
+        <p:nvSpPr>
+          <p:cNvPr id="2" name="Slide Image Placeholder 1"/>
+          <p:cNvSpPr>
+            <a:spLocks noGrp="1"/>
+          </p:cNvSpPr>
+          <p:nvPr>
+            <p:ph type="sldImg" idx="2"/>
+          </p:nvPr>
+        </p:nvSpPr>
+        <p:spPr/>
+      </p:sp>
+      <p:sp>
+        <p:nvSpPr>
+          <p:cNvPr id="3" name="Notes Placeholder 2"/>
+          <p:cNvSpPr>
+            <a:spLocks noGrp="1"/>
+          </p:cNvSpPr>
+          <p:nvPr>
+            <p:ph type="body" idx="3" sz="quarter"/>
+          </p:nvPr>
+        </p:nvSpPr>
+        <p:spPr/>
+        <p:txBody>
+          <a:bodyPr/>
+          <a:lstStyle/>
+          <a:p>
+            <a:r>
+              <a:t>The interactive demo online: choose one of five test blades, see the method decision, the measured depth and the evidence against the threshold. These are real outputs of the method.</a:t>
+            </a:r>
+          </a:p>
+        </p:txBody>
+      </p:sp>
+      <p:sp>
+        <p:nvSpPr>
+          <p:cNvPr id="4" name="Slide Number Placeholder 3"/>
+          <p:cNvSpPr>
+            <a:spLocks noGrp="1"/>
+          </p:cNvSpPr>
+          <p:nvPr>
+            <p:ph type="sldNum" idx="5" sz="quarter"/>
+          </p:nvPr>
+        </p:nvSpPr>
+        <p:spPr/>
+      </p:sp>
+    </p:spTree>
+  </p:cSld>
+  <p:clrMapOvr>
+    <a:masterClrMapping/>
+  </p:clrMapOvr>
+</p:notes>
+</file>
+
+<file path=ppt/notesSlides/notesSlide26.xml><?xml version="1.0" encoding="utf-8"?>
 <p:notes xmlns:a="http://schemas.openxmlformats.org/drawingml/2006/main" xmlns:p="http://schemas.openxmlformats.org/presentationml/2006/main" xmlns:r="http://schemas.openxmlformats.org/officeDocument/2006/relationships">
   <p:cSld>
     <p:spTree>
@@ -17448,21 +17763,39 @@
           <a:p>
             <a:r>
               <a:rPr sz="2400"/>
-              <a:t>A New Idea: Knowing What the Photos Can Show</a:t>
-            </a:r>
-          </a:p>
-        </p:txBody>
-      </p:sp>
-      <p:sp>
-        <p:nvSpPr>
-          <p:cNvPr id="3" name="TextBox 2"/>
+              <a:t>Why Not a Standard Statistical Test?</a:t>
+            </a:r>
+          </a:p>
+        </p:txBody>
+      </p:sp>
+      <p:graphicFrame>
+        <p:nvGraphicFramePr>
+          <p:cNvPr id="3" name="Chart 2"/>
+          <p:cNvGraphicFramePr>
+            <a:graphicFrameLocks noGrp="1"/>
+          </p:cNvGraphicFramePr>
+          <p:nvPr/>
+        </p:nvGraphicFramePr>
+        <p:xfrm>
+          <a:off x="457200" y="1865376"/>
+          <a:ext cx="6766560" cy="4032504"/>
+        </p:xfrm>
+        <a:graphic>
+          <a:graphicData uri="http://schemas.openxmlformats.org/drawingml/2006/chart">
+            <c:chart xmlns:c="http://schemas.openxmlformats.org/drawingml/2006/chart" r:id="rId2"/>
+          </a:graphicData>
+        </a:graphic>
+      </p:graphicFrame>
+      <p:sp>
+        <p:nvSpPr>
+          <p:cNvPr id="4" name="TextBox 3"/>
           <p:cNvSpPr txBox="1"/>
           <p:nvPr/>
         </p:nvSpPr>
         <p:spPr>
           <a:xfrm>
-            <a:off x="548640" y="1947672"/>
-            <a:ext cx="6035040" cy="3127248"/>
+            <a:off x="7498079" y="2029968"/>
+            <a:ext cx="4297680" cy="2962656"/>
           </a:xfrm>
           <a:prstGeom prst="rect">
             <a:avLst/>
@@ -17481,12 +17814,12 @@
               </a:spcAft>
             </a:pPr>
             <a:r>
-              <a:rPr sz="2100" b="0">
+              <a:rPr sz="1700" b="0">
                 <a:solidFill>
                   <a:srgbClr val="1F2937"/>
                 </a:solidFill>
               </a:rPr>
-              <a:t>•  Before searching, predict the smallest detectable dent</a:t>
+              <a:t>•  Textbook tests assume ideal image noise</a:t>
             </a:r>
           </a:p>
           <a:p>
@@ -17496,12 +17829,12 @@
               </a:spcAft>
             </a:pPr>
             <a:r>
-              <a:rPr sz="2100" b="0">
+              <a:rPr sz="1700" b="0">
                 <a:solidFill>
                   <a:srgbClr val="1F2937"/>
                 </a:solidFill>
               </a:rPr>
-              <a:t>•  Per-point map: where can we see damage?</a:t>
+              <a:t>•  Real mismatch (camera, lighting, rendering) is much larger</a:t>
             </a:r>
           </a:p>
           <a:p>
@@ -17511,32 +17844,47 @@
               </a:spcAft>
             </a:pPr>
             <a:r>
-              <a:rPr sz="2100" b="0">
+              <a:rPr sz="1700" b="0">
                 <a:solidFill>
                   <a:srgbClr val="1F2937"/>
                 </a:solidFill>
               </a:rPr>
-              <a:t>•  Tested against reality: predicts which dents are found (AUROC 0.90–0.95 on two sealed tests)</a:t>
-            </a:r>
-          </a:p>
-        </p:txBody>
-      </p:sp>
-      <p:sp>
-        <p:nvSpPr>
-          <p:cNvPr id="4" name="Rounded Rectangle 3"/>
+              <a:t>•  χ²: asked for 1%, gives 32%: about 30× too many</a:t>
+            </a:r>
+          </a:p>
+          <a:p>
+            <a:pPr algn="l">
+              <a:spcAft>
+                <a:spcPts val="800"/>
+              </a:spcAft>
+            </a:pPr>
+            <a:r>
+              <a:rPr sz="1700" b="0">
+                <a:solidFill>
+                  <a:srgbClr val="1F2937"/>
+                </a:solidFill>
+              </a:rPr>
+              <a:t>•  A-contrario: flags 96% of healthy blades</a:t>
+            </a:r>
+          </a:p>
+        </p:txBody>
+      </p:sp>
+      <p:sp>
+        <p:nvSpPr>
+          <p:cNvPr id="5" name="Rounded Rectangle 4"/>
           <p:cNvSpPr/>
           <p:nvPr/>
         </p:nvSpPr>
         <p:spPr>
           <a:xfrm>
-            <a:off x="548640" y="4910328"/>
-            <a:ext cx="6035040" cy="987552"/>
+            <a:off x="7498079" y="4910328"/>
+            <a:ext cx="4297680" cy="1069848"/>
           </a:xfrm>
           <a:prstGeom prst="roundRect">
             <a:avLst/>
           </a:prstGeom>
           <a:solidFill>
-            <a:srgbClr val="F2F5FA"/>
+            <a:srgbClr val="0047BB"/>
           </a:solidFill>
           <a:ln>
             <a:noFill/>
@@ -17563,40 +17911,27 @@
           <a:p>
             <a:pPr algn="ctr"/>
             <a:r>
-              <a:rPr sz="2200" b="1">
+              <a:rPr sz="1900" b="1">
                 <a:solidFill>
-                  <a:srgbClr val="0047BB"/>
+                  <a:srgbClr val="FFFFFF"/>
                 </a:solidFill>
               </a:rPr>
-              <a:t>We bound our misses, not just our false alarms.</a:t>
-            </a:r>
-          </a:p>
-        </p:txBody>
-      </p:sp>
-      <p:pic>
-        <p:nvPicPr>
-          <p:cNvPr id="5" name="Picture 4" descr="s16_map.png"/>
-          <p:cNvPicPr>
-            <a:picLocks noChangeAspect="1"/>
-          </p:cNvPicPr>
-          <p:nvPr/>
-        </p:nvPicPr>
-        <p:blipFill>
-          <a:blip r:embed="rId2"/>
-          <a:stretch>
-            <a:fillRect/>
-          </a:stretch>
-        </p:blipFill>
-        <p:spPr>
-          <a:xfrm>
-            <a:off x="7104888" y="1783080"/>
-            <a:ext cx="4443984" cy="4608576"/>
-          </a:xfrm>
-          <a:prstGeom prst="rect">
-            <a:avLst/>
-          </a:prstGeom>
-        </p:spPr>
-      </p:pic>
+              <a:t>Calibration is required,</a:t>
+            </a:r>
+          </a:p>
+          <a:p>
+            <a:pPr algn="ctr"/>
+            <a:r>
+              <a:rPr sz="1700" b="0">
+                <a:solidFill>
+                  <a:srgbClr val="FFFFFF"/>
+                </a:solidFill>
+              </a:rPr>
+              <a:t>not cosmetic</a:t>
+            </a:r>
+          </a:p>
+        </p:txBody>
+      </p:sp>
     </p:spTree>
   </p:cSld>
   <p:clrMapOvr>
@@ -17631,28 +17966,96 @@
           <a:lstStyle/>
           <a:p>
             <a:r>
-              <a:rPr sz="3000"/>
-              <a:t>From Synthetic to Real Data</a:t>
-            </a:r>
-          </a:p>
-        </p:txBody>
-      </p:sp>
-      <p:sp>
-        <p:nvSpPr>
-          <p:cNvPr id="3" name="Rounded Rectangle 2"/>
+              <a:rPr sz="2400"/>
+              <a:t>A New Idea: Knowing What the Photos Can Show</a:t>
+            </a:r>
+          </a:p>
+        </p:txBody>
+      </p:sp>
+      <p:sp>
+        <p:nvSpPr>
+          <p:cNvPr id="3" name="TextBox 2"/>
+          <p:cNvSpPr txBox="1"/>
+          <p:nvPr/>
+        </p:nvSpPr>
+        <p:spPr>
+          <a:xfrm>
+            <a:off x="548640" y="1947672"/>
+            <a:ext cx="6035040" cy="3127248"/>
+          </a:xfrm>
+          <a:prstGeom prst="rect">
+            <a:avLst/>
+          </a:prstGeom>
+          <a:noFill/>
+        </p:spPr>
+        <p:txBody>
+          <a:bodyPr wrap="square" anchor="t">
+            <a:spAutoFit/>
+          </a:bodyPr>
+          <a:lstStyle/>
+          <a:p>
+            <a:pPr algn="l">
+              <a:spcAft>
+                <a:spcPts val="800"/>
+              </a:spcAft>
+            </a:pPr>
+            <a:r>
+              <a:rPr sz="2100" b="0">
+                <a:solidFill>
+                  <a:srgbClr val="1F2937"/>
+                </a:solidFill>
+              </a:rPr>
+              <a:t>•  Before searching, predict the smallest detectable dent</a:t>
+            </a:r>
+          </a:p>
+          <a:p>
+            <a:pPr algn="l">
+              <a:spcAft>
+                <a:spcPts val="800"/>
+              </a:spcAft>
+            </a:pPr>
+            <a:r>
+              <a:rPr sz="2100" b="0">
+                <a:solidFill>
+                  <a:srgbClr val="1F2937"/>
+                </a:solidFill>
+              </a:rPr>
+              <a:t>•  Per-point map: where can we see damage?</a:t>
+            </a:r>
+          </a:p>
+          <a:p>
+            <a:pPr algn="l">
+              <a:spcAft>
+                <a:spcPts val="800"/>
+              </a:spcAft>
+            </a:pPr>
+            <a:r>
+              <a:rPr sz="2100" b="0">
+                <a:solidFill>
+                  <a:srgbClr val="1F2937"/>
+                </a:solidFill>
+              </a:rPr>
+              <a:t>•  Per-dent prediction tested against reality: AUROC 0.90–0.95 on two sealed tests</a:t>
+            </a:r>
+          </a:p>
+        </p:txBody>
+      </p:sp>
+      <p:sp>
+        <p:nvSpPr>
+          <p:cNvPr id="4" name="Rounded Rectangle 3"/>
           <p:cNvSpPr/>
           <p:nvPr/>
         </p:nvSpPr>
         <p:spPr>
           <a:xfrm>
-            <a:off x="365760" y="1947672"/>
-            <a:ext cx="1691640" cy="1316736"/>
+            <a:off x="548640" y="4910328"/>
+            <a:ext cx="6035040" cy="987552"/>
           </a:xfrm>
           <a:prstGeom prst="roundRect">
             <a:avLst/>
           </a:prstGeom>
           <a:solidFill>
-            <a:srgbClr val="5A6577"/>
+            <a:srgbClr val="F2F5FA"/>
           </a:solidFill>
           <a:ln>
             <a:noFill/>
@@ -17679,633 +18082,30 @@
           <a:p>
             <a:pPr algn="ctr"/>
             <a:r>
-              <a:rPr sz="1500" b="1">
+              <a:rPr sz="1800" b="1">
                 <a:solidFill>
-                  <a:srgbClr val="FFFFFF"/>
+                  <a:srgbClr val="0047BB"/>
                 </a:solidFill>
               </a:rPr>
-              <a:t>Synthetic</a:t>
+              <a:t>We predict which dents we can see.</a:t>
             </a:r>
           </a:p>
           <a:p>
             <a:pPr algn="ctr"/>
             <a:r>
-              <a:rPr sz="1300" b="0">
+              <a:rPr sz="1600" b="0">
                 <a:solidFill>
-                  <a:srgbClr val="FFFFFF"/>
+                  <a:srgbClr val="0047BB"/>
                 </a:solidFill>
               </a:rPr>
-              <a:t>rendered blades, exact truth</a:t>
-            </a:r>
-          </a:p>
-        </p:txBody>
-      </p:sp>
-      <p:sp>
-        <p:nvSpPr>
-          <p:cNvPr id="4" name="Right Arrow 3"/>
-          <p:cNvSpPr/>
-          <p:nvPr/>
-        </p:nvSpPr>
-        <p:spPr>
-          <a:xfrm>
-            <a:off x="2075688" y="2441448"/>
-            <a:ext cx="201168" cy="263347"/>
-          </a:xfrm>
-          <a:prstGeom prst="rightArrow">
-            <a:avLst/>
-          </a:prstGeom>
-          <a:solidFill>
-            <a:srgbClr val="5A6577"/>
-          </a:solidFill>
-          <a:ln>
-            <a:noFill/>
-          </a:ln>
-          <a:effectLst/>
-        </p:spPr>
-        <p:style>
-          <a:lnRef idx="1">
-            <a:schemeClr val="accent1"/>
-          </a:lnRef>
-          <a:fillRef idx="3">
-            <a:schemeClr val="accent1"/>
-          </a:fillRef>
-          <a:effectRef idx="2">
-            <a:schemeClr val="accent1"/>
-          </a:effectRef>
-          <a:fontRef idx="minor">
-            <a:schemeClr val="lt1"/>
-          </a:fontRef>
-        </p:style>
-        <p:txBody>
-          <a:bodyPr rtlCol="0" anchor="ctr"/>
-          <a:lstStyle/>
-          <a:p>
-            <a:pPr algn="ctr"/>
-          </a:p>
-        </p:txBody>
-      </p:sp>
-      <p:sp>
-        <p:nvSpPr>
-          <p:cNvPr id="5" name="Rounded Rectangle 4"/>
-          <p:cNvSpPr/>
-          <p:nvPr/>
-        </p:nvSpPr>
-        <p:spPr>
-          <a:xfrm>
-            <a:off x="2286000" y="1947672"/>
-            <a:ext cx="1691640" cy="1316736"/>
-          </a:xfrm>
-          <a:prstGeom prst="roundRect">
-            <a:avLst/>
-          </a:prstGeom>
-          <a:solidFill>
-            <a:srgbClr val="0047BB"/>
-          </a:solidFill>
-          <a:ln>
-            <a:noFill/>
-          </a:ln>
-          <a:effectLst/>
-        </p:spPr>
-        <p:style>
-          <a:lnRef idx="1">
-            <a:schemeClr val="accent1"/>
-          </a:lnRef>
-          <a:fillRef idx="3">
-            <a:schemeClr val="accent1"/>
-          </a:fillRef>
-          <a:effectRef idx="2">
-            <a:schemeClr val="accent1"/>
-          </a:effectRef>
-          <a:fontRef idx="minor">
-            <a:schemeClr val="lt1"/>
-          </a:fontRef>
-        </p:style>
-        <p:txBody>
-          <a:bodyPr rtlCol="0" anchor="ctr" wrap="square"/>
-          <a:lstStyle/>
-          <a:p>
-            <a:pPr algn="ctr"/>
-            <a:r>
-              <a:rPr sz="1500" b="1">
-                <a:solidFill>
-                  <a:srgbClr val="FFFFFF"/>
-                </a:solidFill>
-              </a:rPr>
-              <a:t>Compare to healthy</a:t>
-            </a:r>
-          </a:p>
-          <a:p>
-            <a:pPr algn="ctr"/>
-            <a:r>
-              <a:rPr sz="1300" b="0">
-                <a:solidFill>
-                  <a:srgbClr val="FFFFFF"/>
-                </a:solidFill>
-              </a:rPr>
-              <a:t>appearance errors cancel</a:t>
-            </a:r>
-          </a:p>
-        </p:txBody>
-      </p:sp>
-      <p:sp>
-        <p:nvSpPr>
-          <p:cNvPr id="6" name="Right Arrow 5"/>
-          <p:cNvSpPr/>
-          <p:nvPr/>
-        </p:nvSpPr>
-        <p:spPr>
-          <a:xfrm>
-            <a:off x="3995928" y="2441448"/>
-            <a:ext cx="201168" cy="263347"/>
-          </a:xfrm>
-          <a:prstGeom prst="rightArrow">
-            <a:avLst/>
-          </a:prstGeom>
-          <a:solidFill>
-            <a:srgbClr val="5A6577"/>
-          </a:solidFill>
-          <a:ln>
-            <a:noFill/>
-          </a:ln>
-          <a:effectLst/>
-        </p:spPr>
-        <p:style>
-          <a:lnRef idx="1">
-            <a:schemeClr val="accent1"/>
-          </a:lnRef>
-          <a:fillRef idx="3">
-            <a:schemeClr val="accent1"/>
-          </a:fillRef>
-          <a:effectRef idx="2">
-            <a:schemeClr val="accent1"/>
-          </a:effectRef>
-          <a:fontRef idx="minor">
-            <a:schemeClr val="lt1"/>
-          </a:fontRef>
-        </p:style>
-        <p:txBody>
-          <a:bodyPr rtlCol="0" anchor="ctr"/>
-          <a:lstStyle/>
-          <a:p>
-            <a:pPr algn="ctr"/>
-          </a:p>
-        </p:txBody>
-      </p:sp>
-      <p:sp>
-        <p:nvSpPr>
-          <p:cNvPr id="7" name="Rounded Rectangle 6"/>
-          <p:cNvSpPr/>
-          <p:nvPr/>
-        </p:nvSpPr>
-        <p:spPr>
-          <a:xfrm>
-            <a:off x="4206240" y="1947672"/>
-            <a:ext cx="1691640" cy="1316736"/>
-          </a:xfrm>
-          <a:prstGeom prst="roundRect">
-            <a:avLst/>
-          </a:prstGeom>
-          <a:solidFill>
-            <a:srgbClr val="0047BB"/>
-          </a:solidFill>
-          <a:ln>
-            <a:noFill/>
-          </a:ln>
-          <a:effectLst/>
-        </p:spPr>
-        <p:style>
-          <a:lnRef idx="1">
-            <a:schemeClr val="accent1"/>
-          </a:lnRef>
-          <a:fillRef idx="3">
-            <a:schemeClr val="accent1"/>
-          </a:fillRef>
-          <a:effectRef idx="2">
-            <a:schemeClr val="accent1"/>
-          </a:effectRef>
-          <a:fontRef idx="minor">
-            <a:schemeClr val="lt1"/>
-          </a:fontRef>
-        </p:style>
-        <p:txBody>
-          <a:bodyPr rtlCol="0" anchor="ctr" wrap="square"/>
-          <a:lstStyle/>
-          <a:p>
-            <a:pPr algn="ctr"/>
-            <a:r>
-              <a:rPr sz="1500" b="1">
-                <a:solidFill>
-                  <a:srgbClr val="FFFFFF"/>
-                </a:solidFill>
-              </a:rPr>
-              <a:t>Correction follows camera</a:t>
-            </a:r>
-          </a:p>
-          <a:p>
-            <a:pPr algn="ctr"/>
-            <a:r>
-              <a:rPr sz="1300" b="0">
-                <a:solidFill>
-                  <a:srgbClr val="FFFFFF"/>
-                </a:solidFill>
-              </a:rPr>
-              <a:t>v1.1: survives camera drift</a:t>
-            </a:r>
-          </a:p>
-        </p:txBody>
-      </p:sp>
-      <p:sp>
-        <p:nvSpPr>
-          <p:cNvPr id="8" name="Right Arrow 7"/>
-          <p:cNvSpPr/>
-          <p:nvPr/>
-        </p:nvSpPr>
-        <p:spPr>
-          <a:xfrm>
-            <a:off x="5916168" y="2441448"/>
-            <a:ext cx="201168" cy="263347"/>
-          </a:xfrm>
-          <a:prstGeom prst="rightArrow">
-            <a:avLst/>
-          </a:prstGeom>
-          <a:solidFill>
-            <a:srgbClr val="5A6577"/>
-          </a:solidFill>
-          <a:ln>
-            <a:noFill/>
-          </a:ln>
-          <a:effectLst/>
-        </p:spPr>
-        <p:style>
-          <a:lnRef idx="1">
-            <a:schemeClr val="accent1"/>
-          </a:lnRef>
-          <a:fillRef idx="3">
-            <a:schemeClr val="accent1"/>
-          </a:fillRef>
-          <a:effectRef idx="2">
-            <a:schemeClr val="accent1"/>
-          </a:effectRef>
-          <a:fontRef idx="minor">
-            <a:schemeClr val="lt1"/>
-          </a:fontRef>
-        </p:style>
-        <p:txBody>
-          <a:bodyPr rtlCol="0" anchor="ctr"/>
-          <a:lstStyle/>
-          <a:p>
-            <a:pPr algn="ctr"/>
-          </a:p>
-        </p:txBody>
-      </p:sp>
-      <p:sp>
-        <p:nvSpPr>
-          <p:cNvPr id="9" name="Rounded Rectangle 8"/>
-          <p:cNvSpPr/>
-          <p:nvPr/>
-        </p:nvSpPr>
-        <p:spPr>
-          <a:xfrm>
-            <a:off x="6126480" y="1947672"/>
-            <a:ext cx="1691640" cy="1316736"/>
-          </a:xfrm>
-          <a:prstGeom prst="roundRect">
-            <a:avLst/>
-          </a:prstGeom>
-          <a:solidFill>
-            <a:srgbClr val="0047BB"/>
-          </a:solidFill>
-          <a:ln>
-            <a:noFill/>
-          </a:ln>
-          <a:effectLst/>
-        </p:spPr>
-        <p:style>
-          <a:lnRef idx="1">
-            <a:schemeClr val="accent1"/>
-          </a:lnRef>
-          <a:fillRef idx="3">
-            <a:schemeClr val="accent1"/>
-          </a:fillRef>
-          <a:effectRef idx="2">
-            <a:schemeClr val="accent1"/>
-          </a:effectRef>
-          <a:fontRef idx="minor">
-            <a:schemeClr val="lt1"/>
-          </a:fontRef>
-        </p:style>
-        <p:txBody>
-          <a:bodyPr rtlCol="0" anchor="ctr" wrap="square"/>
-          <a:lstStyle/>
-          <a:p>
-            <a:pPr algn="ctr"/>
-            <a:r>
-              <a:rPr sz="1500" b="1">
-                <a:solidFill>
-                  <a:srgbClr val="FFFFFF"/>
-                </a:solidFill>
-              </a:rPr>
-              <a:t>Calibrate on negatives</a:t>
-            </a:r>
-          </a:p>
-          <a:p>
-            <a:pPr algn="ctr"/>
-            <a:r>
-              <a:rPr sz="1300" b="0">
-                <a:solidFill>
-                  <a:srgbClr val="FFFFFF"/>
-                </a:solidFill>
-              </a:rPr>
-              <a:t>threshold set on data</a:t>
-            </a:r>
-          </a:p>
-        </p:txBody>
-      </p:sp>
-      <p:sp>
-        <p:nvSpPr>
-          <p:cNvPr id="10" name="Right Arrow 9"/>
-          <p:cNvSpPr/>
-          <p:nvPr/>
-        </p:nvSpPr>
-        <p:spPr>
-          <a:xfrm>
-            <a:off x="7836408" y="2441448"/>
-            <a:ext cx="201168" cy="263347"/>
-          </a:xfrm>
-          <a:prstGeom prst="rightArrow">
-            <a:avLst/>
-          </a:prstGeom>
-          <a:solidFill>
-            <a:srgbClr val="5A6577"/>
-          </a:solidFill>
-          <a:ln>
-            <a:noFill/>
-          </a:ln>
-          <a:effectLst/>
-        </p:spPr>
-        <p:style>
-          <a:lnRef idx="1">
-            <a:schemeClr val="accent1"/>
-          </a:lnRef>
-          <a:fillRef idx="3">
-            <a:schemeClr val="accent1"/>
-          </a:fillRef>
-          <a:effectRef idx="2">
-            <a:schemeClr val="accent1"/>
-          </a:effectRef>
-          <a:fontRef idx="minor">
-            <a:schemeClr val="lt1"/>
-          </a:fontRef>
-        </p:style>
-        <p:txBody>
-          <a:bodyPr rtlCol="0" anchor="ctr"/>
-          <a:lstStyle/>
-          <a:p>
-            <a:pPr algn="ctr"/>
-          </a:p>
-        </p:txBody>
-      </p:sp>
-      <p:sp>
-        <p:nvSpPr>
-          <p:cNvPr id="11" name="Rounded Rectangle 10"/>
-          <p:cNvSpPr/>
-          <p:nvPr/>
-        </p:nvSpPr>
-        <p:spPr>
-          <a:xfrm>
-            <a:off x="8046720" y="1947672"/>
-            <a:ext cx="1691640" cy="1316736"/>
-          </a:xfrm>
-          <a:prstGeom prst="roundRect">
-            <a:avLst/>
-          </a:prstGeom>
-          <a:solidFill>
-            <a:srgbClr val="E8833A"/>
-          </a:solidFill>
-          <a:ln>
-            <a:noFill/>
-          </a:ln>
-          <a:effectLst/>
-        </p:spPr>
-        <p:style>
-          <a:lnRef idx="1">
-            <a:schemeClr val="accent1"/>
-          </a:lnRef>
-          <a:fillRef idx="3">
-            <a:schemeClr val="accent1"/>
-          </a:fillRef>
-          <a:effectRef idx="2">
-            <a:schemeClr val="accent1"/>
-          </a:effectRef>
-          <a:fontRef idx="minor">
-            <a:schemeClr val="lt1"/>
-          </a:fontRef>
-        </p:style>
-        <p:txBody>
-          <a:bodyPr rtlCol="0" anchor="ctr" wrap="square"/>
-          <a:lstStyle/>
-          <a:p>
-            <a:pPr algn="ctr"/>
-            <a:r>
-              <a:rPr sz="1500" b="1">
-                <a:solidFill>
-                  <a:srgbClr val="FFFFFF"/>
-                </a:solidFill>
-              </a:rPr>
-              <a:t>New designs</a:t>
-            </a:r>
-          </a:p>
-          <a:p>
-            <a:pPr algn="ctr"/>
-            <a:r>
-              <a:rPr sz="1300" b="0">
-                <a:solidFill>
-                  <a:srgbClr val="FFFFFF"/>
-                </a:solidFill>
-              </a:rPr>
-              <a:t>6 industrial blades: detection transfers</a:t>
-            </a:r>
-          </a:p>
-        </p:txBody>
-      </p:sp>
-      <p:sp>
-        <p:nvSpPr>
-          <p:cNvPr id="12" name="Right Arrow 11"/>
-          <p:cNvSpPr/>
-          <p:nvPr/>
-        </p:nvSpPr>
-        <p:spPr>
-          <a:xfrm>
-            <a:off x="9756648" y="2441448"/>
-            <a:ext cx="201168" cy="263347"/>
-          </a:xfrm>
-          <a:prstGeom prst="rightArrow">
-            <a:avLst/>
-          </a:prstGeom>
-          <a:solidFill>
-            <a:srgbClr val="5A6577"/>
-          </a:solidFill>
-          <a:ln>
-            <a:noFill/>
-          </a:ln>
-          <a:effectLst/>
-        </p:spPr>
-        <p:style>
-          <a:lnRef idx="1">
-            <a:schemeClr val="accent1"/>
-          </a:lnRef>
-          <a:fillRef idx="3">
-            <a:schemeClr val="accent1"/>
-          </a:fillRef>
-          <a:effectRef idx="2">
-            <a:schemeClr val="accent1"/>
-          </a:effectRef>
-          <a:fontRef idx="minor">
-            <a:schemeClr val="lt1"/>
-          </a:fontRef>
-        </p:style>
-        <p:txBody>
-          <a:bodyPr rtlCol="0" anchor="ctr"/>
-          <a:lstStyle/>
-          <a:p>
-            <a:pPr algn="ctr"/>
-          </a:p>
-        </p:txBody>
-      </p:sp>
-      <p:sp>
-        <p:nvSpPr>
-          <p:cNvPr id="13" name="Rounded Rectangle 12"/>
-          <p:cNvSpPr/>
-          <p:nvPr/>
-        </p:nvSpPr>
-        <p:spPr>
-          <a:xfrm>
-            <a:off x="9966960" y="1947672"/>
-            <a:ext cx="1691640" cy="1316736"/>
-          </a:xfrm>
-          <a:prstGeom prst="roundRect">
-            <a:avLst/>
-          </a:prstGeom>
-          <a:solidFill>
-            <a:srgbClr val="1A7F37"/>
-          </a:solidFill>
-          <a:ln>
-            <a:noFill/>
-          </a:ln>
-          <a:effectLst/>
-        </p:spPr>
-        <p:style>
-          <a:lnRef idx="1">
-            <a:schemeClr val="accent1"/>
-          </a:lnRef>
-          <a:fillRef idx="3">
-            <a:schemeClr val="accent1"/>
-          </a:fillRef>
-          <a:effectRef idx="2">
-            <a:schemeClr val="accent1"/>
-          </a:effectRef>
-          <a:fontRef idx="minor">
-            <a:schemeClr val="lt1"/>
-          </a:fontRef>
-        </p:style>
-        <p:txBody>
-          <a:bodyPr rtlCol="0" anchor="ctr" wrap="square"/>
-          <a:lstStyle/>
-          <a:p>
-            <a:pPr algn="ctr"/>
-            <a:r>
-              <a:rPr sz="1500" b="1">
-                <a:solidFill>
-                  <a:srgbClr val="FFFFFF"/>
-                </a:solidFill>
-              </a:rPr>
-              <a:t>Real blade</a:t>
-            </a:r>
-          </a:p>
-          <a:p>
-            <a:pPr algn="ctr"/>
-            <a:r>
-              <a:rPr sz="1300" b="0">
-                <a:solidFill>
-                  <a:srgbClr val="FFFFFF"/>
-                </a:solidFill>
-              </a:rPr>
-              <a:t>printed, dented, scanned (next)</a:t>
-            </a:r>
-          </a:p>
-        </p:txBody>
-      </p:sp>
-      <p:sp>
-        <p:nvSpPr>
-          <p:cNvPr id="14" name="TextBox 13"/>
-          <p:cNvSpPr txBox="1"/>
-          <p:nvPr/>
-        </p:nvSpPr>
-        <p:spPr>
-          <a:xfrm>
-            <a:off x="548640" y="3593592"/>
-            <a:ext cx="5486400" cy="2468880"/>
-          </a:xfrm>
-          <a:prstGeom prst="rect">
-            <a:avLst/>
-          </a:prstGeom>
-          <a:noFill/>
-        </p:spPr>
-        <p:txBody>
-          <a:bodyPr wrap="square" anchor="t">
-            <a:spAutoFit/>
-          </a:bodyPr>
-          <a:lstStyle/>
-          <a:p>
-            <a:pPr algn="l">
-              <a:spcAft>
-                <a:spcPts val="800"/>
-              </a:spcAft>
-            </a:pPr>
-            <a:r>
-              <a:rPr sz="1700" b="0">
-                <a:solidFill>
-                  <a:srgbClr val="1F2937"/>
-                </a:solidFill>
-              </a:rPr>
-              <a:t>•  Real scanned objects (SiM3D, ICCV 2025): not working yet (separation 0.54)</a:t>
-            </a:r>
-          </a:p>
-          <a:p>
-            <a:pPr algn="l">
-              <a:spcAft>
-                <a:spcPts val="800"/>
-              </a:spcAft>
-            </a:pPr>
-            <a:r>
-              <a:rPr sz="1700" b="0">
-                <a:solidFill>
-                  <a:srgbClr val="1F2937"/>
-                </a:solidFill>
-              </a:rPr>
-              <a:t>•  Why: healthy and damaged photos 4–18 px apart; textured wood</a:t>
-            </a:r>
-          </a:p>
-          <a:p>
-            <a:pPr algn="l">
-              <a:spcAft>
-                <a:spcPts val="800"/>
-              </a:spcAft>
-            </a:pPr>
-            <a:r>
-              <a:rPr sz="1700" b="0">
-                <a:solidFill>
-                  <a:srgbClr val="1F2937"/>
-                </a:solidFill>
-              </a:rPr>
-              <a:t>•  Plan: print industrial blade 5 at 2×, dent it, marker-based camera poses, scanner truth</a:t>
+              <a:t>Maps are an upper bound: optimistic for dents &lt; 0.2 mm.</a:t>
             </a:r>
           </a:p>
         </p:txBody>
       </p:sp>
       <p:pic>
         <p:nvPicPr>
-          <p:cNvPr id="15" name="Picture 14" descr="s8_photo.png"/>
+          <p:cNvPr id="5" name="Picture 4" descr="s16_map.png"/>
           <p:cNvPicPr>
             <a:picLocks noChangeAspect="1"/>
           </p:cNvPicPr>
@@ -18319,134 +18119,14 @@
         </p:blipFill>
         <p:spPr>
           <a:xfrm>
-            <a:off x="6532710" y="3511296"/>
-            <a:ext cx="1930739" cy="2633472"/>
+            <a:off x="7104888" y="1783080"/>
+            <a:ext cx="4443984" cy="4608576"/>
           </a:xfrm>
           <a:prstGeom prst="rect">
             <a:avLst/>
           </a:prstGeom>
         </p:spPr>
       </p:pic>
-      <p:sp>
-        <p:nvSpPr>
-          <p:cNvPr id="16" name="Right Arrow 15"/>
-          <p:cNvSpPr/>
-          <p:nvPr/>
-        </p:nvSpPr>
-        <p:spPr>
-          <a:xfrm>
-            <a:off x="8732520" y="4663440"/>
-            <a:ext cx="502920" cy="329184"/>
-          </a:xfrm>
-          <a:prstGeom prst="rightArrow">
-            <a:avLst/>
-          </a:prstGeom>
-          <a:solidFill>
-            <a:srgbClr val="5A6577"/>
-          </a:solidFill>
-          <a:ln>
-            <a:noFill/>
-          </a:ln>
-          <a:effectLst/>
-        </p:spPr>
-        <p:style>
-          <a:lnRef idx="1">
-            <a:schemeClr val="accent1"/>
-          </a:lnRef>
-          <a:fillRef idx="3">
-            <a:schemeClr val="accent1"/>
-          </a:fillRef>
-          <a:effectRef idx="2">
-            <a:schemeClr val="accent1"/>
-          </a:effectRef>
-          <a:fontRef idx="minor">
-            <a:schemeClr val="lt1"/>
-          </a:fontRef>
-        </p:style>
-        <p:txBody>
-          <a:bodyPr rtlCol="0" anchor="ctr"/>
-          <a:lstStyle/>
-          <a:p>
-            <a:pPr algn="ctr"/>
-          </a:p>
-        </p:txBody>
-      </p:sp>
-      <p:sp>
-        <p:nvSpPr>
-          <p:cNvPr id="17" name="Rounded Rectangle 16"/>
-          <p:cNvSpPr/>
-          <p:nvPr/>
-        </p:nvSpPr>
-        <p:spPr>
-          <a:xfrm>
-            <a:off x="9372600" y="3511296"/>
-            <a:ext cx="2377440" cy="2633472"/>
-          </a:xfrm>
-          <a:prstGeom prst="roundRect">
-            <a:avLst/>
-          </a:prstGeom>
-          <a:solidFill>
-            <a:srgbClr val="F2F5FA"/>
-          </a:solidFill>
-          <a:ln w="19050">
-            <a:solidFill>
-              <a:srgbClr val="5A6577"/>
-            </a:solidFill>
-          </a:ln>
-          <a:effectLst/>
-        </p:spPr>
-        <p:style>
-          <a:lnRef idx="1">
-            <a:schemeClr val="accent1"/>
-          </a:lnRef>
-          <a:fillRef idx="3">
-            <a:schemeClr val="accent1"/>
-          </a:fillRef>
-          <a:effectRef idx="2">
-            <a:schemeClr val="accent1"/>
-          </a:effectRef>
-          <a:fontRef idx="minor">
-            <a:schemeClr val="lt1"/>
-          </a:fontRef>
-        </p:style>
-        <p:txBody>
-          <a:bodyPr rtlCol="0" anchor="ctr" wrap="square"/>
-          <a:lstStyle/>
-          <a:p>
-            <a:pPr algn="ctr"/>
-            <a:r>
-              <a:rPr sz="2000" b="1">
-                <a:solidFill>
-                  <a:srgbClr val="5A6577"/>
-                </a:solidFill>
-              </a:rPr>
-              <a:t>?</a:t>
-            </a:r>
-          </a:p>
-          <a:p>
-            <a:pPr algn="ctr"/>
-            <a:r>
-              <a:rPr sz="1800" b="0">
-                <a:solidFill>
-                  <a:srgbClr val="5A6577"/>
-                </a:solidFill>
-              </a:rPr>
-              <a:t>real printed</a:t>
-            </a:r>
-          </a:p>
-          <a:p>
-            <a:pPr algn="ctr"/>
-            <a:r>
-              <a:rPr sz="1800" b="0">
-                <a:solidFill>
-                  <a:srgbClr val="5A6577"/>
-                </a:solidFill>
-              </a:rPr>
-              <a:t>blade</a:t>
-            </a:r>
-          </a:p>
-        </p:txBody>
-      </p:sp>
     </p:spTree>
   </p:cSld>
   <p:clrMapOvr>
@@ -18482,21 +18162,619 @@
           <a:p>
             <a:r>
               <a:rPr sz="3000"/>
-              <a:t>What's Still Missing</a:t>
-            </a:r>
-          </a:p>
-        </p:txBody>
-      </p:sp>
-      <p:sp>
-        <p:nvSpPr>
-          <p:cNvPr id="3" name="TextBox 2"/>
+              <a:t>From Synthetic to Real Data</a:t>
+            </a:r>
+          </a:p>
+        </p:txBody>
+      </p:sp>
+      <p:sp>
+        <p:nvSpPr>
+          <p:cNvPr id="3" name="Rounded Rectangle 2"/>
+          <p:cNvSpPr/>
+          <p:nvPr/>
+        </p:nvSpPr>
+        <p:spPr>
+          <a:xfrm>
+            <a:off x="365760" y="1947672"/>
+            <a:ext cx="1691640" cy="1316736"/>
+          </a:xfrm>
+          <a:prstGeom prst="roundRect">
+            <a:avLst/>
+          </a:prstGeom>
+          <a:solidFill>
+            <a:srgbClr val="5A6577"/>
+          </a:solidFill>
+          <a:ln>
+            <a:noFill/>
+          </a:ln>
+          <a:effectLst/>
+        </p:spPr>
+        <p:style>
+          <a:lnRef idx="1">
+            <a:schemeClr val="accent1"/>
+          </a:lnRef>
+          <a:fillRef idx="3">
+            <a:schemeClr val="accent1"/>
+          </a:fillRef>
+          <a:effectRef idx="2">
+            <a:schemeClr val="accent1"/>
+          </a:effectRef>
+          <a:fontRef idx="minor">
+            <a:schemeClr val="lt1"/>
+          </a:fontRef>
+        </p:style>
+        <p:txBody>
+          <a:bodyPr rtlCol="0" anchor="ctr" wrap="square"/>
+          <a:lstStyle/>
+          <a:p>
+            <a:pPr algn="ctr"/>
+            <a:r>
+              <a:rPr sz="1500" b="1">
+                <a:solidFill>
+                  <a:srgbClr val="FFFFFF"/>
+                </a:solidFill>
+              </a:rPr>
+              <a:t>Synthetic</a:t>
+            </a:r>
+          </a:p>
+          <a:p>
+            <a:pPr algn="ctr"/>
+            <a:r>
+              <a:rPr sz="1300" b="0">
+                <a:solidFill>
+                  <a:srgbClr val="FFFFFF"/>
+                </a:solidFill>
+              </a:rPr>
+              <a:t>rendered blades, exact truth</a:t>
+            </a:r>
+          </a:p>
+        </p:txBody>
+      </p:sp>
+      <p:sp>
+        <p:nvSpPr>
+          <p:cNvPr id="4" name="Right Arrow 3"/>
+          <p:cNvSpPr/>
+          <p:nvPr/>
+        </p:nvSpPr>
+        <p:spPr>
+          <a:xfrm>
+            <a:off x="2075688" y="2441448"/>
+            <a:ext cx="201168" cy="263347"/>
+          </a:xfrm>
+          <a:prstGeom prst="rightArrow">
+            <a:avLst/>
+          </a:prstGeom>
+          <a:solidFill>
+            <a:srgbClr val="5A6577"/>
+          </a:solidFill>
+          <a:ln>
+            <a:noFill/>
+          </a:ln>
+          <a:effectLst/>
+        </p:spPr>
+        <p:style>
+          <a:lnRef idx="1">
+            <a:schemeClr val="accent1"/>
+          </a:lnRef>
+          <a:fillRef idx="3">
+            <a:schemeClr val="accent1"/>
+          </a:fillRef>
+          <a:effectRef idx="2">
+            <a:schemeClr val="accent1"/>
+          </a:effectRef>
+          <a:fontRef idx="minor">
+            <a:schemeClr val="lt1"/>
+          </a:fontRef>
+        </p:style>
+        <p:txBody>
+          <a:bodyPr rtlCol="0" anchor="ctr"/>
+          <a:lstStyle/>
+          <a:p>
+            <a:pPr algn="ctr"/>
+          </a:p>
+        </p:txBody>
+      </p:sp>
+      <p:sp>
+        <p:nvSpPr>
+          <p:cNvPr id="5" name="Rounded Rectangle 4"/>
+          <p:cNvSpPr/>
+          <p:nvPr/>
+        </p:nvSpPr>
+        <p:spPr>
+          <a:xfrm>
+            <a:off x="2286000" y="1947672"/>
+            <a:ext cx="1691640" cy="1316736"/>
+          </a:xfrm>
+          <a:prstGeom prst="roundRect">
+            <a:avLst/>
+          </a:prstGeom>
+          <a:solidFill>
+            <a:srgbClr val="0047BB"/>
+          </a:solidFill>
+          <a:ln>
+            <a:noFill/>
+          </a:ln>
+          <a:effectLst/>
+        </p:spPr>
+        <p:style>
+          <a:lnRef idx="1">
+            <a:schemeClr val="accent1"/>
+          </a:lnRef>
+          <a:fillRef idx="3">
+            <a:schemeClr val="accent1"/>
+          </a:fillRef>
+          <a:effectRef idx="2">
+            <a:schemeClr val="accent1"/>
+          </a:effectRef>
+          <a:fontRef idx="minor">
+            <a:schemeClr val="lt1"/>
+          </a:fontRef>
+        </p:style>
+        <p:txBody>
+          <a:bodyPr rtlCol="0" anchor="ctr" wrap="square"/>
+          <a:lstStyle/>
+          <a:p>
+            <a:pPr algn="ctr"/>
+            <a:r>
+              <a:rPr sz="1500" b="1">
+                <a:solidFill>
+                  <a:srgbClr val="FFFFFF"/>
+                </a:solidFill>
+              </a:rPr>
+              <a:t>Compare to healthy</a:t>
+            </a:r>
+          </a:p>
+          <a:p>
+            <a:pPr algn="ctr"/>
+            <a:r>
+              <a:rPr sz="1300" b="0">
+                <a:solidFill>
+                  <a:srgbClr val="FFFFFF"/>
+                </a:solidFill>
+              </a:rPr>
+              <a:t>appearance errors cancel</a:t>
+            </a:r>
+          </a:p>
+        </p:txBody>
+      </p:sp>
+      <p:sp>
+        <p:nvSpPr>
+          <p:cNvPr id="6" name="Right Arrow 5"/>
+          <p:cNvSpPr/>
+          <p:nvPr/>
+        </p:nvSpPr>
+        <p:spPr>
+          <a:xfrm>
+            <a:off x="3995928" y="2441448"/>
+            <a:ext cx="201168" cy="263347"/>
+          </a:xfrm>
+          <a:prstGeom prst="rightArrow">
+            <a:avLst/>
+          </a:prstGeom>
+          <a:solidFill>
+            <a:srgbClr val="5A6577"/>
+          </a:solidFill>
+          <a:ln>
+            <a:noFill/>
+          </a:ln>
+          <a:effectLst/>
+        </p:spPr>
+        <p:style>
+          <a:lnRef idx="1">
+            <a:schemeClr val="accent1"/>
+          </a:lnRef>
+          <a:fillRef idx="3">
+            <a:schemeClr val="accent1"/>
+          </a:fillRef>
+          <a:effectRef idx="2">
+            <a:schemeClr val="accent1"/>
+          </a:effectRef>
+          <a:fontRef idx="minor">
+            <a:schemeClr val="lt1"/>
+          </a:fontRef>
+        </p:style>
+        <p:txBody>
+          <a:bodyPr rtlCol="0" anchor="ctr"/>
+          <a:lstStyle/>
+          <a:p>
+            <a:pPr algn="ctr"/>
+          </a:p>
+        </p:txBody>
+      </p:sp>
+      <p:sp>
+        <p:nvSpPr>
+          <p:cNvPr id="7" name="Rounded Rectangle 6"/>
+          <p:cNvSpPr/>
+          <p:nvPr/>
+        </p:nvSpPr>
+        <p:spPr>
+          <a:xfrm>
+            <a:off x="4206240" y="1947672"/>
+            <a:ext cx="1691640" cy="1316736"/>
+          </a:xfrm>
+          <a:prstGeom prst="roundRect">
+            <a:avLst/>
+          </a:prstGeom>
+          <a:solidFill>
+            <a:srgbClr val="0047BB"/>
+          </a:solidFill>
+          <a:ln>
+            <a:noFill/>
+          </a:ln>
+          <a:effectLst/>
+        </p:spPr>
+        <p:style>
+          <a:lnRef idx="1">
+            <a:schemeClr val="accent1"/>
+          </a:lnRef>
+          <a:fillRef idx="3">
+            <a:schemeClr val="accent1"/>
+          </a:fillRef>
+          <a:effectRef idx="2">
+            <a:schemeClr val="accent1"/>
+          </a:effectRef>
+          <a:fontRef idx="minor">
+            <a:schemeClr val="lt1"/>
+          </a:fontRef>
+        </p:style>
+        <p:txBody>
+          <a:bodyPr rtlCol="0" anchor="ctr" wrap="square"/>
+          <a:lstStyle/>
+          <a:p>
+            <a:pPr algn="ctr"/>
+            <a:r>
+              <a:rPr sz="1500" b="1">
+                <a:solidFill>
+                  <a:srgbClr val="FFFFFF"/>
+                </a:solidFill>
+              </a:rPr>
+              <a:t>Correction follows camera</a:t>
+            </a:r>
+          </a:p>
+          <a:p>
+            <a:pPr algn="ctr"/>
+            <a:r>
+              <a:rPr sz="1300" b="0">
+                <a:solidFill>
+                  <a:srgbClr val="FFFFFF"/>
+                </a:solidFill>
+              </a:rPr>
+              <a:t>v1.1: survives camera drift</a:t>
+            </a:r>
+          </a:p>
+        </p:txBody>
+      </p:sp>
+      <p:sp>
+        <p:nvSpPr>
+          <p:cNvPr id="8" name="Right Arrow 7"/>
+          <p:cNvSpPr/>
+          <p:nvPr/>
+        </p:nvSpPr>
+        <p:spPr>
+          <a:xfrm>
+            <a:off x="5916168" y="2441448"/>
+            <a:ext cx="201168" cy="263347"/>
+          </a:xfrm>
+          <a:prstGeom prst="rightArrow">
+            <a:avLst/>
+          </a:prstGeom>
+          <a:solidFill>
+            <a:srgbClr val="5A6577"/>
+          </a:solidFill>
+          <a:ln>
+            <a:noFill/>
+          </a:ln>
+          <a:effectLst/>
+        </p:spPr>
+        <p:style>
+          <a:lnRef idx="1">
+            <a:schemeClr val="accent1"/>
+          </a:lnRef>
+          <a:fillRef idx="3">
+            <a:schemeClr val="accent1"/>
+          </a:fillRef>
+          <a:effectRef idx="2">
+            <a:schemeClr val="accent1"/>
+          </a:effectRef>
+          <a:fontRef idx="minor">
+            <a:schemeClr val="lt1"/>
+          </a:fontRef>
+        </p:style>
+        <p:txBody>
+          <a:bodyPr rtlCol="0" anchor="ctr"/>
+          <a:lstStyle/>
+          <a:p>
+            <a:pPr algn="ctr"/>
+          </a:p>
+        </p:txBody>
+      </p:sp>
+      <p:sp>
+        <p:nvSpPr>
+          <p:cNvPr id="9" name="Rounded Rectangle 8"/>
+          <p:cNvSpPr/>
+          <p:nvPr/>
+        </p:nvSpPr>
+        <p:spPr>
+          <a:xfrm>
+            <a:off x="6126480" y="1947672"/>
+            <a:ext cx="1691640" cy="1316736"/>
+          </a:xfrm>
+          <a:prstGeom prst="roundRect">
+            <a:avLst/>
+          </a:prstGeom>
+          <a:solidFill>
+            <a:srgbClr val="0047BB"/>
+          </a:solidFill>
+          <a:ln>
+            <a:noFill/>
+          </a:ln>
+          <a:effectLst/>
+        </p:spPr>
+        <p:style>
+          <a:lnRef idx="1">
+            <a:schemeClr val="accent1"/>
+          </a:lnRef>
+          <a:fillRef idx="3">
+            <a:schemeClr val="accent1"/>
+          </a:fillRef>
+          <a:effectRef idx="2">
+            <a:schemeClr val="accent1"/>
+          </a:effectRef>
+          <a:fontRef idx="minor">
+            <a:schemeClr val="lt1"/>
+          </a:fontRef>
+        </p:style>
+        <p:txBody>
+          <a:bodyPr rtlCol="0" anchor="ctr" wrap="square"/>
+          <a:lstStyle/>
+          <a:p>
+            <a:pPr algn="ctr"/>
+            <a:r>
+              <a:rPr sz="1500" b="1">
+                <a:solidFill>
+                  <a:srgbClr val="FFFFFF"/>
+                </a:solidFill>
+              </a:rPr>
+              <a:t>Calibrate on negatives</a:t>
+            </a:r>
+          </a:p>
+          <a:p>
+            <a:pPr algn="ctr"/>
+            <a:r>
+              <a:rPr sz="1300" b="0">
+                <a:solidFill>
+                  <a:srgbClr val="FFFFFF"/>
+                </a:solidFill>
+              </a:rPr>
+              <a:t>threshold set on data</a:t>
+            </a:r>
+          </a:p>
+        </p:txBody>
+      </p:sp>
+      <p:sp>
+        <p:nvSpPr>
+          <p:cNvPr id="10" name="Right Arrow 9"/>
+          <p:cNvSpPr/>
+          <p:nvPr/>
+        </p:nvSpPr>
+        <p:spPr>
+          <a:xfrm>
+            <a:off x="7836408" y="2441448"/>
+            <a:ext cx="201168" cy="263347"/>
+          </a:xfrm>
+          <a:prstGeom prst="rightArrow">
+            <a:avLst/>
+          </a:prstGeom>
+          <a:solidFill>
+            <a:srgbClr val="5A6577"/>
+          </a:solidFill>
+          <a:ln>
+            <a:noFill/>
+          </a:ln>
+          <a:effectLst/>
+        </p:spPr>
+        <p:style>
+          <a:lnRef idx="1">
+            <a:schemeClr val="accent1"/>
+          </a:lnRef>
+          <a:fillRef idx="3">
+            <a:schemeClr val="accent1"/>
+          </a:fillRef>
+          <a:effectRef idx="2">
+            <a:schemeClr val="accent1"/>
+          </a:effectRef>
+          <a:fontRef idx="minor">
+            <a:schemeClr val="lt1"/>
+          </a:fontRef>
+        </p:style>
+        <p:txBody>
+          <a:bodyPr rtlCol="0" anchor="ctr"/>
+          <a:lstStyle/>
+          <a:p>
+            <a:pPr algn="ctr"/>
+          </a:p>
+        </p:txBody>
+      </p:sp>
+      <p:sp>
+        <p:nvSpPr>
+          <p:cNvPr id="11" name="Rounded Rectangle 10"/>
+          <p:cNvSpPr/>
+          <p:nvPr/>
+        </p:nvSpPr>
+        <p:spPr>
+          <a:xfrm>
+            <a:off x="8046720" y="1947672"/>
+            <a:ext cx="1691640" cy="1316736"/>
+          </a:xfrm>
+          <a:prstGeom prst="roundRect">
+            <a:avLst/>
+          </a:prstGeom>
+          <a:solidFill>
+            <a:srgbClr val="E8833A"/>
+          </a:solidFill>
+          <a:ln>
+            <a:noFill/>
+          </a:ln>
+          <a:effectLst/>
+        </p:spPr>
+        <p:style>
+          <a:lnRef idx="1">
+            <a:schemeClr val="accent1"/>
+          </a:lnRef>
+          <a:fillRef idx="3">
+            <a:schemeClr val="accent1"/>
+          </a:fillRef>
+          <a:effectRef idx="2">
+            <a:schemeClr val="accent1"/>
+          </a:effectRef>
+          <a:fontRef idx="minor">
+            <a:schemeClr val="lt1"/>
+          </a:fontRef>
+        </p:style>
+        <p:txBody>
+          <a:bodyPr rtlCol="0" anchor="ctr" wrap="square"/>
+          <a:lstStyle/>
+          <a:p>
+            <a:pPr algn="ctr"/>
+            <a:r>
+              <a:rPr sz="1500" b="1">
+                <a:solidFill>
+                  <a:srgbClr val="FFFFFF"/>
+                </a:solidFill>
+              </a:rPr>
+              <a:t>New designs</a:t>
+            </a:r>
+          </a:p>
+          <a:p>
+            <a:pPr algn="ctr"/>
+            <a:r>
+              <a:rPr sz="1300" b="0">
+                <a:solidFill>
+                  <a:srgbClr val="FFFFFF"/>
+                </a:solidFill>
+              </a:rPr>
+              <a:t>6 industrial blades: detection transfers</a:t>
+            </a:r>
+          </a:p>
+        </p:txBody>
+      </p:sp>
+      <p:sp>
+        <p:nvSpPr>
+          <p:cNvPr id="12" name="Right Arrow 11"/>
+          <p:cNvSpPr/>
+          <p:nvPr/>
+        </p:nvSpPr>
+        <p:spPr>
+          <a:xfrm>
+            <a:off x="9756648" y="2441448"/>
+            <a:ext cx="201168" cy="263347"/>
+          </a:xfrm>
+          <a:prstGeom prst="rightArrow">
+            <a:avLst/>
+          </a:prstGeom>
+          <a:solidFill>
+            <a:srgbClr val="5A6577"/>
+          </a:solidFill>
+          <a:ln>
+            <a:noFill/>
+          </a:ln>
+          <a:effectLst/>
+        </p:spPr>
+        <p:style>
+          <a:lnRef idx="1">
+            <a:schemeClr val="accent1"/>
+          </a:lnRef>
+          <a:fillRef idx="3">
+            <a:schemeClr val="accent1"/>
+          </a:fillRef>
+          <a:effectRef idx="2">
+            <a:schemeClr val="accent1"/>
+          </a:effectRef>
+          <a:fontRef idx="minor">
+            <a:schemeClr val="lt1"/>
+          </a:fontRef>
+        </p:style>
+        <p:txBody>
+          <a:bodyPr rtlCol="0" anchor="ctr"/>
+          <a:lstStyle/>
+          <a:p>
+            <a:pPr algn="ctr"/>
+          </a:p>
+        </p:txBody>
+      </p:sp>
+      <p:sp>
+        <p:nvSpPr>
+          <p:cNvPr id="13" name="Rounded Rectangle 12"/>
+          <p:cNvSpPr/>
+          <p:nvPr/>
+        </p:nvSpPr>
+        <p:spPr>
+          <a:xfrm>
+            <a:off x="9966960" y="1947672"/>
+            <a:ext cx="1691640" cy="1316736"/>
+          </a:xfrm>
+          <a:prstGeom prst="roundRect">
+            <a:avLst/>
+          </a:prstGeom>
+          <a:solidFill>
+            <a:srgbClr val="1A7F37"/>
+          </a:solidFill>
+          <a:ln>
+            <a:noFill/>
+          </a:ln>
+          <a:effectLst/>
+        </p:spPr>
+        <p:style>
+          <a:lnRef idx="1">
+            <a:schemeClr val="accent1"/>
+          </a:lnRef>
+          <a:fillRef idx="3">
+            <a:schemeClr val="accent1"/>
+          </a:fillRef>
+          <a:effectRef idx="2">
+            <a:schemeClr val="accent1"/>
+          </a:effectRef>
+          <a:fontRef idx="minor">
+            <a:schemeClr val="lt1"/>
+          </a:fontRef>
+        </p:style>
+        <p:txBody>
+          <a:bodyPr rtlCol="0" anchor="ctr" wrap="square"/>
+          <a:lstStyle/>
+          <a:p>
+            <a:pPr algn="ctr"/>
+            <a:r>
+              <a:rPr sz="1500" b="1">
+                <a:solidFill>
+                  <a:srgbClr val="FFFFFF"/>
+                </a:solidFill>
+              </a:rPr>
+              <a:t>Real blade</a:t>
+            </a:r>
+          </a:p>
+          <a:p>
+            <a:pPr algn="ctr"/>
+            <a:r>
+              <a:rPr sz="1300" b="0">
+                <a:solidFill>
+                  <a:srgbClr val="FFFFFF"/>
+                </a:solidFill>
+              </a:rPr>
+              <a:t>printed, dented, scanned (next)</a:t>
+            </a:r>
+          </a:p>
+        </p:txBody>
+      </p:sp>
+      <p:sp>
+        <p:nvSpPr>
+          <p:cNvPr id="14" name="TextBox 13"/>
           <p:cNvSpPr txBox="1"/>
           <p:nvPr/>
         </p:nvSpPr>
         <p:spPr>
           <a:xfrm>
-            <a:off x="548640" y="1947672"/>
-            <a:ext cx="5486400" cy="2962656"/>
+            <a:off x="548640" y="3593592"/>
+            <a:ext cx="5486400" cy="2468880"/>
           </a:xfrm>
           <a:prstGeom prst="rect">
             <a:avLst/>
@@ -18515,12 +18793,12 @@
               </a:spcAft>
             </a:pPr>
             <a:r>
-              <a:rPr sz="2100" b="0">
+              <a:rPr sz="1700" b="0">
                 <a:solidFill>
                   <a:srgbClr val="1F2937"/>
                 </a:solidFill>
               </a:rPr>
-              <a:t>•  All results so far are on rendered blades</a:t>
+              <a:t>•  Real scanned objects (SiM3D, ICCV 2025): not working yet (separation 0.54)</a:t>
             </a:r>
           </a:p>
           <a:p>
@@ -18530,12 +18808,12 @@
               </a:spcAft>
             </a:pPr>
             <a:r>
-              <a:rPr sz="2100" b="0">
+              <a:rPr sz="1700" b="0">
                 <a:solidFill>
                   <a:srgbClr val="1F2937"/>
                 </a:solidFill>
               </a:rPr>
-              <a:t>•  One real dataset (scanned furniture) did not work yet</a:t>
+              <a:t>•  Why: healthy and damaged photos 4–18 px apart; textured wood</a:t>
             </a:r>
           </a:p>
           <a:p>
@@ -18545,19 +18823,19 @@
               </a:spcAft>
             </a:pPr>
             <a:r>
-              <a:rPr sz="2100" b="0">
+              <a:rPr sz="1700" b="0">
                 <a:solidFill>
                   <a:srgbClr val="1F2937"/>
                 </a:solidFill>
               </a:rPr>
-              <a:t>•  Next: 3D-print a real blade, dent it, photograph it and scan it</a:t>
+              <a:t>•  Plan: print industrial blade 5 at 2×, dent it, marker-based camera poses, scanner truth</a:t>
             </a:r>
           </a:p>
         </p:txBody>
       </p:sp>
       <p:pic>
         <p:nvPicPr>
-          <p:cNvPr id="4" name="Picture 3" descr="s8_photo.png"/>
+          <p:cNvPr id="15" name="Picture 14" descr="s8_photo.png"/>
           <p:cNvPicPr>
             <a:picLocks noChangeAspect="1"/>
           </p:cNvPicPr>
@@ -18571,8 +18849,8 @@
         </p:blipFill>
         <p:spPr>
           <a:xfrm>
-            <a:off x="6412038" y="1947672"/>
-            <a:ext cx="2172082" cy="2962656"/>
+            <a:off x="6532710" y="3511296"/>
+            <a:ext cx="1930739" cy="2633472"/>
           </a:xfrm>
           <a:prstGeom prst="rect">
             <a:avLst/>
@@ -18581,14 +18859,14 @@
       </p:pic>
       <p:sp>
         <p:nvSpPr>
-          <p:cNvPr id="5" name="Right Arrow 4"/>
+          <p:cNvPr id="16" name="Right Arrow 15"/>
           <p:cNvSpPr/>
           <p:nvPr/>
         </p:nvSpPr>
         <p:spPr>
           <a:xfrm>
-            <a:off x="8823960" y="3264408"/>
-            <a:ext cx="548640" cy="329184"/>
+            <a:off x="8732520" y="4663440"/>
+            <a:ext cx="502920" cy="329184"/>
           </a:xfrm>
           <a:prstGeom prst="rightArrow">
             <a:avLst/>
@@ -18625,14 +18903,14 @@
       </p:sp>
       <p:sp>
         <p:nvSpPr>
-          <p:cNvPr id="6" name="Rounded Rectangle 5"/>
+          <p:cNvPr id="17" name="Rounded Rectangle 16"/>
           <p:cNvSpPr/>
           <p:nvPr/>
         </p:nvSpPr>
         <p:spPr>
           <a:xfrm>
-            <a:off x="9509760" y="1947672"/>
-            <a:ext cx="2286000" cy="2962656"/>
+            <a:off x="9372600" y="3511296"/>
+            <a:ext cx="2377440" cy="2633472"/>
           </a:xfrm>
           <a:prstGeom prst="roundRect">
             <a:avLst/>
@@ -18667,7 +18945,7 @@
           <a:p>
             <a:pPr algn="ctr"/>
             <a:r>
-              <a:rPr sz="2200" b="1">
+              <a:rPr sz="2000" b="1">
                 <a:solidFill>
                   <a:srgbClr val="5A6577"/>
                 </a:solidFill>
@@ -18678,7 +18956,7 @@
           <a:p>
             <a:pPr algn="ctr"/>
             <a:r>
-              <a:rPr sz="2000" b="0">
+              <a:rPr sz="1800" b="0">
                 <a:solidFill>
                   <a:srgbClr val="5A6577"/>
                 </a:solidFill>
@@ -18689,50 +18967,12 @@
           <a:p>
             <a:pPr algn="ctr"/>
             <a:r>
-              <a:rPr sz="2000" b="0">
+              <a:rPr sz="1800" b="0">
                 <a:solidFill>
                   <a:srgbClr val="5A6577"/>
                 </a:solidFill>
               </a:rPr>
               <a:t>blade</a:t>
-            </a:r>
-          </a:p>
-        </p:txBody>
-      </p:sp>
-      <p:sp>
-        <p:nvSpPr>
-          <p:cNvPr id="7" name="TextBox 6"/>
-          <p:cNvSpPr txBox="1"/>
-          <p:nvPr/>
-        </p:nvSpPr>
-        <p:spPr>
-          <a:xfrm>
-            <a:off x="6309360" y="5074920"/>
-            <a:ext cx="5486400" cy="493776"/>
-          </a:xfrm>
-          <a:prstGeom prst="rect">
-            <a:avLst/>
-          </a:prstGeom>
-          <a:noFill/>
-        </p:spPr>
-        <p:txBody>
-          <a:bodyPr wrap="square" anchor="t">
-            <a:spAutoFit/>
-          </a:bodyPr>
-          <a:lstStyle/>
-          <a:p>
-            <a:pPr algn="ctr">
-              <a:spcAft>
-                <a:spcPts val="200"/>
-              </a:spcAft>
-            </a:pPr>
-            <a:r>
-              <a:rPr sz="2200" b="1">
-                <a:solidFill>
-                  <a:srgbClr val="0047BB"/>
-                </a:solidFill>
-              </a:rPr>
-              <a:t>Next step: real validation</a:t>
             </a:r>
           </a:p>
         </p:txBody>
@@ -18772,7 +19012,7 @@
           <a:p>
             <a:r>
               <a:rPr sz="3000"/>
-              <a:t>Summary</a:t>
+              <a:t>What's Still Missing</a:t>
             </a:r>
           </a:p>
         </p:txBody>
@@ -18785,8 +19025,8 @@
         </p:nvSpPr>
         <p:spPr>
           <a:xfrm>
-            <a:off x="548640" y="1865376"/>
-            <a:ext cx="5852160" cy="3950208"/>
+            <a:off x="548640" y="1947672"/>
+            <a:ext cx="5486400" cy="2962656"/>
           </a:xfrm>
           <a:prstGeom prst="rect">
             <a:avLst/>
@@ -18810,7 +19050,7 @@
                   <a:srgbClr val="1F2937"/>
                 </a:solidFill>
               </a:rPr>
-              <a:t>•  We built a method that finds 3D damage on blades from a few photos</a:t>
+              <a:t>•  All results so far are on rendered blades</a:t>
             </a:r>
           </a:p>
           <a:p>
@@ -18825,7 +19065,7 @@
                   <a:srgbClr val="1F2937"/>
                 </a:solidFill>
               </a:rPr>
-              <a:t>•  It knows when to say "not enough evidence"</a:t>
+              <a:t>•  One real dataset (scanned furniture) did not work yet</a:t>
             </a:r>
           </a:p>
           <a:p>
@@ -18840,44 +19080,14 @@
                   <a:srgbClr val="1F2937"/>
                 </a:solidFill>
               </a:rPr>
-              <a:t>•  It controls false alarms and predicts which dents it can see</a:t>
-            </a:r>
-          </a:p>
-          <a:p>
-            <a:pPr algn="l">
-              <a:spcAft>
-                <a:spcPts val="800"/>
-              </a:spcAft>
-            </a:pPr>
-            <a:r>
-              <a:rPr sz="2100" b="0">
-                <a:solidFill>
-                  <a:srgbClr val="1F2937"/>
-                </a:solidFill>
-              </a:rPr>
-              <a:t>•  Finds damage on new blade designs (after a fix); depth there still ~40% low</a:t>
-            </a:r>
-          </a:p>
-          <a:p>
-            <a:pPr algn="l">
-              <a:spcAft>
-                <a:spcPts val="800"/>
-              </a:spcAft>
-            </a:pPr>
-            <a:r>
-              <a:rPr sz="2100" b="0">
-                <a:solidFill>
-                  <a:srgbClr val="1F2937"/>
-                </a:solidFill>
-              </a:rPr>
-              <a:t>•  Real validation is next</a:t>
+              <a:t>•  Next: 3D-print a real blade, dent it, photograph it and scan it</a:t>
             </a:r>
           </a:p>
         </p:txBody>
       </p:sp>
       <p:pic>
         <p:nvPicPr>
-          <p:cNvPr id="4" name="Picture 3" descr="method_overview.png"/>
+          <p:cNvPr id="4" name="Picture 3" descr="s8_photo.png"/>
           <p:cNvPicPr>
             <a:picLocks noChangeAspect="1"/>
           </p:cNvPicPr>
@@ -18891,14 +19101,172 @@
         </p:blipFill>
         <p:spPr>
           <a:xfrm>
-            <a:off x="6583680" y="2640003"/>
-            <a:ext cx="5303520" cy="1742585"/>
+            <a:off x="6412038" y="1947672"/>
+            <a:ext cx="2172082" cy="2962656"/>
           </a:xfrm>
           <a:prstGeom prst="rect">
             <a:avLst/>
           </a:prstGeom>
         </p:spPr>
       </p:pic>
+      <p:sp>
+        <p:nvSpPr>
+          <p:cNvPr id="5" name="Right Arrow 4"/>
+          <p:cNvSpPr/>
+          <p:nvPr/>
+        </p:nvSpPr>
+        <p:spPr>
+          <a:xfrm>
+            <a:off x="8823960" y="3264408"/>
+            <a:ext cx="548640" cy="329184"/>
+          </a:xfrm>
+          <a:prstGeom prst="rightArrow">
+            <a:avLst/>
+          </a:prstGeom>
+          <a:solidFill>
+            <a:srgbClr val="5A6577"/>
+          </a:solidFill>
+          <a:ln>
+            <a:noFill/>
+          </a:ln>
+          <a:effectLst/>
+        </p:spPr>
+        <p:style>
+          <a:lnRef idx="1">
+            <a:schemeClr val="accent1"/>
+          </a:lnRef>
+          <a:fillRef idx="3">
+            <a:schemeClr val="accent1"/>
+          </a:fillRef>
+          <a:effectRef idx="2">
+            <a:schemeClr val="accent1"/>
+          </a:effectRef>
+          <a:fontRef idx="minor">
+            <a:schemeClr val="lt1"/>
+          </a:fontRef>
+        </p:style>
+        <p:txBody>
+          <a:bodyPr rtlCol="0" anchor="ctr"/>
+          <a:lstStyle/>
+          <a:p>
+            <a:pPr algn="ctr"/>
+          </a:p>
+        </p:txBody>
+      </p:sp>
+      <p:sp>
+        <p:nvSpPr>
+          <p:cNvPr id="6" name="Rounded Rectangle 5"/>
+          <p:cNvSpPr/>
+          <p:nvPr/>
+        </p:nvSpPr>
+        <p:spPr>
+          <a:xfrm>
+            <a:off x="9509760" y="1947672"/>
+            <a:ext cx="2286000" cy="2962656"/>
+          </a:xfrm>
+          <a:prstGeom prst="roundRect">
+            <a:avLst/>
+          </a:prstGeom>
+          <a:solidFill>
+            <a:srgbClr val="F2F5FA"/>
+          </a:solidFill>
+          <a:ln w="19050">
+            <a:solidFill>
+              <a:srgbClr val="5A6577"/>
+            </a:solidFill>
+          </a:ln>
+          <a:effectLst/>
+        </p:spPr>
+        <p:style>
+          <a:lnRef idx="1">
+            <a:schemeClr val="accent1"/>
+          </a:lnRef>
+          <a:fillRef idx="3">
+            <a:schemeClr val="accent1"/>
+          </a:fillRef>
+          <a:effectRef idx="2">
+            <a:schemeClr val="accent1"/>
+          </a:effectRef>
+          <a:fontRef idx="minor">
+            <a:schemeClr val="lt1"/>
+          </a:fontRef>
+        </p:style>
+        <p:txBody>
+          <a:bodyPr rtlCol="0" anchor="ctr" wrap="square"/>
+          <a:lstStyle/>
+          <a:p>
+            <a:pPr algn="ctr"/>
+            <a:r>
+              <a:rPr sz="2200" b="1">
+                <a:solidFill>
+                  <a:srgbClr val="5A6577"/>
+                </a:solidFill>
+              </a:rPr>
+              <a:t>?</a:t>
+            </a:r>
+          </a:p>
+          <a:p>
+            <a:pPr algn="ctr"/>
+            <a:r>
+              <a:rPr sz="2000" b="0">
+                <a:solidFill>
+                  <a:srgbClr val="5A6577"/>
+                </a:solidFill>
+              </a:rPr>
+              <a:t>real printed</a:t>
+            </a:r>
+          </a:p>
+          <a:p>
+            <a:pPr algn="ctr"/>
+            <a:r>
+              <a:rPr sz="2000" b="0">
+                <a:solidFill>
+                  <a:srgbClr val="5A6577"/>
+                </a:solidFill>
+              </a:rPr>
+              <a:t>blade</a:t>
+            </a:r>
+          </a:p>
+        </p:txBody>
+      </p:sp>
+      <p:sp>
+        <p:nvSpPr>
+          <p:cNvPr id="7" name="TextBox 6"/>
+          <p:cNvSpPr txBox="1"/>
+          <p:nvPr/>
+        </p:nvSpPr>
+        <p:spPr>
+          <a:xfrm>
+            <a:off x="6309360" y="5074920"/>
+            <a:ext cx="5486400" cy="493776"/>
+          </a:xfrm>
+          <a:prstGeom prst="rect">
+            <a:avLst/>
+          </a:prstGeom>
+          <a:noFill/>
+        </p:spPr>
+        <p:txBody>
+          <a:bodyPr wrap="square" anchor="t">
+            <a:spAutoFit/>
+          </a:bodyPr>
+          <a:lstStyle/>
+          <a:p>
+            <a:pPr algn="ctr">
+              <a:spcAft>
+                <a:spcPts val="200"/>
+              </a:spcAft>
+            </a:pPr>
+            <a:r>
+              <a:rPr sz="2200" b="1">
+                <a:solidFill>
+                  <a:srgbClr val="0047BB"/>
+                </a:solidFill>
+              </a:rPr>
+              <a:t>Next step: real validation</a:t>
+            </a:r>
+          </a:p>
+        </p:txBody>
+      </p:sp>
     </p:spTree>
   </p:cSld>
   <p:clrMapOvr>
@@ -18933,6 +19301,168 @@
           <a:lstStyle/>
           <a:p>
             <a:r>
+              <a:rPr sz="3000"/>
+              <a:t>Summary</a:t>
+            </a:r>
+          </a:p>
+        </p:txBody>
+      </p:sp>
+      <p:sp>
+        <p:nvSpPr>
+          <p:cNvPr id="3" name="TextBox 2"/>
+          <p:cNvSpPr txBox="1"/>
+          <p:nvPr/>
+        </p:nvSpPr>
+        <p:spPr>
+          <a:xfrm>
+            <a:off x="548640" y="1865376"/>
+            <a:ext cx="5852160" cy="3950208"/>
+          </a:xfrm>
+          <a:prstGeom prst="rect">
+            <a:avLst/>
+          </a:prstGeom>
+          <a:noFill/>
+        </p:spPr>
+        <p:txBody>
+          <a:bodyPr wrap="square" anchor="t">
+            <a:spAutoFit/>
+          </a:bodyPr>
+          <a:lstStyle/>
+          <a:p>
+            <a:pPr algn="l">
+              <a:spcAft>
+                <a:spcPts val="800"/>
+              </a:spcAft>
+            </a:pPr>
+            <a:r>
+              <a:rPr sz="2100" b="0">
+                <a:solidFill>
+                  <a:srgbClr val="1F2937"/>
+                </a:solidFill>
+              </a:rPr>
+              <a:t>•  We built a method that finds 3D damage on blades from a few photos</a:t>
+            </a:r>
+          </a:p>
+          <a:p>
+            <a:pPr algn="l">
+              <a:spcAft>
+                <a:spcPts val="800"/>
+              </a:spcAft>
+            </a:pPr>
+            <a:r>
+              <a:rPr sz="2100" b="0">
+                <a:solidFill>
+                  <a:srgbClr val="1F2937"/>
+                </a:solidFill>
+              </a:rPr>
+              <a:t>•  It knows when to say "not enough evidence"</a:t>
+            </a:r>
+          </a:p>
+          <a:p>
+            <a:pPr algn="l">
+              <a:spcAft>
+                <a:spcPts val="800"/>
+              </a:spcAft>
+            </a:pPr>
+            <a:r>
+              <a:rPr sz="2100" b="0">
+                <a:solidFill>
+                  <a:srgbClr val="1F2937"/>
+                </a:solidFill>
+              </a:rPr>
+              <a:t>•  It controls false alarms and predicts which dents it can see</a:t>
+            </a:r>
+          </a:p>
+          <a:p>
+            <a:pPr algn="l">
+              <a:spcAft>
+                <a:spcPts val="800"/>
+              </a:spcAft>
+            </a:pPr>
+            <a:r>
+              <a:rPr sz="2100" b="0">
+                <a:solidFill>
+                  <a:srgbClr val="1F2937"/>
+                </a:solidFill>
+              </a:rPr>
+              <a:t>•  Finds damage on new blade designs (after a fix); depth there still ~40% low</a:t>
+            </a:r>
+          </a:p>
+          <a:p>
+            <a:pPr algn="l">
+              <a:spcAft>
+                <a:spcPts val="800"/>
+              </a:spcAft>
+            </a:pPr>
+            <a:r>
+              <a:rPr sz="2100" b="0">
+                <a:solidFill>
+                  <a:srgbClr val="1F2937"/>
+                </a:solidFill>
+              </a:rPr>
+              <a:t>•  Real validation is next</a:t>
+            </a:r>
+          </a:p>
+        </p:txBody>
+      </p:sp>
+      <p:pic>
+        <p:nvPicPr>
+          <p:cNvPr id="4" name="Picture 3" descr="method_overview.png"/>
+          <p:cNvPicPr>
+            <a:picLocks noChangeAspect="1"/>
+          </p:cNvPicPr>
+          <p:nvPr/>
+        </p:nvPicPr>
+        <p:blipFill>
+          <a:blip r:embed="rId2"/>
+          <a:stretch>
+            <a:fillRect/>
+          </a:stretch>
+        </p:blipFill>
+        <p:spPr>
+          <a:xfrm>
+            <a:off x="6583680" y="2640003"/>
+            <a:ext cx="5303520" cy="1742585"/>
+          </a:xfrm>
+          <a:prstGeom prst="rect">
+            <a:avLst/>
+          </a:prstGeom>
+        </p:spPr>
+      </p:pic>
+    </p:spTree>
+  </p:cSld>
+  <p:clrMapOvr>
+    <a:masterClrMapping/>
+  </p:clrMapOvr>
+</p:sld>
+</file>
+
+<file path=ppt/slides/slide28.xml><?xml version="1.0" encoding="utf-8"?>
+<p:sld xmlns:a="http://schemas.openxmlformats.org/drawingml/2006/main" xmlns:p="http://schemas.openxmlformats.org/presentationml/2006/main" xmlns:r="http://schemas.openxmlformats.org/officeDocument/2006/relationships">
+  <p:cSld>
+    <p:spTree>
+      <p:nvGrpSpPr>
+        <p:cNvPr id="1" name=""/>
+        <p:cNvGrpSpPr/>
+        <p:nvPr/>
+      </p:nvGrpSpPr>
+      <p:grpSpPr/>
+      <p:sp>
+        <p:nvSpPr>
+          <p:cNvPr id="2" name="Title 1"/>
+          <p:cNvSpPr>
+            <a:spLocks noGrp="1"/>
+          </p:cNvSpPr>
+          <p:nvPr>
+            <p:ph type="title"/>
+          </p:nvPr>
+        </p:nvSpPr>
+        <p:spPr/>
+        <p:txBody>
+          <a:bodyPr/>
+          <a:lstStyle/>
+          <a:p>
+            <a:r>
               <a:rPr sz="2400"/>
               <a:t>3D Demo: Actual Damage vs Model Prediction</a:t>
             </a:r>
@@ -19092,7 +19622,7 @@
 </p:sld>
 </file>
 
-<file path=ppt/slides/slide28.xml><?xml version="1.0" encoding="utf-8"?>
+<file path=ppt/slides/slide29.xml><?xml version="1.0" encoding="utf-8"?>
 <p:sld xmlns:a="http://schemas.openxmlformats.org/drawingml/2006/main" xmlns:p="http://schemas.openxmlformats.org/presentationml/2006/main" xmlns:r="http://schemas.openxmlformats.org/officeDocument/2006/relationships">
   <p:cSld>
     <p:spTree>

</xml_diff>